<commit_message>
Agregar Emilio de Gomez y auditar requisitos
</commit_message>
<xml_diff>
--- a/presentacion/PresentacionFinal_Grupo_RedesNeuronalesGrafos.pptx
+++ b/presentacion/PresentacionFinal_Grupo_RedesNeuronalesGrafos.pptx
@@ -2,27 +2,27 @@
 <file path=ppt/presentation.xml><?xml version="1.0" encoding="utf-8"?>
 <p:presentation xmlns:p="http://schemas.openxmlformats.org/presentationml/2006/main">
   <p:sldMasterIdLst>
-    <p:sldMasterId xmlns:r="http://schemas.openxmlformats.org/officeDocument/2006/relationships" id="2147483648" r:id="R683ec9b6da9b42f2"/>
+    <p:sldMasterId xmlns:r="http://schemas.openxmlformats.org/officeDocument/2006/relationships" id="2147483648" r:id="Ra1c8de7e41ec4033"/>
   </p:sldMasterIdLst>
   <p:notesMasterIdLst>
-    <p:notesMasterId xmlns:r="http://schemas.openxmlformats.org/officeDocument/2006/relationships" r:id="R8b99273eba07432f"/>
+    <p:notesMasterId xmlns:r="http://schemas.openxmlformats.org/officeDocument/2006/relationships" r:id="Rb4c81f9e865941c5"/>
   </p:notesMasterIdLst>
   <p:sldIdLst>
-    <p:sldId xmlns:r="http://schemas.openxmlformats.org/officeDocument/2006/relationships" id="256" r:id="Ra031e7f57c79468d"/>
-    <p:sldId xmlns:r="http://schemas.openxmlformats.org/officeDocument/2006/relationships" id="257" r:id="R6a01b4e8cb7349b0"/>
-    <p:sldId xmlns:r="http://schemas.openxmlformats.org/officeDocument/2006/relationships" id="258" r:id="R428e1498044b4ef1"/>
-    <p:sldId xmlns:r="http://schemas.openxmlformats.org/officeDocument/2006/relationships" id="259" r:id="R2554ce5d39564eae"/>
-    <p:sldId xmlns:r="http://schemas.openxmlformats.org/officeDocument/2006/relationships" id="260" r:id="R6b782f57554244e6"/>
-    <p:sldId xmlns:r="http://schemas.openxmlformats.org/officeDocument/2006/relationships" id="261" r:id="R18d759c30f764bcf"/>
-    <p:sldId xmlns:r="http://schemas.openxmlformats.org/officeDocument/2006/relationships" id="262" r:id="Reea22092d0d946ec"/>
-    <p:sldId xmlns:r="http://schemas.openxmlformats.org/officeDocument/2006/relationships" id="263" r:id="R4764dea1bdad4e02"/>
-    <p:sldId xmlns:r="http://schemas.openxmlformats.org/officeDocument/2006/relationships" id="264" r:id="Rb142f34549ef4aa6"/>
-    <p:sldId xmlns:r="http://schemas.openxmlformats.org/officeDocument/2006/relationships" id="265" r:id="Rd1617c1e96ea413d"/>
-    <p:sldId xmlns:r="http://schemas.openxmlformats.org/officeDocument/2006/relationships" id="266" r:id="R126cf93b78384f7a"/>
-    <p:sldId xmlns:r="http://schemas.openxmlformats.org/officeDocument/2006/relationships" id="267" r:id="R29f87048a21f4604"/>
-    <p:sldId xmlns:r="http://schemas.openxmlformats.org/officeDocument/2006/relationships" id="268" r:id="R13b54e02035d498e"/>
-    <p:sldId xmlns:r="http://schemas.openxmlformats.org/officeDocument/2006/relationships" id="269" r:id="R8a948ba9cd764ab9"/>
-    <p:sldId xmlns:r="http://schemas.openxmlformats.org/officeDocument/2006/relationships" id="270" r:id="R7bd4a3b5903343f4"/>
+    <p:sldId xmlns:r="http://schemas.openxmlformats.org/officeDocument/2006/relationships" id="256" r:id="R80d4fefb2ad84c9c"/>
+    <p:sldId xmlns:r="http://schemas.openxmlformats.org/officeDocument/2006/relationships" id="257" r:id="R3508daa134a546d1"/>
+    <p:sldId xmlns:r="http://schemas.openxmlformats.org/officeDocument/2006/relationships" id="258" r:id="Rb1145e02880d45dc"/>
+    <p:sldId xmlns:r="http://schemas.openxmlformats.org/officeDocument/2006/relationships" id="259" r:id="Rd0f0232a0678499d"/>
+    <p:sldId xmlns:r="http://schemas.openxmlformats.org/officeDocument/2006/relationships" id="260" r:id="R954104fb7fce4909"/>
+    <p:sldId xmlns:r="http://schemas.openxmlformats.org/officeDocument/2006/relationships" id="261" r:id="Ra29e51cf3ad7448e"/>
+    <p:sldId xmlns:r="http://schemas.openxmlformats.org/officeDocument/2006/relationships" id="262" r:id="Ree908b4b5b974a8a"/>
+    <p:sldId xmlns:r="http://schemas.openxmlformats.org/officeDocument/2006/relationships" id="263" r:id="R1d0a962f0dee4a16"/>
+    <p:sldId xmlns:r="http://schemas.openxmlformats.org/officeDocument/2006/relationships" id="264" r:id="R6f5cb33008f14853"/>
+    <p:sldId xmlns:r="http://schemas.openxmlformats.org/officeDocument/2006/relationships" id="265" r:id="Radcbe6b1e8ef4c3d"/>
+    <p:sldId xmlns:r="http://schemas.openxmlformats.org/officeDocument/2006/relationships" id="266" r:id="R60257372645349c0"/>
+    <p:sldId xmlns:r="http://schemas.openxmlformats.org/officeDocument/2006/relationships" id="267" r:id="Rfdffe6eadad24e67"/>
+    <p:sldId xmlns:r="http://schemas.openxmlformats.org/officeDocument/2006/relationships" id="268" r:id="R63ac272e1342465f"/>
+    <p:sldId xmlns:r="http://schemas.openxmlformats.org/officeDocument/2006/relationships" id="269" r:id="R2569573867f84ba3"/>
+    <p:sldId xmlns:r="http://schemas.openxmlformats.org/officeDocument/2006/relationships" id="270" r:id="R30c002c6de6f43c1"/>
   </p:sldIdLst>
   <p:sldSz cx="12192000" cy="6858000"/>
   <p:notesSz cx="6858000" cy="9144000"/>
@@ -1839,7 +1839,7 @@
   </p:cSld>
   <p:clrMap bg1="lt1" tx1="dk1" bg2="lt2" tx2="dk2" accent1="accent1" accent2="accent2" accent3="accent3" accent4="accent4" accent5="accent5" accent6="accent6" hlink="hlink" folHlink="folHlink"/>
   <p:sldLayoutIdLst>
-    <p:sldLayoutId xmlns:r="http://schemas.openxmlformats.org/officeDocument/2006/relationships" id="2147483649" r:id="R900bb6f81f9b4296"/>
+    <p:sldLayoutId xmlns:r="http://schemas.openxmlformats.org/officeDocument/2006/relationships" id="2147483649" r:id="R50cd9cc6ccbb4e64"/>
   </p:sldLayoutIdLst>
   <p:txStyles>
     <p:titleStyle>
@@ -2595,7 +2595,7 @@
           <p:cNvPr id="8" name="">
             <a:extLst xmlns:a="http://schemas.openxmlformats.org/drawingml/2006/main">
               <a:ext uri="{FF2B5EF4-FFF2-40B4-BE49-F238E27FC236}">
-                <a16:creationId xmlns:a16="http://schemas.microsoft.com/office/drawing/2014/main" id="{F0C40507-FF3C-4832-A022-2B1B9E736E27}"/>
+                <a16:creationId xmlns:a16="http://schemas.microsoft.com/office/drawing/2014/main" id="{A3E16AEC-D2BF-4491-A25D-0AD91BB84776}"/>
               </a:ext>
             </a:extLst>
           </p:cNvPr>
@@ -2626,7 +2626,7 @@
           <p:cNvPr id="2" name="">
             <a:extLst xmlns:a="http://schemas.openxmlformats.org/drawingml/2006/main">
               <a:ext uri="{FF2B5EF4-FFF2-40B4-BE49-F238E27FC236}">
-                <a16:creationId xmlns:a16="http://schemas.microsoft.com/office/drawing/2014/main" id="{40ECBC36-3F4C-4EFF-89A1-00A53A952213}"/>
+                <a16:creationId xmlns:a16="http://schemas.microsoft.com/office/drawing/2014/main" id="{0A4E67C6-9D51-45EF-A093-DB38C5314C90}"/>
               </a:ext>
             </a:extLst>
           </p:cNvPr>
@@ -2682,7 +2682,7 @@
           <p:cNvPr id="3" name="">
             <a:extLst xmlns:a="http://schemas.openxmlformats.org/drawingml/2006/main">
               <a:ext uri="{FF2B5EF4-FFF2-40B4-BE49-F238E27FC236}">
-                <a16:creationId xmlns:a16="http://schemas.microsoft.com/office/drawing/2014/main" id="{B5A48500-6B9B-42FB-BCFC-72104D438EEF}"/>
+                <a16:creationId xmlns:a16="http://schemas.microsoft.com/office/drawing/2014/main" id="{4047806A-3417-4968-8624-EA73BC05DCEB}"/>
               </a:ext>
             </a:extLst>
           </p:cNvPr>
@@ -2761,7 +2761,7 @@
           <p:cNvPr id="4" name="">
             <a:extLst xmlns:a="http://schemas.openxmlformats.org/drawingml/2006/main">
               <a:ext uri="{FF2B5EF4-FFF2-40B4-BE49-F238E27FC236}">
-                <a16:creationId xmlns:a16="http://schemas.microsoft.com/office/drawing/2014/main" id="{F43731CE-3103-4E8F-BD80-FE49CF7A9D1B}"/>
+                <a16:creationId xmlns:a16="http://schemas.microsoft.com/office/drawing/2014/main" id="{1F6B1E84-2B99-4583-BCE7-EC0F8B6F98F7}"/>
               </a:ext>
             </a:extLst>
           </p:cNvPr>
@@ -2817,7 +2817,7 @@
           <p:cNvPr id="5" name="">
             <a:extLst xmlns:a="http://schemas.openxmlformats.org/drawingml/2006/main">
               <a:ext uri="{FF2B5EF4-FFF2-40B4-BE49-F238E27FC236}">
-                <a16:creationId xmlns:a16="http://schemas.microsoft.com/office/drawing/2014/main" id="{8CCFC173-3370-4923-BF73-9E2CF515D48F}"/>
+                <a16:creationId xmlns:a16="http://schemas.microsoft.com/office/drawing/2014/main" id="{71D50B1B-1676-4DE1-AA40-99E33F6677AA}"/>
               </a:ext>
             </a:extLst>
           </p:cNvPr>
@@ -2848,19 +2848,19 @@
           <p:cNvPr id="6" name="">
             <a:extLst xmlns:a="http://schemas.openxmlformats.org/drawingml/2006/main">
               <a:ext uri="{FF2B5EF4-FFF2-40B4-BE49-F238E27FC236}">
-                <a16:creationId xmlns:a16="http://schemas.microsoft.com/office/drawing/2014/main" id="{E025E082-959E-4995-98FD-27397BD05E71}"/>
-              </a:ext>
-            </a:extLst>
-          </p:cNvPr>
-          <p:cNvSpPr>
-            <a:spLocks xmlns:a="http://schemas.openxmlformats.org/drawingml/2006/main" noGrp="1"/>
-          </p:cNvSpPr>
-          <p:nvPr/>
-        </p:nvSpPr>
-        <p:spPr>
-          <a:xfrm xmlns:a="http://schemas.openxmlformats.org/drawingml/2006/main">
-            <a:off x="628650" y="4714875"/>
-            <a:ext cx="10668000" cy="523875"/>
+                <a16:creationId xmlns:a16="http://schemas.microsoft.com/office/drawing/2014/main" id="{AE554211-EE6C-46AC-9C07-75A251C96801}"/>
+              </a:ext>
+            </a:extLst>
+          </p:cNvPr>
+          <p:cNvSpPr>
+            <a:spLocks xmlns:a="http://schemas.openxmlformats.org/drawingml/2006/main" noGrp="1"/>
+          </p:cNvSpPr>
+          <p:nvPr/>
+        </p:nvSpPr>
+        <p:spPr>
+          <a:xfrm xmlns:a="http://schemas.openxmlformats.org/drawingml/2006/main">
+            <a:off x="628650" y="4591050"/>
+            <a:ext cx="10668000" cy="723900"/>
           </a:xfrm>
           <a:prstGeom xmlns:a="http://schemas.openxmlformats.org/drawingml/2006/main" prst="rect">
             <a:avLst/>
@@ -2876,7 +2876,7 @@
           <a:lstStyle xmlns:a="http://schemas.openxmlformats.org/drawingml/2006/main"/>
           <a:p xmlns:a="http://schemas.openxmlformats.org/drawingml/2006/main">
             <a:pPr algn="l">
-              <a:defRPr sz="1650" b="0">
+              <a:defRPr sz="1500" b="0">
                 <a:solidFill>
                   <a:srgbClr val="FFFFFF"/>
                 </a:solidFill>
@@ -2886,7 +2886,7 @@
               </a:defRPr>
             </a:pPr>
             <a:r>
-              <a:rPr sz="1650" b="0">
+              <a:rPr sz="1500" b="0">
                 <a:solidFill>
                   <a:srgbClr val="FFFFFF"/>
                 </a:solidFill>
@@ -2894,7 +2894,30 @@
                 <a:ea typeface="Arial"/>
                 <a:cs typeface="Arial"/>
               </a:rPr>
-              <a:t>Diego Díaz · Bairon Horna · Ignacio Marín · Jordan López · Aaron Medrano</a:t>
+              <a:t>Diego Díaz · Bairon Horna · Ignacio Marín</a:t>
+            </a:r>
+          </a:p>
+          <a:p xmlns:a="http://schemas.openxmlformats.org/drawingml/2006/main">
+            <a:pPr algn="l">
+              <a:defRPr sz="1500" b="0">
+                <a:solidFill>
+                  <a:srgbClr val="FFFFFF"/>
+                </a:solidFill>
+                <a:latin typeface="Arial"/>
+                <a:ea typeface="Arial"/>
+                <a:cs typeface="Arial"/>
+              </a:defRPr>
+            </a:pPr>
+            <a:r>
+              <a:rPr sz="1500" b="0">
+                <a:solidFill>
+                  <a:srgbClr val="FFFFFF"/>
+                </a:solidFill>
+                <a:latin typeface="Arial"/>
+                <a:ea typeface="Arial"/>
+                <a:cs typeface="Arial"/>
+              </a:rPr>
+              <a:t>Jordan López · Aaron Medrano · Emilio de Gomez</a:t>
             </a:r>
           </a:p>
         </p:txBody>
@@ -2904,7 +2927,7 @@
           <p:cNvPr id="7" name="">
             <a:extLst xmlns:a="http://schemas.openxmlformats.org/drawingml/2006/main">
               <a:ext uri="{FF2B5EF4-FFF2-40B4-BE49-F238E27FC236}">
-                <a16:creationId xmlns:a16="http://schemas.microsoft.com/office/drawing/2014/main" id="{53A5B98F-56E4-4F97-A284-7D75B65625F4}"/>
+                <a16:creationId xmlns:a16="http://schemas.microsoft.com/office/drawing/2014/main" id="{528B7F75-6CCE-4946-9BAD-03DEA57CB99C}"/>
               </a:ext>
             </a:extLst>
           </p:cNvPr>
@@ -2958,7 +2981,7 @@
     </p:spTree>
     <p:extLst>
       <p:ext uri="{BB962C8B-B14F-4D97-AF65-F5344CB8AC3E}">
-        <p14:creationId xmlns:p14="http://schemas.microsoft.com/office/powerpoint/2010/main" val="660051476"/>
+        <p14:creationId xmlns:p14="http://schemas.microsoft.com/office/powerpoint/2010/main" val="1013751241"/>
       </p:ext>
     </p:extLst>
   </p:cSld>
@@ -2982,7 +3005,7 @@
           <p:cNvPr id="9" name="">
             <a:extLst xmlns:a="http://schemas.openxmlformats.org/drawingml/2006/main">
               <a:ext uri="{FF2B5EF4-FFF2-40B4-BE49-F238E27FC236}">
-                <a16:creationId xmlns:a16="http://schemas.microsoft.com/office/drawing/2014/main" id="{B1BEADF3-6917-46FF-9981-FE5F6A9FF23B}"/>
+                <a16:creationId xmlns:a16="http://schemas.microsoft.com/office/drawing/2014/main" id="{2F27C3DF-9F4D-481D-A8C7-52715844957F}"/>
               </a:ext>
             </a:extLst>
           </p:cNvPr>
@@ -3013,7 +3036,7 @@
           <p:cNvPr id="2" name="">
             <a:extLst xmlns:a="http://schemas.openxmlformats.org/drawingml/2006/main">
               <a:ext uri="{FF2B5EF4-FFF2-40B4-BE49-F238E27FC236}">
-                <a16:creationId xmlns:a16="http://schemas.microsoft.com/office/drawing/2014/main" id="{E8EC8FF6-B33C-4795-BB9C-745C3F6A007E}"/>
+                <a16:creationId xmlns:a16="http://schemas.microsoft.com/office/drawing/2014/main" id="{7B0C21B0-8BAA-4422-B414-7275B132DFBF}"/>
               </a:ext>
             </a:extLst>
           </p:cNvPr>
@@ -3069,7 +3092,7 @@
           <p:cNvPr id="3" name="">
             <a:extLst xmlns:a="http://schemas.openxmlformats.org/drawingml/2006/main">
               <a:ext uri="{FF2B5EF4-FFF2-40B4-BE49-F238E27FC236}">
-                <a16:creationId xmlns:a16="http://schemas.microsoft.com/office/drawing/2014/main" id="{4F4ADB32-8998-4D84-AB57-87DB0D8C309D}"/>
+                <a16:creationId xmlns:a16="http://schemas.microsoft.com/office/drawing/2014/main" id="{1D0DB05C-E9EA-45B4-8479-8D25BE892153}"/>
               </a:ext>
             </a:extLst>
           </p:cNvPr>
@@ -3129,7 +3152,7 @@
           <p:nvPr/>
         </p:nvPicPr>
         <p:blipFill>
-          <a:blip xmlns:r="http://schemas.openxmlformats.org/officeDocument/2006/relationships" xmlns:a="http://schemas.openxmlformats.org/drawingml/2006/main" r:embed="R2f2375ecd3cf496d"/>
+          <a:blip xmlns:r="http://schemas.openxmlformats.org/officeDocument/2006/relationships" xmlns:a="http://schemas.openxmlformats.org/drawingml/2006/main" r:embed="R785367ca3e4247ee"/>
           <a:stretch xmlns:a="http://schemas.openxmlformats.org/drawingml/2006/main"/>
         </p:blipFill>
         <p:spPr>
@@ -3147,7 +3170,7 @@
           <p:cNvPr id="5" name="">
             <a:extLst xmlns:a="http://schemas.openxmlformats.org/drawingml/2006/main">
               <a:ext uri="{FF2B5EF4-FFF2-40B4-BE49-F238E27FC236}">
-                <a16:creationId xmlns:a16="http://schemas.microsoft.com/office/drawing/2014/main" id="{437C0040-A365-4155-B74F-8811F2688A12}"/>
+                <a16:creationId xmlns:a16="http://schemas.microsoft.com/office/drawing/2014/main" id="{F9DBF377-9EE7-4E95-A716-D08D28B2321D}"/>
               </a:ext>
             </a:extLst>
           </p:cNvPr>
@@ -3182,7 +3205,7 @@
           <p:cNvPr id="6" name="">
             <a:extLst xmlns:a="http://schemas.openxmlformats.org/drawingml/2006/main">
               <a:ext uri="{FF2B5EF4-FFF2-40B4-BE49-F238E27FC236}">
-                <a16:creationId xmlns:a16="http://schemas.microsoft.com/office/drawing/2014/main" id="{89D0CFC0-24EA-48AC-979F-6EF1C201B034}"/>
+                <a16:creationId xmlns:a16="http://schemas.microsoft.com/office/drawing/2014/main" id="{B60A4E18-77D1-47A6-B1E4-66E65510E62B}"/>
               </a:ext>
             </a:extLst>
           </p:cNvPr>
@@ -3238,7 +3261,7 @@
           <p:cNvPr id="7" name="">
             <a:extLst xmlns:a="http://schemas.openxmlformats.org/drawingml/2006/main">
               <a:ext uri="{FF2B5EF4-FFF2-40B4-BE49-F238E27FC236}">
-                <a16:creationId xmlns:a16="http://schemas.microsoft.com/office/drawing/2014/main" id="{575C1405-4C2C-4067-8F26-566CD0542D02}"/>
+                <a16:creationId xmlns:a16="http://schemas.microsoft.com/office/drawing/2014/main" id="{A3A3297A-2CF9-4E8C-91C0-178F6AAC7948}"/>
               </a:ext>
             </a:extLst>
           </p:cNvPr>
@@ -3363,7 +3386,7 @@
           <p:cNvPr id="8" name="">
             <a:extLst xmlns:a="http://schemas.openxmlformats.org/drawingml/2006/main">
               <a:ext uri="{FF2B5EF4-FFF2-40B4-BE49-F238E27FC236}">
-                <a16:creationId xmlns:a16="http://schemas.microsoft.com/office/drawing/2014/main" id="{245D53E6-49AF-4C17-A376-7F085569F2CD}"/>
+                <a16:creationId xmlns:a16="http://schemas.microsoft.com/office/drawing/2014/main" id="{A6A0ECBC-1A02-406E-8F78-625F86D4414E}"/>
               </a:ext>
             </a:extLst>
           </p:cNvPr>
@@ -3417,7 +3440,7 @@
     </p:spTree>
     <p:extLst>
       <p:ext uri="{BB962C8B-B14F-4D97-AF65-F5344CB8AC3E}">
-        <p14:creationId xmlns:p14="http://schemas.microsoft.com/office/powerpoint/2010/main" val="1648971171"/>
+        <p14:creationId xmlns:p14="http://schemas.microsoft.com/office/powerpoint/2010/main" val="297849940"/>
       </p:ext>
     </p:extLst>
   </p:cSld>
@@ -3441,7 +3464,7 @@
           <p:cNvPr id="12" name="">
             <a:extLst xmlns:a="http://schemas.openxmlformats.org/drawingml/2006/main">
               <a:ext uri="{FF2B5EF4-FFF2-40B4-BE49-F238E27FC236}">
-                <a16:creationId xmlns:a16="http://schemas.microsoft.com/office/drawing/2014/main" id="{996D362B-998B-43F6-9C8B-F83DB5DC7BF8}"/>
+                <a16:creationId xmlns:a16="http://schemas.microsoft.com/office/drawing/2014/main" id="{6924B06A-51AB-4D09-8FC3-974E69937485}"/>
               </a:ext>
             </a:extLst>
           </p:cNvPr>
@@ -3472,7 +3495,7 @@
           <p:cNvPr id="2" name="">
             <a:extLst xmlns:a="http://schemas.openxmlformats.org/drawingml/2006/main">
               <a:ext uri="{FF2B5EF4-FFF2-40B4-BE49-F238E27FC236}">
-                <a16:creationId xmlns:a16="http://schemas.microsoft.com/office/drawing/2014/main" id="{3A204503-DFA4-4532-9090-373E12ACD745}"/>
+                <a16:creationId xmlns:a16="http://schemas.microsoft.com/office/drawing/2014/main" id="{B50F81AD-F782-426F-AF0E-26F983EE0D90}"/>
               </a:ext>
             </a:extLst>
           </p:cNvPr>
@@ -3528,7 +3551,7 @@
           <p:cNvPr id="3" name="">
             <a:extLst xmlns:a="http://schemas.openxmlformats.org/drawingml/2006/main">
               <a:ext uri="{FF2B5EF4-FFF2-40B4-BE49-F238E27FC236}">
-                <a16:creationId xmlns:a16="http://schemas.microsoft.com/office/drawing/2014/main" id="{1672EECC-B1D6-4FD4-8F75-FFD9D0E1DD1C}"/>
+                <a16:creationId xmlns:a16="http://schemas.microsoft.com/office/drawing/2014/main" id="{5E9CF3CB-C9A1-4AE0-9329-F2AC5549E685}"/>
               </a:ext>
             </a:extLst>
           </p:cNvPr>
@@ -3591,7 +3614,7 @@
         </p:xfrm>
         <a:graphic xmlns:a="http://schemas.openxmlformats.org/drawingml/2006/main">
           <a:graphicData uri="http://schemas.openxmlformats.org/drawingml/2006/chart">
-            <c:chart xmlns:r="http://schemas.openxmlformats.org/officeDocument/2006/relationships" xmlns:c="http://schemas.openxmlformats.org/drawingml/2006/chart" r:id="Re2d99e556f684e55"/>
+            <c:chart xmlns:r="http://schemas.openxmlformats.org/officeDocument/2006/relationships" xmlns:c="http://schemas.openxmlformats.org/drawingml/2006/chart" r:id="R1e5fe20a545f4405"/>
           </a:graphicData>
         </a:graphic>
       </p:graphicFrame>
@@ -3600,7 +3623,7 @@
           <p:cNvPr id="5" name="">
             <a:extLst xmlns:a="http://schemas.openxmlformats.org/drawingml/2006/main">
               <a:ext uri="{FF2B5EF4-FFF2-40B4-BE49-F238E27FC236}">
-                <a16:creationId xmlns:a16="http://schemas.microsoft.com/office/drawing/2014/main" id="{73265445-3EC8-4603-8982-A70B793DC7F5}"/>
+                <a16:creationId xmlns:a16="http://schemas.microsoft.com/office/drawing/2014/main" id="{C27AFA92-494D-472C-A72B-2BCFB65BDD6C}"/>
               </a:ext>
             </a:extLst>
           </p:cNvPr>
@@ -3635,7 +3658,7 @@
           <p:cNvPr id="6" name="">
             <a:extLst xmlns:a="http://schemas.openxmlformats.org/drawingml/2006/main">
               <a:ext uri="{FF2B5EF4-FFF2-40B4-BE49-F238E27FC236}">
-                <a16:creationId xmlns:a16="http://schemas.microsoft.com/office/drawing/2014/main" id="{30BC368A-66EA-475C-A95C-FB9927F009E5}"/>
+                <a16:creationId xmlns:a16="http://schemas.microsoft.com/office/drawing/2014/main" id="{6A324162-D6D5-42C7-8A9C-58A144CFC00D}"/>
               </a:ext>
             </a:extLst>
           </p:cNvPr>
@@ -3691,7 +3714,7 @@
           <p:cNvPr id="7" name="">
             <a:extLst xmlns:a="http://schemas.openxmlformats.org/drawingml/2006/main">
               <a:ext uri="{FF2B5EF4-FFF2-40B4-BE49-F238E27FC236}">
-                <a16:creationId xmlns:a16="http://schemas.microsoft.com/office/drawing/2014/main" id="{157664A8-3297-4825-A5AB-C05B37DC351E}"/>
+                <a16:creationId xmlns:a16="http://schemas.microsoft.com/office/drawing/2014/main" id="{21E92E47-9569-4B8C-A598-BB83D0C95098}"/>
               </a:ext>
             </a:extLst>
           </p:cNvPr>
@@ -3747,7 +3770,7 @@
           <p:cNvPr id="8" name="">
             <a:extLst xmlns:a="http://schemas.openxmlformats.org/drawingml/2006/main">
               <a:ext uri="{FF2B5EF4-FFF2-40B4-BE49-F238E27FC236}">
-                <a16:creationId xmlns:a16="http://schemas.microsoft.com/office/drawing/2014/main" id="{61329503-F4AD-473D-8845-03E6C715808A}"/>
+                <a16:creationId xmlns:a16="http://schemas.microsoft.com/office/drawing/2014/main" id="{75AABE29-881A-45C9-824B-5E8D728B415C}"/>
               </a:ext>
             </a:extLst>
           </p:cNvPr>
@@ -3782,7 +3805,7 @@
           <p:cNvPr id="9" name="">
             <a:extLst xmlns:a="http://schemas.openxmlformats.org/drawingml/2006/main">
               <a:ext uri="{FF2B5EF4-FFF2-40B4-BE49-F238E27FC236}">
-                <a16:creationId xmlns:a16="http://schemas.microsoft.com/office/drawing/2014/main" id="{955CF5F5-379B-4B7B-954A-0D7E2D048AAE}"/>
+                <a16:creationId xmlns:a16="http://schemas.microsoft.com/office/drawing/2014/main" id="{19B367C4-3490-47E9-B495-4C34785CD6AE}"/>
               </a:ext>
             </a:extLst>
           </p:cNvPr>
@@ -3838,7 +3861,7 @@
           <p:cNvPr id="10" name="">
             <a:extLst xmlns:a="http://schemas.openxmlformats.org/drawingml/2006/main">
               <a:ext uri="{FF2B5EF4-FFF2-40B4-BE49-F238E27FC236}">
-                <a16:creationId xmlns:a16="http://schemas.microsoft.com/office/drawing/2014/main" id="{7E57AA06-A5B8-4140-B5B8-EB5DA704FE1C}"/>
+                <a16:creationId xmlns:a16="http://schemas.microsoft.com/office/drawing/2014/main" id="{A1481805-689A-4669-8DD4-B101E543D0BA}"/>
               </a:ext>
             </a:extLst>
           </p:cNvPr>
@@ -3917,7 +3940,7 @@
           <p:cNvPr id="11" name="">
             <a:extLst xmlns:a="http://schemas.openxmlformats.org/drawingml/2006/main">
               <a:ext uri="{FF2B5EF4-FFF2-40B4-BE49-F238E27FC236}">
-                <a16:creationId xmlns:a16="http://schemas.microsoft.com/office/drawing/2014/main" id="{1AB8E23C-2323-46E3-9A9E-BB5ECBAC4208}"/>
+                <a16:creationId xmlns:a16="http://schemas.microsoft.com/office/drawing/2014/main" id="{7C7289F9-6F86-41B4-AFD2-1B0C5C3C990E}"/>
               </a:ext>
             </a:extLst>
           </p:cNvPr>
@@ -3971,7 +3994,7 @@
     </p:spTree>
     <p:extLst>
       <p:ext uri="{BB962C8B-B14F-4D97-AF65-F5344CB8AC3E}">
-        <p14:creationId xmlns:p14="http://schemas.microsoft.com/office/powerpoint/2010/main" val="1195258857"/>
+        <p14:creationId xmlns:p14="http://schemas.microsoft.com/office/powerpoint/2010/main" val="226661291"/>
       </p:ext>
     </p:extLst>
   </p:cSld>
@@ -3995,7 +4018,7 @@
           <p:cNvPr id="10" name="">
             <a:extLst xmlns:a="http://schemas.openxmlformats.org/drawingml/2006/main">
               <a:ext uri="{FF2B5EF4-FFF2-40B4-BE49-F238E27FC236}">
-                <a16:creationId xmlns:a16="http://schemas.microsoft.com/office/drawing/2014/main" id="{D40223BE-AB1F-4041-A39D-A69D7E5B99E5}"/>
+                <a16:creationId xmlns:a16="http://schemas.microsoft.com/office/drawing/2014/main" id="{57DE1E46-C71B-4BE8-9586-B474FBBD098E}"/>
               </a:ext>
             </a:extLst>
           </p:cNvPr>
@@ -4026,7 +4049,7 @@
           <p:cNvPr id="2" name="">
             <a:extLst xmlns:a="http://schemas.openxmlformats.org/drawingml/2006/main">
               <a:ext uri="{FF2B5EF4-FFF2-40B4-BE49-F238E27FC236}">
-                <a16:creationId xmlns:a16="http://schemas.microsoft.com/office/drawing/2014/main" id="{B770F3E2-07DF-462B-8789-D98FFAE5A54F}"/>
+                <a16:creationId xmlns:a16="http://schemas.microsoft.com/office/drawing/2014/main" id="{F4750023-C480-4FD9-BFBF-2D8F7D2E8BD6}"/>
               </a:ext>
             </a:extLst>
           </p:cNvPr>
@@ -4082,7 +4105,7 @@
           <p:cNvPr id="3" name="">
             <a:extLst xmlns:a="http://schemas.openxmlformats.org/drawingml/2006/main">
               <a:ext uri="{FF2B5EF4-FFF2-40B4-BE49-F238E27FC236}">
-                <a16:creationId xmlns:a16="http://schemas.microsoft.com/office/drawing/2014/main" id="{CB26746C-30B8-48FD-A5E3-29288145B80B}"/>
+                <a16:creationId xmlns:a16="http://schemas.microsoft.com/office/drawing/2014/main" id="{AEBC45E2-51AB-4407-9820-27147395B6D8}"/>
               </a:ext>
             </a:extLst>
           </p:cNvPr>
@@ -4138,7 +4161,7 @@
           <p:cNvPr id="4" name="">
             <a:extLst xmlns:a="http://schemas.openxmlformats.org/drawingml/2006/main">
               <a:ext uri="{FF2B5EF4-FFF2-40B4-BE49-F238E27FC236}">
-                <a16:creationId xmlns:a16="http://schemas.microsoft.com/office/drawing/2014/main" id="{0FE56E72-FF46-4C42-A63B-6A02946AECE5}"/>
+                <a16:creationId xmlns:a16="http://schemas.microsoft.com/office/drawing/2014/main" id="{80BAC3AF-E90A-4266-B063-13AA3F4D2EA8}"/>
               </a:ext>
             </a:extLst>
           </p:cNvPr>
@@ -4173,7 +4196,7 @@
           <p:cNvPr id="5" name="">
             <a:extLst xmlns:a="http://schemas.openxmlformats.org/drawingml/2006/main">
               <a:ext uri="{FF2B5EF4-FFF2-40B4-BE49-F238E27FC236}">
-                <a16:creationId xmlns:a16="http://schemas.microsoft.com/office/drawing/2014/main" id="{BFD5AAA6-311C-467E-8B80-65F30CDE732C}"/>
+                <a16:creationId xmlns:a16="http://schemas.microsoft.com/office/drawing/2014/main" id="{69B185BE-CA11-4577-9317-B9B8689B7B1A}"/>
               </a:ext>
             </a:extLst>
           </p:cNvPr>
@@ -4229,7 +4252,7 @@
           <p:cNvPr id="6" name="">
             <a:extLst xmlns:a="http://schemas.openxmlformats.org/drawingml/2006/main">
               <a:ext uri="{FF2B5EF4-FFF2-40B4-BE49-F238E27FC236}">
-                <a16:creationId xmlns:a16="http://schemas.microsoft.com/office/drawing/2014/main" id="{2D9235F1-4B4D-4584-9CD4-5C4C8E7AB419}"/>
+                <a16:creationId xmlns:a16="http://schemas.microsoft.com/office/drawing/2014/main" id="{52E27B2F-155E-4966-805D-4B6040056AC5}"/>
               </a:ext>
             </a:extLst>
           </p:cNvPr>
@@ -4377,7 +4400,7 @@
           <p:cNvPr id="7" name="">
             <a:extLst xmlns:a="http://schemas.openxmlformats.org/drawingml/2006/main">
               <a:ext uri="{FF2B5EF4-FFF2-40B4-BE49-F238E27FC236}">
-                <a16:creationId xmlns:a16="http://schemas.microsoft.com/office/drawing/2014/main" id="{335C361C-76D7-4A3B-B92B-19A083AFE490}"/>
+                <a16:creationId xmlns:a16="http://schemas.microsoft.com/office/drawing/2014/main" id="{D617802A-907B-40F5-9DDC-980FE30FCF79}"/>
               </a:ext>
             </a:extLst>
           </p:cNvPr>
@@ -4412,7 +4435,7 @@
           <p:cNvPr id="8" name="">
             <a:extLst xmlns:a="http://schemas.openxmlformats.org/drawingml/2006/main">
               <a:ext uri="{FF2B5EF4-FFF2-40B4-BE49-F238E27FC236}">
-                <a16:creationId xmlns:a16="http://schemas.microsoft.com/office/drawing/2014/main" id="{C784584B-FF39-4E66-81B2-3707DAE02AD1}"/>
+                <a16:creationId xmlns:a16="http://schemas.microsoft.com/office/drawing/2014/main" id="{026512F0-3B33-42A9-B7F9-1E6EEBDDC5C9}"/>
               </a:ext>
             </a:extLst>
           </p:cNvPr>
@@ -4468,7 +4491,7 @@
           <p:cNvPr id="9" name="">
             <a:extLst xmlns:a="http://schemas.openxmlformats.org/drawingml/2006/main">
               <a:ext uri="{FF2B5EF4-FFF2-40B4-BE49-F238E27FC236}">
-                <a16:creationId xmlns:a16="http://schemas.microsoft.com/office/drawing/2014/main" id="{91D33F3D-01A2-44B1-84EF-DE82BE789245}"/>
+                <a16:creationId xmlns:a16="http://schemas.microsoft.com/office/drawing/2014/main" id="{A4A7F900-BE3C-4382-9A34-602D726F4D7B}"/>
               </a:ext>
             </a:extLst>
           </p:cNvPr>
@@ -4614,7 +4637,7 @@
     </p:spTree>
     <p:extLst>
       <p:ext uri="{BB962C8B-B14F-4D97-AF65-F5344CB8AC3E}">
-        <p14:creationId xmlns:p14="http://schemas.microsoft.com/office/powerpoint/2010/main" val="1843304848"/>
+        <p14:creationId xmlns:p14="http://schemas.microsoft.com/office/powerpoint/2010/main" val="1884841431"/>
       </p:ext>
     </p:extLst>
   </p:cSld>
@@ -4638,7 +4661,7 @@
           <p:cNvPr id="10" name="">
             <a:extLst xmlns:a="http://schemas.openxmlformats.org/drawingml/2006/main">
               <a:ext uri="{FF2B5EF4-FFF2-40B4-BE49-F238E27FC236}">
-                <a16:creationId xmlns:a16="http://schemas.microsoft.com/office/drawing/2014/main" id="{1DE9E785-87E2-43F4-91EE-46F612E5C134}"/>
+                <a16:creationId xmlns:a16="http://schemas.microsoft.com/office/drawing/2014/main" id="{BECB5F8E-D4B5-4FF6-BEAE-0A259A58A78E}"/>
               </a:ext>
             </a:extLst>
           </p:cNvPr>
@@ -4669,7 +4692,7 @@
           <p:cNvPr id="2" name="">
             <a:extLst xmlns:a="http://schemas.openxmlformats.org/drawingml/2006/main">
               <a:ext uri="{FF2B5EF4-FFF2-40B4-BE49-F238E27FC236}">
-                <a16:creationId xmlns:a16="http://schemas.microsoft.com/office/drawing/2014/main" id="{24F65C9E-439E-414B-85CA-4CED61516D96}"/>
+                <a16:creationId xmlns:a16="http://schemas.microsoft.com/office/drawing/2014/main" id="{BCB25BE1-642C-4F6B-9D07-0C21D31D3D5C}"/>
               </a:ext>
             </a:extLst>
           </p:cNvPr>
@@ -4725,7 +4748,7 @@
           <p:cNvPr id="3" name="">
             <a:extLst xmlns:a="http://schemas.openxmlformats.org/drawingml/2006/main">
               <a:ext uri="{FF2B5EF4-FFF2-40B4-BE49-F238E27FC236}">
-                <a16:creationId xmlns:a16="http://schemas.microsoft.com/office/drawing/2014/main" id="{30CC66CC-1D17-4854-A8C0-771FA5228D13}"/>
+                <a16:creationId xmlns:a16="http://schemas.microsoft.com/office/drawing/2014/main" id="{3991087C-A3D0-4A17-8F06-49617F2224F2}"/>
               </a:ext>
             </a:extLst>
           </p:cNvPr>
@@ -4781,7 +4804,7 @@
           <p:cNvPr id="4" name="">
             <a:extLst xmlns:a="http://schemas.openxmlformats.org/drawingml/2006/main">
               <a:ext uri="{FF2B5EF4-FFF2-40B4-BE49-F238E27FC236}">
-                <a16:creationId xmlns:a16="http://schemas.microsoft.com/office/drawing/2014/main" id="{5448EF01-0FA2-499C-A93F-6FA7630B71E3}"/>
+                <a16:creationId xmlns:a16="http://schemas.microsoft.com/office/drawing/2014/main" id="{3A41B777-F57A-4F68-BC61-63B303D7B60B}"/>
               </a:ext>
             </a:extLst>
           </p:cNvPr>
@@ -4837,7 +4860,7 @@
           <p:cNvPr id="5" name="">
             <a:extLst xmlns:a="http://schemas.openxmlformats.org/drawingml/2006/main">
               <a:ext uri="{FF2B5EF4-FFF2-40B4-BE49-F238E27FC236}">
-                <a16:creationId xmlns:a16="http://schemas.microsoft.com/office/drawing/2014/main" id="{5790A645-911C-441B-9D6B-019EB6BB4B9F}"/>
+                <a16:creationId xmlns:a16="http://schemas.microsoft.com/office/drawing/2014/main" id="{C1914AAA-6DA2-4FA8-A63C-3EDEBF754CFF}"/>
               </a:ext>
             </a:extLst>
           </p:cNvPr>
@@ -4893,7 +4916,7 @@
           <p:cNvPr id="6" name="">
             <a:extLst xmlns:a="http://schemas.openxmlformats.org/drawingml/2006/main">
               <a:ext uri="{FF2B5EF4-FFF2-40B4-BE49-F238E27FC236}">
-                <a16:creationId xmlns:a16="http://schemas.microsoft.com/office/drawing/2014/main" id="{3962AA7B-A54D-42F0-A86B-373B759F7CC3}"/>
+                <a16:creationId xmlns:a16="http://schemas.microsoft.com/office/drawing/2014/main" id="{F9F8EA7A-0453-4909-BC24-60C7EE8F728C}"/>
               </a:ext>
             </a:extLst>
           </p:cNvPr>
@@ -4949,7 +4972,7 @@
           <p:cNvPr id="7" name="">
             <a:extLst xmlns:a="http://schemas.openxmlformats.org/drawingml/2006/main">
               <a:ext uri="{FF2B5EF4-FFF2-40B4-BE49-F238E27FC236}">
-                <a16:creationId xmlns:a16="http://schemas.microsoft.com/office/drawing/2014/main" id="{B94C4D15-A164-456D-809F-D1334B7FF56B}"/>
+                <a16:creationId xmlns:a16="http://schemas.microsoft.com/office/drawing/2014/main" id="{CFFE7540-17D1-4FAD-910E-E6E5186D7CE5}"/>
               </a:ext>
             </a:extLst>
           </p:cNvPr>
@@ -5005,7 +5028,7 @@
           <p:cNvPr id="8" name="">
             <a:extLst xmlns:a="http://schemas.openxmlformats.org/drawingml/2006/main">
               <a:ext uri="{FF2B5EF4-FFF2-40B4-BE49-F238E27FC236}">
-                <a16:creationId xmlns:a16="http://schemas.microsoft.com/office/drawing/2014/main" id="{98C81C3B-1CC9-4173-93E4-6979ECC777F8}"/>
+                <a16:creationId xmlns:a16="http://schemas.microsoft.com/office/drawing/2014/main" id="{70D1B3A9-CA33-4C68-99B1-6160E91F8EAB}"/>
               </a:ext>
             </a:extLst>
           </p:cNvPr>
@@ -5040,7 +5063,7 @@
           <p:cNvPr id="9" name="">
             <a:extLst xmlns:a="http://schemas.openxmlformats.org/drawingml/2006/main">
               <a:ext uri="{FF2B5EF4-FFF2-40B4-BE49-F238E27FC236}">
-                <a16:creationId xmlns:a16="http://schemas.microsoft.com/office/drawing/2014/main" id="{273AE918-13E7-4D2F-AF2C-FA5A137A3A4B}"/>
+                <a16:creationId xmlns:a16="http://schemas.microsoft.com/office/drawing/2014/main" id="{B087101A-C327-4A4F-A924-3D5F0AB4D0BD}"/>
               </a:ext>
             </a:extLst>
           </p:cNvPr>
@@ -5094,7 +5117,7 @@
     </p:spTree>
     <p:extLst>
       <p:ext uri="{BB962C8B-B14F-4D97-AF65-F5344CB8AC3E}">
-        <p14:creationId xmlns:p14="http://schemas.microsoft.com/office/powerpoint/2010/main" val="1364728566"/>
+        <p14:creationId xmlns:p14="http://schemas.microsoft.com/office/powerpoint/2010/main" val="2975995"/>
       </p:ext>
     </p:extLst>
   </p:cSld>
@@ -5118,7 +5141,7 @@
           <p:cNvPr id="7" name="">
             <a:extLst xmlns:a="http://schemas.openxmlformats.org/drawingml/2006/main">
               <a:ext uri="{FF2B5EF4-FFF2-40B4-BE49-F238E27FC236}">
-                <a16:creationId xmlns:a16="http://schemas.microsoft.com/office/drawing/2014/main" id="{E7ADDFF8-CB97-4D13-8EAE-9B971B29BF06}"/>
+                <a16:creationId xmlns:a16="http://schemas.microsoft.com/office/drawing/2014/main" id="{A1F55C30-5525-4117-B759-DE2B1DDB22ED}"/>
               </a:ext>
             </a:extLst>
           </p:cNvPr>
@@ -5149,7 +5172,7 @@
           <p:cNvPr id="2" name="">
             <a:extLst xmlns:a="http://schemas.openxmlformats.org/drawingml/2006/main">
               <a:ext uri="{FF2B5EF4-FFF2-40B4-BE49-F238E27FC236}">
-                <a16:creationId xmlns:a16="http://schemas.microsoft.com/office/drawing/2014/main" id="{50E029E1-16DC-4234-9479-AC705F1F421D}"/>
+                <a16:creationId xmlns:a16="http://schemas.microsoft.com/office/drawing/2014/main" id="{4478B432-E21D-4783-AC7E-402D0AC04C83}"/>
               </a:ext>
             </a:extLst>
           </p:cNvPr>
@@ -5205,7 +5228,7 @@
           <p:cNvPr id="3" name="">
             <a:extLst xmlns:a="http://schemas.openxmlformats.org/drawingml/2006/main">
               <a:ext uri="{FF2B5EF4-FFF2-40B4-BE49-F238E27FC236}">
-                <a16:creationId xmlns:a16="http://schemas.microsoft.com/office/drawing/2014/main" id="{F26E2277-5C75-41F2-96D5-FE21F7F94A73}"/>
+                <a16:creationId xmlns:a16="http://schemas.microsoft.com/office/drawing/2014/main" id="{45DE5780-A162-42D5-A8AF-B98CF27B74B7}"/>
               </a:ext>
             </a:extLst>
           </p:cNvPr>
@@ -5677,7 +5700,7 @@
           <p:cNvPr id="5" name="">
             <a:extLst xmlns:a="http://schemas.openxmlformats.org/drawingml/2006/main">
               <a:ext uri="{FF2B5EF4-FFF2-40B4-BE49-F238E27FC236}">
-                <a16:creationId xmlns:a16="http://schemas.microsoft.com/office/drawing/2014/main" id="{EB23EEF6-F2D5-4137-B75D-0D43CBB19A25}"/>
+                <a16:creationId xmlns:a16="http://schemas.microsoft.com/office/drawing/2014/main" id="{23DD776F-243F-4F2E-AB8C-9DA2697BD50F}"/>
               </a:ext>
             </a:extLst>
           </p:cNvPr>
@@ -5733,7 +5756,7 @@
           <p:cNvPr id="6" name="">
             <a:extLst xmlns:a="http://schemas.openxmlformats.org/drawingml/2006/main">
               <a:ext uri="{FF2B5EF4-FFF2-40B4-BE49-F238E27FC236}">
-                <a16:creationId xmlns:a16="http://schemas.microsoft.com/office/drawing/2014/main" id="{7D85A863-C0B6-4F13-B8C0-2CE083A1BE8E}"/>
+                <a16:creationId xmlns:a16="http://schemas.microsoft.com/office/drawing/2014/main" id="{05B43177-901D-4273-8720-56F29A74C0A3}"/>
               </a:ext>
             </a:extLst>
           </p:cNvPr>
@@ -5787,7 +5810,7 @@
     </p:spTree>
     <p:extLst>
       <p:ext uri="{BB962C8B-B14F-4D97-AF65-F5344CB8AC3E}">
-        <p14:creationId xmlns:p14="http://schemas.microsoft.com/office/powerpoint/2010/main" val="1695007410"/>
+        <p14:creationId xmlns:p14="http://schemas.microsoft.com/office/powerpoint/2010/main" val="1679233575"/>
       </p:ext>
     </p:extLst>
   </p:cSld>
@@ -5811,7 +5834,7 @@
           <p:cNvPr id="13" name="">
             <a:extLst xmlns:a="http://schemas.openxmlformats.org/drawingml/2006/main">
               <a:ext uri="{FF2B5EF4-FFF2-40B4-BE49-F238E27FC236}">
-                <a16:creationId xmlns:a16="http://schemas.microsoft.com/office/drawing/2014/main" id="{C3794661-5C27-4CEF-BE1B-0A2AFAB77A14}"/>
+                <a16:creationId xmlns:a16="http://schemas.microsoft.com/office/drawing/2014/main" id="{81524F35-B36E-43E1-8755-B89F93790922}"/>
               </a:ext>
             </a:extLst>
           </p:cNvPr>
@@ -5842,7 +5865,7 @@
           <p:cNvPr id="2" name="">
             <a:extLst xmlns:a="http://schemas.openxmlformats.org/drawingml/2006/main">
               <a:ext uri="{FF2B5EF4-FFF2-40B4-BE49-F238E27FC236}">
-                <a16:creationId xmlns:a16="http://schemas.microsoft.com/office/drawing/2014/main" id="{2FE4A0A5-32C1-44DF-9BA0-1CA1276672A6}"/>
+                <a16:creationId xmlns:a16="http://schemas.microsoft.com/office/drawing/2014/main" id="{077EEEAF-41E3-4C0B-A933-A40B40AFFDD5}"/>
               </a:ext>
             </a:extLst>
           </p:cNvPr>
@@ -5898,7 +5921,7 @@
           <p:cNvPr id="3" name="">
             <a:extLst xmlns:a="http://schemas.openxmlformats.org/drawingml/2006/main">
               <a:ext uri="{FF2B5EF4-FFF2-40B4-BE49-F238E27FC236}">
-                <a16:creationId xmlns:a16="http://schemas.microsoft.com/office/drawing/2014/main" id="{971199CC-8763-45D7-8A23-F610259FDDAE}"/>
+                <a16:creationId xmlns:a16="http://schemas.microsoft.com/office/drawing/2014/main" id="{66F434BC-2D2F-44DC-A2B1-6CDF74841628}"/>
               </a:ext>
             </a:extLst>
           </p:cNvPr>
@@ -5954,7 +5977,7 @@
           <p:cNvPr id="4" name="">
             <a:extLst xmlns:a="http://schemas.openxmlformats.org/drawingml/2006/main">
               <a:ext uri="{FF2B5EF4-FFF2-40B4-BE49-F238E27FC236}">
-                <a16:creationId xmlns:a16="http://schemas.microsoft.com/office/drawing/2014/main" id="{435603D2-BA50-4E57-89AF-235DC18CB9AD}"/>
+                <a16:creationId xmlns:a16="http://schemas.microsoft.com/office/drawing/2014/main" id="{719748D6-57FB-4F24-8EC1-55879F317B2E}"/>
               </a:ext>
             </a:extLst>
           </p:cNvPr>
@@ -6010,7 +6033,7 @@
           <p:cNvPr id="5" name="">
             <a:extLst xmlns:a="http://schemas.openxmlformats.org/drawingml/2006/main">
               <a:ext uri="{FF2B5EF4-FFF2-40B4-BE49-F238E27FC236}">
-                <a16:creationId xmlns:a16="http://schemas.microsoft.com/office/drawing/2014/main" id="{F0BC13B1-4744-4E0F-8BE4-78363162C17D}"/>
+                <a16:creationId xmlns:a16="http://schemas.microsoft.com/office/drawing/2014/main" id="{5F0AEA91-253F-4B9F-B5E5-5E6F633C9D7B}"/>
               </a:ext>
             </a:extLst>
           </p:cNvPr>
@@ -6045,7 +6068,7 @@
           <p:cNvPr id="6" name="">
             <a:extLst xmlns:a="http://schemas.openxmlformats.org/drawingml/2006/main">
               <a:ext uri="{FF2B5EF4-FFF2-40B4-BE49-F238E27FC236}">
-                <a16:creationId xmlns:a16="http://schemas.microsoft.com/office/drawing/2014/main" id="{F82D3053-9472-4335-A0DF-FEA20E5A1E4B}"/>
+                <a16:creationId xmlns:a16="http://schemas.microsoft.com/office/drawing/2014/main" id="{65933E41-6669-4DD2-ADBB-734E4F04B8A6}"/>
               </a:ext>
             </a:extLst>
           </p:cNvPr>
@@ -6124,7 +6147,7 @@
           <p:cNvPr id="7" name="">
             <a:extLst xmlns:a="http://schemas.openxmlformats.org/drawingml/2006/main">
               <a:ext uri="{FF2B5EF4-FFF2-40B4-BE49-F238E27FC236}">
-                <a16:creationId xmlns:a16="http://schemas.microsoft.com/office/drawing/2014/main" id="{A4D40C97-8FF0-4EEA-A9B1-88B05577B60D}"/>
+                <a16:creationId xmlns:a16="http://schemas.microsoft.com/office/drawing/2014/main" id="{A18C90C8-AA23-4132-9306-DABA6A9CCD5E}"/>
               </a:ext>
             </a:extLst>
           </p:cNvPr>
@@ -6180,7 +6203,7 @@
           <p:cNvPr id="8" name="">
             <a:extLst xmlns:a="http://schemas.openxmlformats.org/drawingml/2006/main">
               <a:ext uri="{FF2B5EF4-FFF2-40B4-BE49-F238E27FC236}">
-                <a16:creationId xmlns:a16="http://schemas.microsoft.com/office/drawing/2014/main" id="{8EFBA162-CB80-490D-B42E-04A832B2731A}"/>
+                <a16:creationId xmlns:a16="http://schemas.microsoft.com/office/drawing/2014/main" id="{832CB9FF-0CBC-4C5D-9930-7988974AF103}"/>
               </a:ext>
             </a:extLst>
           </p:cNvPr>
@@ -6215,7 +6238,7 @@
           <p:cNvPr id="9" name="">
             <a:extLst xmlns:a="http://schemas.openxmlformats.org/drawingml/2006/main">
               <a:ext uri="{FF2B5EF4-FFF2-40B4-BE49-F238E27FC236}">
-                <a16:creationId xmlns:a16="http://schemas.microsoft.com/office/drawing/2014/main" id="{390EA72E-29B7-4F89-8D94-AA08B83A9DD8}"/>
+                <a16:creationId xmlns:a16="http://schemas.microsoft.com/office/drawing/2014/main" id="{333EF2E4-70B9-4BD8-A71C-CE8A522FB3EF}"/>
               </a:ext>
             </a:extLst>
           </p:cNvPr>
@@ -6294,7 +6317,7 @@
           <p:cNvPr id="10" name="">
             <a:extLst xmlns:a="http://schemas.openxmlformats.org/drawingml/2006/main">
               <a:ext uri="{FF2B5EF4-FFF2-40B4-BE49-F238E27FC236}">
-                <a16:creationId xmlns:a16="http://schemas.microsoft.com/office/drawing/2014/main" id="{F915A049-AEF6-43B6-B198-1EFA9CC66724}"/>
+                <a16:creationId xmlns:a16="http://schemas.microsoft.com/office/drawing/2014/main" id="{694F072C-D854-42C7-81F6-06D6F9A0D5A4}"/>
               </a:ext>
             </a:extLst>
           </p:cNvPr>
@@ -6350,7 +6373,7 @@
           <p:cNvPr id="11" name="">
             <a:extLst xmlns:a="http://schemas.openxmlformats.org/drawingml/2006/main">
               <a:ext uri="{FF2B5EF4-FFF2-40B4-BE49-F238E27FC236}">
-                <a16:creationId xmlns:a16="http://schemas.microsoft.com/office/drawing/2014/main" id="{5BF7704D-AB14-422E-AE76-1C4D878DCDCF}"/>
+                <a16:creationId xmlns:a16="http://schemas.microsoft.com/office/drawing/2014/main" id="{D92BE1FB-FFE0-499D-B591-C836E180A65B}"/>
               </a:ext>
             </a:extLst>
           </p:cNvPr>
@@ -6406,7 +6429,7 @@
           <p:cNvPr id="12" name="">
             <a:extLst xmlns:a="http://schemas.openxmlformats.org/drawingml/2006/main">
               <a:ext uri="{FF2B5EF4-FFF2-40B4-BE49-F238E27FC236}">
-                <a16:creationId xmlns:a16="http://schemas.microsoft.com/office/drawing/2014/main" id="{48B6C16A-852D-415E-889D-B76A8BA21260}"/>
+                <a16:creationId xmlns:a16="http://schemas.microsoft.com/office/drawing/2014/main" id="{67EB68B5-0539-4500-9015-A7CDF09A4412}"/>
               </a:ext>
             </a:extLst>
           </p:cNvPr>
@@ -6460,7 +6483,7 @@
     </p:spTree>
     <p:extLst>
       <p:ext uri="{BB962C8B-B14F-4D97-AF65-F5344CB8AC3E}">
-        <p14:creationId xmlns:p14="http://schemas.microsoft.com/office/powerpoint/2010/main" val="1328372982"/>
+        <p14:creationId xmlns:p14="http://schemas.microsoft.com/office/powerpoint/2010/main" val="1745393687"/>
       </p:ext>
     </p:extLst>
   </p:cSld>
@@ -6484,7 +6507,7 @@
           <p:cNvPr id="23" name="">
             <a:extLst xmlns:a="http://schemas.openxmlformats.org/drawingml/2006/main">
               <a:ext uri="{FF2B5EF4-FFF2-40B4-BE49-F238E27FC236}">
-                <a16:creationId xmlns:a16="http://schemas.microsoft.com/office/drawing/2014/main" id="{A42DDA78-48E8-4320-8F7B-BB5027F6CD1D}"/>
+                <a16:creationId xmlns:a16="http://schemas.microsoft.com/office/drawing/2014/main" id="{84078D10-5BC0-47E7-89FC-8495931E1F8B}"/>
               </a:ext>
             </a:extLst>
           </p:cNvPr>
@@ -6515,7 +6538,7 @@
           <p:cNvPr id="2" name="">
             <a:extLst xmlns:a="http://schemas.openxmlformats.org/drawingml/2006/main">
               <a:ext uri="{FF2B5EF4-FFF2-40B4-BE49-F238E27FC236}">
-                <a16:creationId xmlns:a16="http://schemas.microsoft.com/office/drawing/2014/main" id="{359509BA-2F4C-45CF-8390-9B2D9CA17FD9}"/>
+                <a16:creationId xmlns:a16="http://schemas.microsoft.com/office/drawing/2014/main" id="{13FABEFA-E66B-49A3-A283-08FD8E1724A7}"/>
               </a:ext>
             </a:extLst>
           </p:cNvPr>
@@ -6571,7 +6594,7 @@
           <p:cNvPr id="3" name="">
             <a:extLst xmlns:a="http://schemas.openxmlformats.org/drawingml/2006/main">
               <a:ext uri="{FF2B5EF4-FFF2-40B4-BE49-F238E27FC236}">
-                <a16:creationId xmlns:a16="http://schemas.microsoft.com/office/drawing/2014/main" id="{3CFD39A5-5E09-43C7-B6CA-168728B6D198}"/>
+                <a16:creationId xmlns:a16="http://schemas.microsoft.com/office/drawing/2014/main" id="{8A9684E5-5548-4E48-A851-E5A4D350D624}"/>
               </a:ext>
             </a:extLst>
           </p:cNvPr>
@@ -6627,7 +6650,7 @@
           <p:cNvPr id="4" name="">
             <a:extLst xmlns:a="http://schemas.openxmlformats.org/drawingml/2006/main">
               <a:ext uri="{FF2B5EF4-FFF2-40B4-BE49-F238E27FC236}">
-                <a16:creationId xmlns:a16="http://schemas.microsoft.com/office/drawing/2014/main" id="{098C9AC5-B9DB-4416-AEEF-E98482DE1AFE}"/>
+                <a16:creationId xmlns:a16="http://schemas.microsoft.com/office/drawing/2014/main" id="{F4593A34-4489-4179-9990-F510661A48A0}"/>
               </a:ext>
             </a:extLst>
           </p:cNvPr>
@@ -6683,7 +6706,7 @@
           <p:cNvPr id="5" name="">
             <a:extLst xmlns:a="http://schemas.openxmlformats.org/drawingml/2006/main">
               <a:ext uri="{FF2B5EF4-FFF2-40B4-BE49-F238E27FC236}">
-                <a16:creationId xmlns:a16="http://schemas.microsoft.com/office/drawing/2014/main" id="{D6CC7E69-2566-4D9B-AFB3-98B489B2812B}"/>
+                <a16:creationId xmlns:a16="http://schemas.microsoft.com/office/drawing/2014/main" id="{E87F7233-1CE7-4DAF-906E-CE7C6E84643B}"/>
               </a:ext>
             </a:extLst>
           </p:cNvPr>
@@ -6739,7 +6762,7 @@
           <p:cNvPr id="6" name="">
             <a:extLst xmlns:a="http://schemas.openxmlformats.org/drawingml/2006/main">
               <a:ext uri="{FF2B5EF4-FFF2-40B4-BE49-F238E27FC236}">
-                <a16:creationId xmlns:a16="http://schemas.microsoft.com/office/drawing/2014/main" id="{90EEE5AD-832F-463C-A799-CC75C13F377B}"/>
+                <a16:creationId xmlns:a16="http://schemas.microsoft.com/office/drawing/2014/main" id="{6F50C347-1A98-4036-A7C5-FBC28DBB8269}"/>
               </a:ext>
             </a:extLst>
           </p:cNvPr>
@@ -6972,7 +6995,7 @@
           <p:cNvPr id="16" name="">
             <a:extLst xmlns:a="http://schemas.openxmlformats.org/drawingml/2006/main">
               <a:ext uri="{FF2B5EF4-FFF2-40B4-BE49-F238E27FC236}">
-                <a16:creationId xmlns:a16="http://schemas.microsoft.com/office/drawing/2014/main" id="{D25AF242-D020-4529-BCAB-DD43FBD291F8}"/>
+                <a16:creationId xmlns:a16="http://schemas.microsoft.com/office/drawing/2014/main" id="{DBD1152A-08FA-47C3-ACB4-A14499F6CE42}"/>
               </a:ext>
             </a:extLst>
           </p:cNvPr>
@@ -7005,7 +7028,7 @@
           <p:cNvPr id="17" name="">
             <a:extLst xmlns:a="http://schemas.openxmlformats.org/drawingml/2006/main">
               <a:ext uri="{FF2B5EF4-FFF2-40B4-BE49-F238E27FC236}">
-                <a16:creationId xmlns:a16="http://schemas.microsoft.com/office/drawing/2014/main" id="{B63CF121-3A7C-4243-91BF-63B48F71D80A}"/>
+                <a16:creationId xmlns:a16="http://schemas.microsoft.com/office/drawing/2014/main" id="{7EB0CBBA-9C5A-4418-87A6-507E2B7C349E}"/>
               </a:ext>
             </a:extLst>
           </p:cNvPr>
@@ -7038,7 +7061,7 @@
           <p:cNvPr id="18" name="">
             <a:extLst xmlns:a="http://schemas.openxmlformats.org/drawingml/2006/main">
               <a:ext uri="{FF2B5EF4-FFF2-40B4-BE49-F238E27FC236}">
-                <a16:creationId xmlns:a16="http://schemas.microsoft.com/office/drawing/2014/main" id="{B9F4F680-9DF0-41F0-B797-830404699391}"/>
+                <a16:creationId xmlns:a16="http://schemas.microsoft.com/office/drawing/2014/main" id="{E4F6B1A1-0B77-4821-8BE5-74A94376BA37}"/>
               </a:ext>
             </a:extLst>
           </p:cNvPr>
@@ -7071,7 +7094,7 @@
           <p:cNvPr id="19" name="">
             <a:extLst xmlns:a="http://schemas.openxmlformats.org/drawingml/2006/main">
               <a:ext uri="{FF2B5EF4-FFF2-40B4-BE49-F238E27FC236}">
-                <a16:creationId xmlns:a16="http://schemas.microsoft.com/office/drawing/2014/main" id="{EAB7B738-90A4-41E5-9087-5E49362474C3}"/>
+                <a16:creationId xmlns:a16="http://schemas.microsoft.com/office/drawing/2014/main" id="{EE31CE7A-B293-4FCB-A65E-028712B7970D}"/>
               </a:ext>
             </a:extLst>
           </p:cNvPr>
@@ -7104,7 +7127,7 @@
           <p:cNvPr id="20" name="">
             <a:extLst xmlns:a="http://schemas.openxmlformats.org/drawingml/2006/main">
               <a:ext uri="{FF2B5EF4-FFF2-40B4-BE49-F238E27FC236}">
-                <a16:creationId xmlns:a16="http://schemas.microsoft.com/office/drawing/2014/main" id="{E54D39B1-FC4D-4D68-B8D7-676AA3E0400E}"/>
+                <a16:creationId xmlns:a16="http://schemas.microsoft.com/office/drawing/2014/main" id="{B530987B-3CF2-4964-A3B1-BFB2EECAC9EB}"/>
               </a:ext>
             </a:extLst>
           </p:cNvPr>
@@ -7137,7 +7160,7 @@
           <p:cNvPr id="21" name="">
             <a:extLst xmlns:a="http://schemas.openxmlformats.org/drawingml/2006/main">
               <a:ext uri="{FF2B5EF4-FFF2-40B4-BE49-F238E27FC236}">
-                <a16:creationId xmlns:a16="http://schemas.microsoft.com/office/drawing/2014/main" id="{57A0480D-433F-4F71-A2E8-40F367B8DC9F}"/>
+                <a16:creationId xmlns:a16="http://schemas.microsoft.com/office/drawing/2014/main" id="{16C7BC70-F71C-4724-B139-4821A94DE8C2}"/>
               </a:ext>
             </a:extLst>
           </p:cNvPr>
@@ -7170,7 +7193,7 @@
           <p:cNvPr id="22" name="">
             <a:extLst xmlns:a="http://schemas.openxmlformats.org/drawingml/2006/main">
               <a:ext uri="{FF2B5EF4-FFF2-40B4-BE49-F238E27FC236}">
-                <a16:creationId xmlns:a16="http://schemas.microsoft.com/office/drawing/2014/main" id="{65C961A1-4ED3-44E5-B18D-7D05782613E2}"/>
+                <a16:creationId xmlns:a16="http://schemas.microsoft.com/office/drawing/2014/main" id="{01BC328F-8B51-49EF-A6FF-99967FE3852D}"/>
               </a:ext>
             </a:extLst>
           </p:cNvPr>
@@ -7224,7 +7247,7 @@
     </p:spTree>
     <p:extLst>
       <p:ext uri="{BB962C8B-B14F-4D97-AF65-F5344CB8AC3E}">
-        <p14:creationId xmlns:p14="http://schemas.microsoft.com/office/powerpoint/2010/main" val="1402730115"/>
+        <p14:creationId xmlns:p14="http://schemas.microsoft.com/office/powerpoint/2010/main" val="1897070129"/>
       </p:ext>
     </p:extLst>
   </p:cSld>
@@ -7248,7 +7271,7 @@
           <p:cNvPr id="21" name="">
             <a:extLst xmlns:a="http://schemas.openxmlformats.org/drawingml/2006/main">
               <a:ext uri="{FF2B5EF4-FFF2-40B4-BE49-F238E27FC236}">
-                <a16:creationId xmlns:a16="http://schemas.microsoft.com/office/drawing/2014/main" id="{31C439CB-5096-48C2-B7B0-8234D86AC2A0}"/>
+                <a16:creationId xmlns:a16="http://schemas.microsoft.com/office/drawing/2014/main" id="{2BEE2628-279E-43E5-A6A2-284B771ADC6F}"/>
               </a:ext>
             </a:extLst>
           </p:cNvPr>
@@ -7279,7 +7302,7 @@
           <p:cNvPr id="2" name="">
             <a:extLst xmlns:a="http://schemas.openxmlformats.org/drawingml/2006/main">
               <a:ext uri="{FF2B5EF4-FFF2-40B4-BE49-F238E27FC236}">
-                <a16:creationId xmlns:a16="http://schemas.microsoft.com/office/drawing/2014/main" id="{B272F488-F2F1-4E1F-B53D-9106073DDBFE}"/>
+                <a16:creationId xmlns:a16="http://schemas.microsoft.com/office/drawing/2014/main" id="{BA31BFC6-038C-41C9-AEE4-B361B6435AD9}"/>
               </a:ext>
             </a:extLst>
           </p:cNvPr>
@@ -7335,7 +7358,7 @@
           <p:cNvPr id="3" name="">
             <a:extLst xmlns:a="http://schemas.openxmlformats.org/drawingml/2006/main">
               <a:ext uri="{FF2B5EF4-FFF2-40B4-BE49-F238E27FC236}">
-                <a16:creationId xmlns:a16="http://schemas.microsoft.com/office/drawing/2014/main" id="{51183455-62ED-497A-970A-8F707869DFA9}"/>
+                <a16:creationId xmlns:a16="http://schemas.microsoft.com/office/drawing/2014/main" id="{3EA2F002-05F5-49E7-80B2-68B02457C21B}"/>
               </a:ext>
             </a:extLst>
           </p:cNvPr>
@@ -7391,7 +7414,7 @@
           <p:cNvPr id="4" name="">
             <a:extLst xmlns:a="http://schemas.openxmlformats.org/drawingml/2006/main">
               <a:ext uri="{FF2B5EF4-FFF2-40B4-BE49-F238E27FC236}">
-                <a16:creationId xmlns:a16="http://schemas.microsoft.com/office/drawing/2014/main" id="{68F399FB-C5FE-4ADF-822F-9BF71934F6C3}"/>
+                <a16:creationId xmlns:a16="http://schemas.microsoft.com/office/drawing/2014/main" id="{8D34129D-87FB-4FEA-BF62-ED5C89FB6493}"/>
               </a:ext>
             </a:extLst>
           </p:cNvPr>
@@ -7447,7 +7470,7 @@
           <p:cNvPr id="5" name="">
             <a:extLst xmlns:a="http://schemas.openxmlformats.org/drawingml/2006/main">
               <a:ext uri="{FF2B5EF4-FFF2-40B4-BE49-F238E27FC236}">
-                <a16:creationId xmlns:a16="http://schemas.microsoft.com/office/drawing/2014/main" id="{278054EE-A96C-4438-9557-D507F180C5F5}"/>
+                <a16:creationId xmlns:a16="http://schemas.microsoft.com/office/drawing/2014/main" id="{3FE7BE0E-6F0A-439A-BEE5-8923272981C6}"/>
               </a:ext>
             </a:extLst>
           </p:cNvPr>
@@ -7482,7 +7505,7 @@
           <p:cNvPr id="6" name="">
             <a:extLst xmlns:a="http://schemas.openxmlformats.org/drawingml/2006/main">
               <a:ext uri="{FF2B5EF4-FFF2-40B4-BE49-F238E27FC236}">
-                <a16:creationId xmlns:a16="http://schemas.microsoft.com/office/drawing/2014/main" id="{1CAD07B9-EA75-44E4-B531-5F84C94E9412}"/>
+                <a16:creationId xmlns:a16="http://schemas.microsoft.com/office/drawing/2014/main" id="{A11B949D-0A4E-4367-BD9A-D45670F0DE4A}"/>
               </a:ext>
             </a:extLst>
           </p:cNvPr>
@@ -7538,7 +7561,7 @@
           <p:cNvPr id="7" name="">
             <a:extLst xmlns:a="http://schemas.openxmlformats.org/drawingml/2006/main">
               <a:ext uri="{FF2B5EF4-FFF2-40B4-BE49-F238E27FC236}">
-                <a16:creationId xmlns:a16="http://schemas.microsoft.com/office/drawing/2014/main" id="{FCC16499-413E-4887-B82C-7D73B149135D}"/>
+                <a16:creationId xmlns:a16="http://schemas.microsoft.com/office/drawing/2014/main" id="{E2198B35-B0A5-4CA3-8B67-15C650EC6C43}"/>
               </a:ext>
             </a:extLst>
           </p:cNvPr>
@@ -7594,7 +7617,7 @@
           <p:cNvPr id="8" name="">
             <a:extLst xmlns:a="http://schemas.openxmlformats.org/drawingml/2006/main">
               <a:ext uri="{FF2B5EF4-FFF2-40B4-BE49-F238E27FC236}">
-                <a16:creationId xmlns:a16="http://schemas.microsoft.com/office/drawing/2014/main" id="{C5B77650-8110-4C68-A2BE-C594E2052C3E}"/>
+                <a16:creationId xmlns:a16="http://schemas.microsoft.com/office/drawing/2014/main" id="{7769F910-8F86-4D32-9D58-7BC38FBC99FB}"/>
               </a:ext>
             </a:extLst>
           </p:cNvPr>
@@ -7650,7 +7673,7 @@
           <p:cNvPr id="9" name="">
             <a:extLst xmlns:a="http://schemas.openxmlformats.org/drawingml/2006/main">
               <a:ext uri="{FF2B5EF4-FFF2-40B4-BE49-F238E27FC236}">
-                <a16:creationId xmlns:a16="http://schemas.microsoft.com/office/drawing/2014/main" id="{4A82BEC8-5455-4FFB-878E-4BFC898D9D6E}"/>
+                <a16:creationId xmlns:a16="http://schemas.microsoft.com/office/drawing/2014/main" id="{2B2A75AF-E6E9-432E-B09B-833161B3C350}"/>
               </a:ext>
             </a:extLst>
           </p:cNvPr>
@@ -7685,7 +7708,7 @@
           <p:cNvPr id="10" name="">
             <a:extLst xmlns:a="http://schemas.openxmlformats.org/drawingml/2006/main">
               <a:ext uri="{FF2B5EF4-FFF2-40B4-BE49-F238E27FC236}">
-                <a16:creationId xmlns:a16="http://schemas.microsoft.com/office/drawing/2014/main" id="{134D3367-DC74-4C41-BE5A-7524D616A34D}"/>
+                <a16:creationId xmlns:a16="http://schemas.microsoft.com/office/drawing/2014/main" id="{750BB6C8-5B36-4EA7-BB01-A406EE248C08}"/>
               </a:ext>
             </a:extLst>
           </p:cNvPr>
@@ -7741,7 +7764,7 @@
           <p:cNvPr id="11" name="">
             <a:extLst xmlns:a="http://schemas.openxmlformats.org/drawingml/2006/main">
               <a:ext uri="{FF2B5EF4-FFF2-40B4-BE49-F238E27FC236}">
-                <a16:creationId xmlns:a16="http://schemas.microsoft.com/office/drawing/2014/main" id="{F63CD314-1599-40F9-83C0-F2B53B1E32BD}"/>
+                <a16:creationId xmlns:a16="http://schemas.microsoft.com/office/drawing/2014/main" id="{D3A80DF7-CA19-41CA-A4B2-A2731933CD3C}"/>
               </a:ext>
             </a:extLst>
           </p:cNvPr>
@@ -7797,7 +7820,7 @@
           <p:cNvPr id="12" name="">
             <a:extLst xmlns:a="http://schemas.openxmlformats.org/drawingml/2006/main">
               <a:ext uri="{FF2B5EF4-FFF2-40B4-BE49-F238E27FC236}">
-                <a16:creationId xmlns:a16="http://schemas.microsoft.com/office/drawing/2014/main" id="{EC5E38B9-4F99-4433-BC03-2C5001C430FA}"/>
+                <a16:creationId xmlns:a16="http://schemas.microsoft.com/office/drawing/2014/main" id="{FAE712F7-5B02-4288-9C05-41E3325CDDAD}"/>
               </a:ext>
             </a:extLst>
           </p:cNvPr>
@@ -7853,7 +7876,7 @@
           <p:cNvPr id="13" name="">
             <a:extLst xmlns:a="http://schemas.openxmlformats.org/drawingml/2006/main">
               <a:ext uri="{FF2B5EF4-FFF2-40B4-BE49-F238E27FC236}">
-                <a16:creationId xmlns:a16="http://schemas.microsoft.com/office/drawing/2014/main" id="{97778695-7971-49E4-9F8A-A60EF10CF61A}"/>
+                <a16:creationId xmlns:a16="http://schemas.microsoft.com/office/drawing/2014/main" id="{557E22C8-F511-491A-9119-CC159C08069D}"/>
               </a:ext>
             </a:extLst>
           </p:cNvPr>
@@ -7888,7 +7911,7 @@
           <p:cNvPr id="14" name="">
             <a:extLst xmlns:a="http://schemas.openxmlformats.org/drawingml/2006/main">
               <a:ext uri="{FF2B5EF4-FFF2-40B4-BE49-F238E27FC236}">
-                <a16:creationId xmlns:a16="http://schemas.microsoft.com/office/drawing/2014/main" id="{2ACAA429-104B-4D31-891F-D0DB214F1B0D}"/>
+                <a16:creationId xmlns:a16="http://schemas.microsoft.com/office/drawing/2014/main" id="{B5CF56F3-D860-4F7B-87E0-853E9B594A3E}"/>
               </a:ext>
             </a:extLst>
           </p:cNvPr>
@@ -7944,7 +7967,7 @@
           <p:cNvPr id="15" name="">
             <a:extLst xmlns:a="http://schemas.openxmlformats.org/drawingml/2006/main">
               <a:ext uri="{FF2B5EF4-FFF2-40B4-BE49-F238E27FC236}">
-                <a16:creationId xmlns:a16="http://schemas.microsoft.com/office/drawing/2014/main" id="{64341345-92C0-48E8-A582-BDA483D3B252}"/>
+                <a16:creationId xmlns:a16="http://schemas.microsoft.com/office/drawing/2014/main" id="{7955058F-2A25-460D-B0DB-D1A0C03072F8}"/>
               </a:ext>
             </a:extLst>
           </p:cNvPr>
@@ -8000,7 +8023,7 @@
           <p:cNvPr id="16" name="">
             <a:extLst xmlns:a="http://schemas.openxmlformats.org/drawingml/2006/main">
               <a:ext uri="{FF2B5EF4-FFF2-40B4-BE49-F238E27FC236}">
-                <a16:creationId xmlns:a16="http://schemas.microsoft.com/office/drawing/2014/main" id="{702CCDA3-4041-491B-BE2D-D9C80A4203F6}"/>
+                <a16:creationId xmlns:a16="http://schemas.microsoft.com/office/drawing/2014/main" id="{3863DD69-4BB5-411A-9F08-033A2A9920D3}"/>
               </a:ext>
             </a:extLst>
           </p:cNvPr>
@@ -8056,7 +8079,7 @@
           <p:cNvPr id="17" name="">
             <a:extLst xmlns:a="http://schemas.openxmlformats.org/drawingml/2006/main">
               <a:ext uri="{FF2B5EF4-FFF2-40B4-BE49-F238E27FC236}">
-                <a16:creationId xmlns:a16="http://schemas.microsoft.com/office/drawing/2014/main" id="{294A13A1-BD50-4C28-B9E7-84034F83A17F}"/>
+                <a16:creationId xmlns:a16="http://schemas.microsoft.com/office/drawing/2014/main" id="{DEA44914-30E3-41C3-B799-7D5B4159A33C}"/>
               </a:ext>
             </a:extLst>
           </p:cNvPr>
@@ -8091,7 +8114,7 @@
           <p:cNvPr id="18" name="">
             <a:extLst xmlns:a="http://schemas.openxmlformats.org/drawingml/2006/main">
               <a:ext uri="{FF2B5EF4-FFF2-40B4-BE49-F238E27FC236}">
-                <a16:creationId xmlns:a16="http://schemas.microsoft.com/office/drawing/2014/main" id="{30703935-286D-421D-8AA1-04D649F8A77D}"/>
+                <a16:creationId xmlns:a16="http://schemas.microsoft.com/office/drawing/2014/main" id="{49A35148-2548-463F-995A-BE5103AEB498}"/>
               </a:ext>
             </a:extLst>
           </p:cNvPr>
@@ -8147,7 +8170,7 @@
           <p:cNvPr id="19" name="">
             <a:extLst xmlns:a="http://schemas.openxmlformats.org/drawingml/2006/main">
               <a:ext uri="{FF2B5EF4-FFF2-40B4-BE49-F238E27FC236}">
-                <a16:creationId xmlns:a16="http://schemas.microsoft.com/office/drawing/2014/main" id="{BD55FFEB-7BBE-43A6-B711-794341E70427}"/>
+                <a16:creationId xmlns:a16="http://schemas.microsoft.com/office/drawing/2014/main" id="{921C0BDF-10B0-4B91-AD2A-E5D2C866D1AE}"/>
               </a:ext>
             </a:extLst>
           </p:cNvPr>
@@ -8203,7 +8226,7 @@
           <p:cNvPr id="20" name="">
             <a:extLst xmlns:a="http://schemas.openxmlformats.org/drawingml/2006/main">
               <a:ext uri="{FF2B5EF4-FFF2-40B4-BE49-F238E27FC236}">
-                <a16:creationId xmlns:a16="http://schemas.microsoft.com/office/drawing/2014/main" id="{3CBB3F3D-E328-44CE-A84D-D82F48DE75DA}"/>
+                <a16:creationId xmlns:a16="http://schemas.microsoft.com/office/drawing/2014/main" id="{0C1C1E47-5451-4D4A-8B0B-5C0706C00F3E}"/>
               </a:ext>
             </a:extLst>
           </p:cNvPr>
@@ -8257,7 +8280,7 @@
     </p:spTree>
     <p:extLst>
       <p:ext uri="{BB962C8B-B14F-4D97-AF65-F5344CB8AC3E}">
-        <p14:creationId xmlns:p14="http://schemas.microsoft.com/office/powerpoint/2010/main" val="1531166814"/>
+        <p14:creationId xmlns:p14="http://schemas.microsoft.com/office/powerpoint/2010/main" val="1279908097"/>
       </p:ext>
     </p:extLst>
   </p:cSld>
@@ -8281,7 +8304,7 @@
           <p:cNvPr id="12" name="">
             <a:extLst xmlns:a="http://schemas.openxmlformats.org/drawingml/2006/main">
               <a:ext uri="{FF2B5EF4-FFF2-40B4-BE49-F238E27FC236}">
-                <a16:creationId xmlns:a16="http://schemas.microsoft.com/office/drawing/2014/main" id="{A1D9C6C4-FBC8-428C-B323-50059030295E}"/>
+                <a16:creationId xmlns:a16="http://schemas.microsoft.com/office/drawing/2014/main" id="{0B78563C-22FB-4267-A985-E1D8A772BBB3}"/>
               </a:ext>
             </a:extLst>
           </p:cNvPr>
@@ -8312,7 +8335,7 @@
           <p:cNvPr id="2" name="">
             <a:extLst xmlns:a="http://schemas.openxmlformats.org/drawingml/2006/main">
               <a:ext uri="{FF2B5EF4-FFF2-40B4-BE49-F238E27FC236}">
-                <a16:creationId xmlns:a16="http://schemas.microsoft.com/office/drawing/2014/main" id="{1F0A9667-D925-4051-92DF-C6BC4202D3C7}"/>
+                <a16:creationId xmlns:a16="http://schemas.microsoft.com/office/drawing/2014/main" id="{9B5CDA9C-F43D-4785-897C-33B0645F9147}"/>
               </a:ext>
             </a:extLst>
           </p:cNvPr>
@@ -8368,7 +8391,7 @@
           <p:cNvPr id="3" name="">
             <a:extLst xmlns:a="http://schemas.openxmlformats.org/drawingml/2006/main">
               <a:ext uri="{FF2B5EF4-FFF2-40B4-BE49-F238E27FC236}">
-                <a16:creationId xmlns:a16="http://schemas.microsoft.com/office/drawing/2014/main" id="{07E72DA8-4550-4F0C-96B3-2B8E5CDE32F3}"/>
+                <a16:creationId xmlns:a16="http://schemas.microsoft.com/office/drawing/2014/main" id="{4ACC59F0-5CF8-4593-880B-D992F4F5DE6A}"/>
               </a:ext>
             </a:extLst>
           </p:cNvPr>
@@ -8874,7 +8897,7 @@
           <p:cNvPr id="5" name="">
             <a:extLst xmlns:a="http://schemas.openxmlformats.org/drawingml/2006/main">
               <a:ext uri="{FF2B5EF4-FFF2-40B4-BE49-F238E27FC236}">
-                <a16:creationId xmlns:a16="http://schemas.microsoft.com/office/drawing/2014/main" id="{E6C7597C-F94C-41AD-A7F2-10692D7D1B4E}"/>
+                <a16:creationId xmlns:a16="http://schemas.microsoft.com/office/drawing/2014/main" id="{95344540-F75F-426C-9527-64B01C4DA48F}"/>
               </a:ext>
             </a:extLst>
           </p:cNvPr>
@@ -8909,7 +8932,7 @@
           <p:cNvPr id="6" name="">
             <a:extLst xmlns:a="http://schemas.openxmlformats.org/drawingml/2006/main">
               <a:ext uri="{FF2B5EF4-FFF2-40B4-BE49-F238E27FC236}">
-                <a16:creationId xmlns:a16="http://schemas.microsoft.com/office/drawing/2014/main" id="{993533FD-4968-4ADD-BD47-3412135A70FC}"/>
+                <a16:creationId xmlns:a16="http://schemas.microsoft.com/office/drawing/2014/main" id="{FE1A8A45-686C-40C1-B234-288ADCDB5C29}"/>
               </a:ext>
             </a:extLst>
           </p:cNvPr>
@@ -8965,7 +8988,7 @@
           <p:cNvPr id="7" name="">
             <a:extLst xmlns:a="http://schemas.openxmlformats.org/drawingml/2006/main">
               <a:ext uri="{FF2B5EF4-FFF2-40B4-BE49-F238E27FC236}">
-                <a16:creationId xmlns:a16="http://schemas.microsoft.com/office/drawing/2014/main" id="{F6C3A7C5-5226-478F-8A88-B8E7805EB262}"/>
+                <a16:creationId xmlns:a16="http://schemas.microsoft.com/office/drawing/2014/main" id="{090D5369-1196-4017-8351-33D7A7AFE915}"/>
               </a:ext>
             </a:extLst>
           </p:cNvPr>
@@ -9021,7 +9044,7 @@
           <p:cNvPr id="8" name="">
             <a:extLst xmlns:a="http://schemas.openxmlformats.org/drawingml/2006/main">
               <a:ext uri="{FF2B5EF4-FFF2-40B4-BE49-F238E27FC236}">
-                <a16:creationId xmlns:a16="http://schemas.microsoft.com/office/drawing/2014/main" id="{88701B5B-FAAB-446B-9853-AF4E3CEACCBF}"/>
+                <a16:creationId xmlns:a16="http://schemas.microsoft.com/office/drawing/2014/main" id="{AD3DC169-EDB6-4626-8CB0-72B6FFB795B7}"/>
               </a:ext>
             </a:extLst>
           </p:cNvPr>
@@ -9056,7 +9079,7 @@
           <p:cNvPr id="9" name="">
             <a:extLst xmlns:a="http://schemas.openxmlformats.org/drawingml/2006/main">
               <a:ext uri="{FF2B5EF4-FFF2-40B4-BE49-F238E27FC236}">
-                <a16:creationId xmlns:a16="http://schemas.microsoft.com/office/drawing/2014/main" id="{5B51A3A7-3142-443F-AFED-5E5CB32EFE5E}"/>
+                <a16:creationId xmlns:a16="http://schemas.microsoft.com/office/drawing/2014/main" id="{F181AE5A-D3DF-4AB6-8ED1-2DB2F376A09B}"/>
               </a:ext>
             </a:extLst>
           </p:cNvPr>
@@ -9112,7 +9135,7 @@
           <p:cNvPr id="10" name="">
             <a:extLst xmlns:a="http://schemas.openxmlformats.org/drawingml/2006/main">
               <a:ext uri="{FF2B5EF4-FFF2-40B4-BE49-F238E27FC236}">
-                <a16:creationId xmlns:a16="http://schemas.microsoft.com/office/drawing/2014/main" id="{42A19120-979A-4182-A6D1-EAC4C1C4AE8B}"/>
+                <a16:creationId xmlns:a16="http://schemas.microsoft.com/office/drawing/2014/main" id="{75A0CC0E-88D9-4C04-8188-8B9FBF70A071}"/>
               </a:ext>
             </a:extLst>
           </p:cNvPr>
@@ -9168,7 +9191,7 @@
           <p:cNvPr id="11" name="">
             <a:extLst xmlns:a="http://schemas.openxmlformats.org/drawingml/2006/main">
               <a:ext uri="{FF2B5EF4-FFF2-40B4-BE49-F238E27FC236}">
-                <a16:creationId xmlns:a16="http://schemas.microsoft.com/office/drawing/2014/main" id="{B40AFCFC-44BE-49A7-B214-460874596EE1}"/>
+                <a16:creationId xmlns:a16="http://schemas.microsoft.com/office/drawing/2014/main" id="{34D31060-1B51-4C34-A6B8-0E805A5BB3C5}"/>
               </a:ext>
             </a:extLst>
           </p:cNvPr>
@@ -9222,7 +9245,7 @@
     </p:spTree>
     <p:extLst>
       <p:ext uri="{BB962C8B-B14F-4D97-AF65-F5344CB8AC3E}">
-        <p14:creationId xmlns:p14="http://schemas.microsoft.com/office/powerpoint/2010/main" val="1562727851"/>
+        <p14:creationId xmlns:p14="http://schemas.microsoft.com/office/powerpoint/2010/main" val="1643460280"/>
       </p:ext>
     </p:extLst>
   </p:cSld>
@@ -9246,7 +9269,7 @@
           <p:cNvPr id="6" name="">
             <a:extLst xmlns:a="http://schemas.openxmlformats.org/drawingml/2006/main">
               <a:ext uri="{FF2B5EF4-FFF2-40B4-BE49-F238E27FC236}">
-                <a16:creationId xmlns:a16="http://schemas.microsoft.com/office/drawing/2014/main" id="{25C27CFA-AB32-4B7B-B9A5-2C82A137DB27}"/>
+                <a16:creationId xmlns:a16="http://schemas.microsoft.com/office/drawing/2014/main" id="{CE0F9111-8A0A-4395-922D-0DBCBC04DB4D}"/>
               </a:ext>
             </a:extLst>
           </p:cNvPr>
@@ -9277,7 +9300,7 @@
           <p:cNvPr id="2" name="">
             <a:extLst xmlns:a="http://schemas.openxmlformats.org/drawingml/2006/main">
               <a:ext uri="{FF2B5EF4-FFF2-40B4-BE49-F238E27FC236}">
-                <a16:creationId xmlns:a16="http://schemas.microsoft.com/office/drawing/2014/main" id="{D4078617-8ED9-419F-A8E2-2013B3D6430B}"/>
+                <a16:creationId xmlns:a16="http://schemas.microsoft.com/office/drawing/2014/main" id="{5A1799C8-5C36-4B70-8751-10CD11B58643}"/>
               </a:ext>
             </a:extLst>
           </p:cNvPr>
@@ -9333,7 +9356,7 @@
           <p:cNvPr id="3" name="">
             <a:extLst xmlns:a="http://schemas.openxmlformats.org/drawingml/2006/main">
               <a:ext uri="{FF2B5EF4-FFF2-40B4-BE49-F238E27FC236}">
-                <a16:creationId xmlns:a16="http://schemas.microsoft.com/office/drawing/2014/main" id="{445ADA67-8051-48DB-99F4-11ED52CEC302}"/>
+                <a16:creationId xmlns:a16="http://schemas.microsoft.com/office/drawing/2014/main" id="{531D9F5A-E309-4350-98D1-591FD8A8AD5E}"/>
               </a:ext>
             </a:extLst>
           </p:cNvPr>
@@ -9393,7 +9416,7 @@
           <p:nvPr/>
         </p:nvPicPr>
         <p:blipFill>
-          <a:blip xmlns:r="http://schemas.openxmlformats.org/officeDocument/2006/relationships" xmlns:a="http://schemas.openxmlformats.org/drawingml/2006/main" r:embed="Rb154d5f5ca694326"/>
+          <a:blip xmlns:r="http://schemas.openxmlformats.org/officeDocument/2006/relationships" xmlns:a="http://schemas.openxmlformats.org/drawingml/2006/main" r:embed="R2afbd4057f104a22"/>
           <a:stretch xmlns:a="http://schemas.openxmlformats.org/drawingml/2006/main"/>
         </p:blipFill>
         <p:spPr>
@@ -9411,7 +9434,7 @@
           <p:cNvPr id="5" name="">
             <a:extLst xmlns:a="http://schemas.openxmlformats.org/drawingml/2006/main">
               <a:ext uri="{FF2B5EF4-FFF2-40B4-BE49-F238E27FC236}">
-                <a16:creationId xmlns:a16="http://schemas.microsoft.com/office/drawing/2014/main" id="{1AEAA153-AE9B-4E9F-AAF3-6783B9401B43}"/>
+                <a16:creationId xmlns:a16="http://schemas.microsoft.com/office/drawing/2014/main" id="{89CFDB6C-AEB4-411A-868B-BE0F0786D2B3}"/>
               </a:ext>
             </a:extLst>
           </p:cNvPr>
@@ -9465,7 +9488,7 @@
     </p:spTree>
     <p:extLst>
       <p:ext uri="{BB962C8B-B14F-4D97-AF65-F5344CB8AC3E}">
-        <p14:creationId xmlns:p14="http://schemas.microsoft.com/office/powerpoint/2010/main" val="1942410730"/>
+        <p14:creationId xmlns:p14="http://schemas.microsoft.com/office/powerpoint/2010/main" val="1751962506"/>
       </p:ext>
     </p:extLst>
   </p:cSld>
@@ -9489,7 +9512,7 @@
           <p:cNvPr id="15" name="">
             <a:extLst xmlns:a="http://schemas.openxmlformats.org/drawingml/2006/main">
               <a:ext uri="{FF2B5EF4-FFF2-40B4-BE49-F238E27FC236}">
-                <a16:creationId xmlns:a16="http://schemas.microsoft.com/office/drawing/2014/main" id="{D9ED23EE-AE59-437F-940D-58F19C83A387}"/>
+                <a16:creationId xmlns:a16="http://schemas.microsoft.com/office/drawing/2014/main" id="{F7599E72-AA25-4308-A415-9D1197EEDFC4}"/>
               </a:ext>
             </a:extLst>
           </p:cNvPr>
@@ -9520,7 +9543,7 @@
           <p:cNvPr id="2" name="">
             <a:extLst xmlns:a="http://schemas.openxmlformats.org/drawingml/2006/main">
               <a:ext uri="{FF2B5EF4-FFF2-40B4-BE49-F238E27FC236}">
-                <a16:creationId xmlns:a16="http://schemas.microsoft.com/office/drawing/2014/main" id="{79A24DDA-1878-443F-A476-B5E010F6C03E}"/>
+                <a16:creationId xmlns:a16="http://schemas.microsoft.com/office/drawing/2014/main" id="{FF1AB893-669A-453F-8EEE-F4E433C03E4E}"/>
               </a:ext>
             </a:extLst>
           </p:cNvPr>
@@ -9576,7 +9599,7 @@
           <p:cNvPr id="3" name="">
             <a:extLst xmlns:a="http://schemas.openxmlformats.org/drawingml/2006/main">
               <a:ext uri="{FF2B5EF4-FFF2-40B4-BE49-F238E27FC236}">
-                <a16:creationId xmlns:a16="http://schemas.microsoft.com/office/drawing/2014/main" id="{6E144EB9-915C-490E-B771-63E7EA60AAEE}"/>
+                <a16:creationId xmlns:a16="http://schemas.microsoft.com/office/drawing/2014/main" id="{98396447-21AD-4262-8F32-2BAE918EDED9}"/>
               </a:ext>
             </a:extLst>
           </p:cNvPr>
@@ -9632,7 +9655,7 @@
           <p:cNvPr id="4" name="">
             <a:extLst xmlns:a="http://schemas.openxmlformats.org/drawingml/2006/main">
               <a:ext uri="{FF2B5EF4-FFF2-40B4-BE49-F238E27FC236}">
-                <a16:creationId xmlns:a16="http://schemas.microsoft.com/office/drawing/2014/main" id="{ACDB19DB-8BF0-42B4-8632-6D6350A3B62E}"/>
+                <a16:creationId xmlns:a16="http://schemas.microsoft.com/office/drawing/2014/main" id="{F1525339-4F8B-42A4-93A3-38F73E57AE45}"/>
               </a:ext>
             </a:extLst>
           </p:cNvPr>
@@ -9667,7 +9690,7 @@
           <p:cNvPr id="5" name="">
             <a:extLst xmlns:a="http://schemas.openxmlformats.org/drawingml/2006/main">
               <a:ext uri="{FF2B5EF4-FFF2-40B4-BE49-F238E27FC236}">
-                <a16:creationId xmlns:a16="http://schemas.microsoft.com/office/drawing/2014/main" id="{8AFBB04A-3E89-4DD6-8C6E-050811444336}"/>
+                <a16:creationId xmlns:a16="http://schemas.microsoft.com/office/drawing/2014/main" id="{3A0C247E-97B2-4DE4-9448-C5DE8BDDCAEB}"/>
               </a:ext>
             </a:extLst>
           </p:cNvPr>
@@ -9723,7 +9746,7 @@
           <p:cNvPr id="6" name="">
             <a:extLst xmlns:a="http://schemas.openxmlformats.org/drawingml/2006/main">
               <a:ext uri="{FF2B5EF4-FFF2-40B4-BE49-F238E27FC236}">
-                <a16:creationId xmlns:a16="http://schemas.microsoft.com/office/drawing/2014/main" id="{C301ADA1-2E73-445D-8844-74C1A980E212}"/>
+                <a16:creationId xmlns:a16="http://schemas.microsoft.com/office/drawing/2014/main" id="{1D0E6A4F-6A14-471C-B023-E884D7F8B4E7}"/>
               </a:ext>
             </a:extLst>
           </p:cNvPr>
@@ -9779,7 +9802,7 @@
           <p:cNvPr id="7" name="">
             <a:extLst xmlns:a="http://schemas.openxmlformats.org/drawingml/2006/main">
               <a:ext uri="{FF2B5EF4-FFF2-40B4-BE49-F238E27FC236}">
-                <a16:creationId xmlns:a16="http://schemas.microsoft.com/office/drawing/2014/main" id="{B8735810-1A12-4902-B0CE-09C7B6C84626}"/>
+                <a16:creationId xmlns:a16="http://schemas.microsoft.com/office/drawing/2014/main" id="{509ADA65-9C9F-4695-BD3E-0FEB7B66C72C}"/>
               </a:ext>
             </a:extLst>
           </p:cNvPr>
@@ -9835,7 +9858,7 @@
           <p:cNvPr id="8" name="">
             <a:extLst xmlns:a="http://schemas.openxmlformats.org/drawingml/2006/main">
               <a:ext uri="{FF2B5EF4-FFF2-40B4-BE49-F238E27FC236}">
-                <a16:creationId xmlns:a16="http://schemas.microsoft.com/office/drawing/2014/main" id="{98AD523E-F9E8-40E7-AE32-24AB209968E3}"/>
+                <a16:creationId xmlns:a16="http://schemas.microsoft.com/office/drawing/2014/main" id="{9DB9E8E5-B115-45DB-A8E6-DA292F62E56A}"/>
               </a:ext>
             </a:extLst>
           </p:cNvPr>
@@ -9891,7 +9914,7 @@
           <p:cNvPr id="9" name="">
             <a:extLst xmlns:a="http://schemas.openxmlformats.org/drawingml/2006/main">
               <a:ext uri="{FF2B5EF4-FFF2-40B4-BE49-F238E27FC236}">
-                <a16:creationId xmlns:a16="http://schemas.microsoft.com/office/drawing/2014/main" id="{458EA900-B065-4A74-8B9D-485BDDE728C7}"/>
+                <a16:creationId xmlns:a16="http://schemas.microsoft.com/office/drawing/2014/main" id="{316E9253-2BEF-4DA5-B41D-1FF0836EAA5E}"/>
               </a:ext>
             </a:extLst>
           </p:cNvPr>
@@ -9947,7 +9970,7 @@
           <p:cNvPr id="10" name="">
             <a:extLst xmlns:a="http://schemas.openxmlformats.org/drawingml/2006/main">
               <a:ext uri="{FF2B5EF4-FFF2-40B4-BE49-F238E27FC236}">
-                <a16:creationId xmlns:a16="http://schemas.microsoft.com/office/drawing/2014/main" id="{FCF04160-5824-474E-BECB-04F087081C21}"/>
+                <a16:creationId xmlns:a16="http://schemas.microsoft.com/office/drawing/2014/main" id="{0197B913-C4AC-4B0B-A2A6-1EC0C37608D3}"/>
               </a:ext>
             </a:extLst>
           </p:cNvPr>
@@ -10003,7 +10026,7 @@
           <p:cNvPr id="11" name="">
             <a:extLst xmlns:a="http://schemas.openxmlformats.org/drawingml/2006/main">
               <a:ext uri="{FF2B5EF4-FFF2-40B4-BE49-F238E27FC236}">
-                <a16:creationId xmlns:a16="http://schemas.microsoft.com/office/drawing/2014/main" id="{71F3501E-00EC-4A45-87A1-21AA49DE5FEB}"/>
+                <a16:creationId xmlns:a16="http://schemas.microsoft.com/office/drawing/2014/main" id="{25368B41-D14C-4F6C-8FA9-9E269975A099}"/>
               </a:ext>
             </a:extLst>
           </p:cNvPr>
@@ -10059,7 +10082,7 @@
           <p:cNvPr id="12" name="">
             <a:extLst xmlns:a="http://schemas.openxmlformats.org/drawingml/2006/main">
               <a:ext uri="{FF2B5EF4-FFF2-40B4-BE49-F238E27FC236}">
-                <a16:creationId xmlns:a16="http://schemas.microsoft.com/office/drawing/2014/main" id="{081AD6F1-BA46-4EAF-8103-5839ACF1DAF6}"/>
+                <a16:creationId xmlns:a16="http://schemas.microsoft.com/office/drawing/2014/main" id="{91D5B451-2330-4C5D-BE5A-8B9D5047FE5D}"/>
               </a:ext>
             </a:extLst>
           </p:cNvPr>
@@ -10115,7 +10138,7 @@
           <p:cNvPr id="13" name="">
             <a:extLst xmlns:a="http://schemas.openxmlformats.org/drawingml/2006/main">
               <a:ext uri="{FF2B5EF4-FFF2-40B4-BE49-F238E27FC236}">
-                <a16:creationId xmlns:a16="http://schemas.microsoft.com/office/drawing/2014/main" id="{879851FA-AE4A-4701-B57E-DC956C89FCD2}"/>
+                <a16:creationId xmlns:a16="http://schemas.microsoft.com/office/drawing/2014/main" id="{E0FC359B-A39C-4827-ADE8-B9E976711264}"/>
               </a:ext>
             </a:extLst>
           </p:cNvPr>
@@ -10171,7 +10194,7 @@
           <p:cNvPr id="14" name="">
             <a:extLst xmlns:a="http://schemas.openxmlformats.org/drawingml/2006/main">
               <a:ext uri="{FF2B5EF4-FFF2-40B4-BE49-F238E27FC236}">
-                <a16:creationId xmlns:a16="http://schemas.microsoft.com/office/drawing/2014/main" id="{264ED8F0-840E-4F4A-A449-F10C684C0B61}"/>
+                <a16:creationId xmlns:a16="http://schemas.microsoft.com/office/drawing/2014/main" id="{707C7860-95FA-4DB2-96AC-B94C145493DA}"/>
               </a:ext>
             </a:extLst>
           </p:cNvPr>
@@ -10225,7 +10248,7 @@
     </p:spTree>
     <p:extLst>
       <p:ext uri="{BB962C8B-B14F-4D97-AF65-F5344CB8AC3E}">
-        <p14:creationId xmlns:p14="http://schemas.microsoft.com/office/powerpoint/2010/main" val="1314988736"/>
+        <p14:creationId xmlns:p14="http://schemas.microsoft.com/office/powerpoint/2010/main" val="556623697"/>
       </p:ext>
     </p:extLst>
   </p:cSld>
@@ -10249,7 +10272,7 @@
           <p:cNvPr id="13" name="">
             <a:extLst xmlns:a="http://schemas.openxmlformats.org/drawingml/2006/main">
               <a:ext uri="{FF2B5EF4-FFF2-40B4-BE49-F238E27FC236}">
-                <a16:creationId xmlns:a16="http://schemas.microsoft.com/office/drawing/2014/main" id="{47A92B5C-429A-4E7B-A515-C00969CD75F5}"/>
+                <a16:creationId xmlns:a16="http://schemas.microsoft.com/office/drawing/2014/main" id="{03BC9576-8155-449C-B105-5EE043D05537}"/>
               </a:ext>
             </a:extLst>
           </p:cNvPr>
@@ -10280,7 +10303,7 @@
           <p:cNvPr id="2" name="">
             <a:extLst xmlns:a="http://schemas.openxmlformats.org/drawingml/2006/main">
               <a:ext uri="{FF2B5EF4-FFF2-40B4-BE49-F238E27FC236}">
-                <a16:creationId xmlns:a16="http://schemas.microsoft.com/office/drawing/2014/main" id="{7BA699DE-CD23-4A40-90B8-FBEB7A866CF7}"/>
+                <a16:creationId xmlns:a16="http://schemas.microsoft.com/office/drawing/2014/main" id="{245C78C8-E05A-41AA-906B-40A01CABCC6F}"/>
               </a:ext>
             </a:extLst>
           </p:cNvPr>
@@ -10336,7 +10359,7 @@
           <p:cNvPr id="3" name="">
             <a:extLst xmlns:a="http://schemas.openxmlformats.org/drawingml/2006/main">
               <a:ext uri="{FF2B5EF4-FFF2-40B4-BE49-F238E27FC236}">
-                <a16:creationId xmlns:a16="http://schemas.microsoft.com/office/drawing/2014/main" id="{AE36A500-6D04-49E5-A274-CA051C497BED}"/>
+                <a16:creationId xmlns:a16="http://schemas.microsoft.com/office/drawing/2014/main" id="{231CB081-0951-4639-8E2E-946743B5CD46}"/>
               </a:ext>
             </a:extLst>
           </p:cNvPr>
@@ -10392,7 +10415,7 @@
           <p:cNvPr id="4" name="">
             <a:extLst xmlns:a="http://schemas.openxmlformats.org/drawingml/2006/main">
               <a:ext uri="{FF2B5EF4-FFF2-40B4-BE49-F238E27FC236}">
-                <a16:creationId xmlns:a16="http://schemas.microsoft.com/office/drawing/2014/main" id="{7C06CE8C-855C-4864-887A-33E5124AA52C}"/>
+                <a16:creationId xmlns:a16="http://schemas.microsoft.com/office/drawing/2014/main" id="{42A7C614-7622-4049-92CD-BE784081B258}"/>
               </a:ext>
             </a:extLst>
           </p:cNvPr>
@@ -10427,7 +10450,7 @@
           <p:cNvPr id="5" name="">
             <a:extLst xmlns:a="http://schemas.openxmlformats.org/drawingml/2006/main">
               <a:ext uri="{FF2B5EF4-FFF2-40B4-BE49-F238E27FC236}">
-                <a16:creationId xmlns:a16="http://schemas.microsoft.com/office/drawing/2014/main" id="{89F8AF0D-6DAA-450B-A854-F3D40A9967DF}"/>
+                <a16:creationId xmlns:a16="http://schemas.microsoft.com/office/drawing/2014/main" id="{009C9956-70D7-466C-BD65-A5258762BE9A}"/>
               </a:ext>
             </a:extLst>
           </p:cNvPr>
@@ -10483,7 +10506,7 @@
           <p:cNvPr id="6" name="">
             <a:extLst xmlns:a="http://schemas.openxmlformats.org/drawingml/2006/main">
               <a:ext uri="{FF2B5EF4-FFF2-40B4-BE49-F238E27FC236}">
-                <a16:creationId xmlns:a16="http://schemas.microsoft.com/office/drawing/2014/main" id="{70721FDB-3022-4758-9049-E2168B96FF5B}"/>
+                <a16:creationId xmlns:a16="http://schemas.microsoft.com/office/drawing/2014/main" id="{29CBEE6F-7CBF-427A-A789-A7C14603DF3A}"/>
               </a:ext>
             </a:extLst>
           </p:cNvPr>
@@ -10539,7 +10562,7 @@
           <p:cNvPr id="7" name="">
             <a:extLst xmlns:a="http://schemas.openxmlformats.org/drawingml/2006/main">
               <a:ext uri="{FF2B5EF4-FFF2-40B4-BE49-F238E27FC236}">
-                <a16:creationId xmlns:a16="http://schemas.microsoft.com/office/drawing/2014/main" id="{8D4A42C7-393F-47FF-841B-D0B9EB891D6C}"/>
+                <a16:creationId xmlns:a16="http://schemas.microsoft.com/office/drawing/2014/main" id="{C5FDE54C-6671-41E5-B237-C8AA6A0559F5}"/>
               </a:ext>
             </a:extLst>
           </p:cNvPr>
@@ -10664,7 +10687,7 @@
           <p:cNvPr id="8" name="">
             <a:extLst xmlns:a="http://schemas.openxmlformats.org/drawingml/2006/main">
               <a:ext uri="{FF2B5EF4-FFF2-40B4-BE49-F238E27FC236}">
-                <a16:creationId xmlns:a16="http://schemas.microsoft.com/office/drawing/2014/main" id="{BA794BFB-CDE2-486B-B77F-A8F2D9A49ADE}"/>
+                <a16:creationId xmlns:a16="http://schemas.microsoft.com/office/drawing/2014/main" id="{24612310-C7E1-4018-8956-CD7BB9EE6CE9}"/>
               </a:ext>
             </a:extLst>
           </p:cNvPr>
@@ -10699,7 +10722,7 @@
           <p:cNvPr id="9" name="">
             <a:extLst xmlns:a="http://schemas.openxmlformats.org/drawingml/2006/main">
               <a:ext uri="{FF2B5EF4-FFF2-40B4-BE49-F238E27FC236}">
-                <a16:creationId xmlns:a16="http://schemas.microsoft.com/office/drawing/2014/main" id="{C50AE0D0-94A2-4DBE-9B82-179AC7B3FFB4}"/>
+                <a16:creationId xmlns:a16="http://schemas.microsoft.com/office/drawing/2014/main" id="{03DEB421-CC9D-4B7B-925B-C12879B16EFE}"/>
               </a:ext>
             </a:extLst>
           </p:cNvPr>
@@ -10755,7 +10778,7 @@
           <p:cNvPr id="10" name="">
             <a:extLst xmlns:a="http://schemas.openxmlformats.org/drawingml/2006/main">
               <a:ext uri="{FF2B5EF4-FFF2-40B4-BE49-F238E27FC236}">
-                <a16:creationId xmlns:a16="http://schemas.microsoft.com/office/drawing/2014/main" id="{9CC7BC08-2433-45F9-AEFE-B8183E4D1DA7}"/>
+                <a16:creationId xmlns:a16="http://schemas.microsoft.com/office/drawing/2014/main" id="{878210E6-F1E2-4733-956C-2A22459FC6C9}"/>
               </a:ext>
             </a:extLst>
           </p:cNvPr>
@@ -10811,7 +10834,7 @@
           <p:cNvPr id="11" name="">
             <a:extLst xmlns:a="http://schemas.openxmlformats.org/drawingml/2006/main">
               <a:ext uri="{FF2B5EF4-FFF2-40B4-BE49-F238E27FC236}">
-                <a16:creationId xmlns:a16="http://schemas.microsoft.com/office/drawing/2014/main" id="{383C09C1-0522-4FC3-97EB-CF3B94247AE3}"/>
+                <a16:creationId xmlns:a16="http://schemas.microsoft.com/office/drawing/2014/main" id="{E0C7EAD3-7496-4939-8885-140FF34D2ACE}"/>
               </a:ext>
             </a:extLst>
           </p:cNvPr>
@@ -10936,7 +10959,7 @@
           <p:cNvPr id="12" name="">
             <a:extLst xmlns:a="http://schemas.openxmlformats.org/drawingml/2006/main">
               <a:ext uri="{FF2B5EF4-FFF2-40B4-BE49-F238E27FC236}">
-                <a16:creationId xmlns:a16="http://schemas.microsoft.com/office/drawing/2014/main" id="{BB949581-F43E-43E6-9406-EE9CF33F3329}"/>
+                <a16:creationId xmlns:a16="http://schemas.microsoft.com/office/drawing/2014/main" id="{3E2E51D9-F8CF-4B34-8639-BB86259518D2}"/>
               </a:ext>
             </a:extLst>
           </p:cNvPr>
@@ -10990,7 +11013,7 @@
     </p:spTree>
     <p:extLst>
       <p:ext uri="{BB962C8B-B14F-4D97-AF65-F5344CB8AC3E}">
-        <p14:creationId xmlns:p14="http://schemas.microsoft.com/office/powerpoint/2010/main" val="1243095534"/>
+        <p14:creationId xmlns:p14="http://schemas.microsoft.com/office/powerpoint/2010/main" val="1841499208"/>
       </p:ext>
     </p:extLst>
   </p:cSld>
@@ -11014,7 +11037,7 @@
           <p:cNvPr id="19" name="">
             <a:extLst xmlns:a="http://schemas.openxmlformats.org/drawingml/2006/main">
               <a:ext uri="{FF2B5EF4-FFF2-40B4-BE49-F238E27FC236}">
-                <a16:creationId xmlns:a16="http://schemas.microsoft.com/office/drawing/2014/main" id="{468AA057-FE4A-49D3-88D8-1849CCAAD5F4}"/>
+                <a16:creationId xmlns:a16="http://schemas.microsoft.com/office/drawing/2014/main" id="{E3326098-46D0-42D9-845E-5E76DEA8332B}"/>
               </a:ext>
             </a:extLst>
           </p:cNvPr>
@@ -11045,7 +11068,7 @@
           <p:cNvPr id="2" name="">
             <a:extLst xmlns:a="http://schemas.openxmlformats.org/drawingml/2006/main">
               <a:ext uri="{FF2B5EF4-FFF2-40B4-BE49-F238E27FC236}">
-                <a16:creationId xmlns:a16="http://schemas.microsoft.com/office/drawing/2014/main" id="{360F9B1E-4580-4969-AF28-C9DB1E92F92E}"/>
+                <a16:creationId xmlns:a16="http://schemas.microsoft.com/office/drawing/2014/main" id="{05B2ABCA-8468-4C54-B011-0861639672AA}"/>
               </a:ext>
             </a:extLst>
           </p:cNvPr>
@@ -11101,7 +11124,7 @@
           <p:cNvPr id="3" name="">
             <a:extLst xmlns:a="http://schemas.openxmlformats.org/drawingml/2006/main">
               <a:ext uri="{FF2B5EF4-FFF2-40B4-BE49-F238E27FC236}">
-                <a16:creationId xmlns:a16="http://schemas.microsoft.com/office/drawing/2014/main" id="{99BF61A8-D671-45A0-9E58-7E8A83D23658}"/>
+                <a16:creationId xmlns:a16="http://schemas.microsoft.com/office/drawing/2014/main" id="{F1F27474-893A-4E8B-B58E-39E53F0B6EB1}"/>
               </a:ext>
             </a:extLst>
           </p:cNvPr>
@@ -11201,7 +11224,7 @@
           <p:cNvPr id="6" name="">
             <a:extLst xmlns:a="http://schemas.openxmlformats.org/drawingml/2006/main">
               <a:ext uri="{FF2B5EF4-FFF2-40B4-BE49-F238E27FC236}">
-                <a16:creationId xmlns:a16="http://schemas.microsoft.com/office/drawing/2014/main" id="{FCDDA526-636C-41D7-B2E3-AE62E663F196}"/>
+                <a16:creationId xmlns:a16="http://schemas.microsoft.com/office/drawing/2014/main" id="{FFDE2974-EF45-48B5-B33D-D6960024FC90}"/>
               </a:ext>
             </a:extLst>
           </p:cNvPr>
@@ -11236,7 +11259,7 @@
           <p:cNvPr id="7" name="">
             <a:extLst xmlns:a="http://schemas.openxmlformats.org/drawingml/2006/main">
               <a:ext uri="{FF2B5EF4-FFF2-40B4-BE49-F238E27FC236}">
-                <a16:creationId xmlns:a16="http://schemas.microsoft.com/office/drawing/2014/main" id="{BD7DD1B5-D1EA-4340-A296-AE4F2937052C}"/>
+                <a16:creationId xmlns:a16="http://schemas.microsoft.com/office/drawing/2014/main" id="{3A8175C7-E92C-4EDD-BB99-053CE9B71D1D}"/>
               </a:ext>
             </a:extLst>
           </p:cNvPr>
@@ -11292,7 +11315,7 @@
           <p:cNvPr id="8" name="">
             <a:extLst xmlns:a="http://schemas.openxmlformats.org/drawingml/2006/main">
               <a:ext uri="{FF2B5EF4-FFF2-40B4-BE49-F238E27FC236}">
-                <a16:creationId xmlns:a16="http://schemas.microsoft.com/office/drawing/2014/main" id="{16BFC3D3-9812-47A4-B71A-0C41849D2B11}"/>
+                <a16:creationId xmlns:a16="http://schemas.microsoft.com/office/drawing/2014/main" id="{BF1A1A8E-F7D3-4061-88A4-C6CE8F31D810}"/>
               </a:ext>
             </a:extLst>
           </p:cNvPr>
@@ -11348,7 +11371,7 @@
           <p:cNvPr id="9" name="">
             <a:extLst xmlns:a="http://schemas.openxmlformats.org/drawingml/2006/main">
               <a:ext uri="{FF2B5EF4-FFF2-40B4-BE49-F238E27FC236}">
-                <a16:creationId xmlns:a16="http://schemas.microsoft.com/office/drawing/2014/main" id="{011F5728-F9E2-4BC8-84CA-AC3EEE622A9F}"/>
+                <a16:creationId xmlns:a16="http://schemas.microsoft.com/office/drawing/2014/main" id="{6D6065FB-E34F-4999-AC34-547990C688FD}"/>
               </a:ext>
             </a:extLst>
           </p:cNvPr>
@@ -11404,7 +11427,7 @@
           <p:cNvPr id="10" name="">
             <a:extLst xmlns:a="http://schemas.openxmlformats.org/drawingml/2006/main">
               <a:ext uri="{FF2B5EF4-FFF2-40B4-BE49-F238E27FC236}">
-                <a16:creationId xmlns:a16="http://schemas.microsoft.com/office/drawing/2014/main" id="{DE53865D-34AB-4EF4-9899-EE8E484E2572}"/>
+                <a16:creationId xmlns:a16="http://schemas.microsoft.com/office/drawing/2014/main" id="{6F89BCC0-AFC4-45CA-8E02-FF4323749316}"/>
               </a:ext>
             </a:extLst>
           </p:cNvPr>
@@ -11439,7 +11462,7 @@
           <p:cNvPr id="11" name="">
             <a:extLst xmlns:a="http://schemas.openxmlformats.org/drawingml/2006/main">
               <a:ext uri="{FF2B5EF4-FFF2-40B4-BE49-F238E27FC236}">
-                <a16:creationId xmlns:a16="http://schemas.microsoft.com/office/drawing/2014/main" id="{36757ED1-CEB1-422A-8022-303219220860}"/>
+                <a16:creationId xmlns:a16="http://schemas.microsoft.com/office/drawing/2014/main" id="{8E131FF9-F940-49E2-97EC-55E6DF9B3201}"/>
               </a:ext>
             </a:extLst>
           </p:cNvPr>
@@ -11495,7 +11518,7 @@
           <p:cNvPr id="12" name="">
             <a:extLst xmlns:a="http://schemas.openxmlformats.org/drawingml/2006/main">
               <a:ext uri="{FF2B5EF4-FFF2-40B4-BE49-F238E27FC236}">
-                <a16:creationId xmlns:a16="http://schemas.microsoft.com/office/drawing/2014/main" id="{21E90110-75BC-4BFF-AA78-4E708DCBCDE4}"/>
+                <a16:creationId xmlns:a16="http://schemas.microsoft.com/office/drawing/2014/main" id="{926D2A7F-5EAD-49D4-8294-799B61274C81}"/>
               </a:ext>
             </a:extLst>
           </p:cNvPr>
@@ -11551,7 +11574,7 @@
           <p:cNvPr id="13" name="">
             <a:extLst xmlns:a="http://schemas.openxmlformats.org/drawingml/2006/main">
               <a:ext uri="{FF2B5EF4-FFF2-40B4-BE49-F238E27FC236}">
-                <a16:creationId xmlns:a16="http://schemas.microsoft.com/office/drawing/2014/main" id="{F6D4F50B-81ED-4052-BFE0-2AAB929829F5}"/>
+                <a16:creationId xmlns:a16="http://schemas.microsoft.com/office/drawing/2014/main" id="{6B3A19AB-B25E-4D07-A48F-ED740C27A8BA}"/>
               </a:ext>
             </a:extLst>
           </p:cNvPr>
@@ -11607,7 +11630,7 @@
           <p:cNvPr id="14" name="">
             <a:extLst xmlns:a="http://schemas.openxmlformats.org/drawingml/2006/main">
               <a:ext uri="{FF2B5EF4-FFF2-40B4-BE49-F238E27FC236}">
-                <a16:creationId xmlns:a16="http://schemas.microsoft.com/office/drawing/2014/main" id="{D1BA69DA-62EF-48BC-9F65-E017505DB38A}"/>
+                <a16:creationId xmlns:a16="http://schemas.microsoft.com/office/drawing/2014/main" id="{CF68C280-0056-4A9D-9B80-7B9BE8B32DB9}"/>
               </a:ext>
             </a:extLst>
           </p:cNvPr>
@@ -11642,7 +11665,7 @@
           <p:cNvPr id="15" name="">
             <a:extLst xmlns:a="http://schemas.openxmlformats.org/drawingml/2006/main">
               <a:ext uri="{FF2B5EF4-FFF2-40B4-BE49-F238E27FC236}">
-                <a16:creationId xmlns:a16="http://schemas.microsoft.com/office/drawing/2014/main" id="{F4B26704-A61F-400E-AC48-D5CC70974A26}"/>
+                <a16:creationId xmlns:a16="http://schemas.microsoft.com/office/drawing/2014/main" id="{894788AF-2B40-4A14-AFCB-97EFA0D2D6A4}"/>
               </a:ext>
             </a:extLst>
           </p:cNvPr>
@@ -11698,7 +11721,7 @@
           <p:cNvPr id="16" name="">
             <a:extLst xmlns:a="http://schemas.openxmlformats.org/drawingml/2006/main">
               <a:ext uri="{FF2B5EF4-FFF2-40B4-BE49-F238E27FC236}">
-                <a16:creationId xmlns:a16="http://schemas.microsoft.com/office/drawing/2014/main" id="{037AA0F0-1050-4BA5-AAD2-BC623C5D2041}"/>
+                <a16:creationId xmlns:a16="http://schemas.microsoft.com/office/drawing/2014/main" id="{F4D1BB11-68FF-480E-8392-73C013F6101A}"/>
               </a:ext>
             </a:extLst>
           </p:cNvPr>
@@ -11754,7 +11777,7 @@
           <p:cNvPr id="17" name="">
             <a:extLst xmlns:a="http://schemas.openxmlformats.org/drawingml/2006/main">
               <a:ext uri="{FF2B5EF4-FFF2-40B4-BE49-F238E27FC236}">
-                <a16:creationId xmlns:a16="http://schemas.microsoft.com/office/drawing/2014/main" id="{3564C84C-41F8-42EC-A7F2-88FC402C8E30}"/>
+                <a16:creationId xmlns:a16="http://schemas.microsoft.com/office/drawing/2014/main" id="{CB70BEC3-F8BB-4354-987D-49BEFF302F7F}"/>
               </a:ext>
             </a:extLst>
           </p:cNvPr>
@@ -11810,7 +11833,7 @@
           <p:cNvPr id="18" name="">
             <a:extLst xmlns:a="http://schemas.openxmlformats.org/drawingml/2006/main">
               <a:ext uri="{FF2B5EF4-FFF2-40B4-BE49-F238E27FC236}">
-                <a16:creationId xmlns:a16="http://schemas.microsoft.com/office/drawing/2014/main" id="{DD228397-7C74-4F6A-B609-F4875AFF612E}"/>
+                <a16:creationId xmlns:a16="http://schemas.microsoft.com/office/drawing/2014/main" id="{5EC12E1F-74B6-44B3-8100-478B0CA67C94}"/>
               </a:ext>
             </a:extLst>
           </p:cNvPr>
@@ -11864,7 +11887,7 @@
     </p:spTree>
     <p:extLst>
       <p:ext uri="{BB962C8B-B14F-4D97-AF65-F5344CB8AC3E}">
-        <p14:creationId xmlns:p14="http://schemas.microsoft.com/office/powerpoint/2010/main" val="1641502922"/>
+        <p14:creationId xmlns:p14="http://schemas.microsoft.com/office/powerpoint/2010/main" val="1915906940"/>
       </p:ext>
     </p:extLst>
   </p:cSld>
@@ -11888,7 +11911,7 @@
           <p:cNvPr id="14" name="">
             <a:extLst xmlns:a="http://schemas.openxmlformats.org/drawingml/2006/main">
               <a:ext uri="{FF2B5EF4-FFF2-40B4-BE49-F238E27FC236}">
-                <a16:creationId xmlns:a16="http://schemas.microsoft.com/office/drawing/2014/main" id="{C2343355-4801-444A-B1C3-5C6A2FECDFCB}"/>
+                <a16:creationId xmlns:a16="http://schemas.microsoft.com/office/drawing/2014/main" id="{C8284807-3FD1-42BE-9CF9-E0CE8277DC49}"/>
               </a:ext>
             </a:extLst>
           </p:cNvPr>
@@ -11919,7 +11942,7 @@
           <p:cNvPr id="2" name="">
             <a:extLst xmlns:a="http://schemas.openxmlformats.org/drawingml/2006/main">
               <a:ext uri="{FF2B5EF4-FFF2-40B4-BE49-F238E27FC236}">
-                <a16:creationId xmlns:a16="http://schemas.microsoft.com/office/drawing/2014/main" id="{451B4870-E39F-48BF-A5ED-F603CE3F442F}"/>
+                <a16:creationId xmlns:a16="http://schemas.microsoft.com/office/drawing/2014/main" id="{63CE4564-C57D-498F-929D-FCE4FE25E9B0}"/>
               </a:ext>
             </a:extLst>
           </p:cNvPr>
@@ -11975,7 +11998,7 @@
           <p:cNvPr id="3" name="">
             <a:extLst xmlns:a="http://schemas.openxmlformats.org/drawingml/2006/main">
               <a:ext uri="{FF2B5EF4-FFF2-40B4-BE49-F238E27FC236}">
-                <a16:creationId xmlns:a16="http://schemas.microsoft.com/office/drawing/2014/main" id="{9838BD06-2379-4E27-9CC1-DB449B765656}"/>
+                <a16:creationId xmlns:a16="http://schemas.microsoft.com/office/drawing/2014/main" id="{63339096-AB1D-424C-BAFE-FB2F6C16C5A0}"/>
               </a:ext>
             </a:extLst>
           </p:cNvPr>
@@ -12382,7 +12405,7 @@
           <p:cNvPr id="5" name="">
             <a:extLst xmlns:a="http://schemas.openxmlformats.org/drawingml/2006/main">
               <a:ext uri="{FF2B5EF4-FFF2-40B4-BE49-F238E27FC236}">
-                <a16:creationId xmlns:a16="http://schemas.microsoft.com/office/drawing/2014/main" id="{1418CBC8-EFBA-414B-87EC-4DBB3CDB914A}"/>
+                <a16:creationId xmlns:a16="http://schemas.microsoft.com/office/drawing/2014/main" id="{5FF204DE-316C-4D66-AF8E-A47FD068187F}"/>
               </a:ext>
             </a:extLst>
           </p:cNvPr>
@@ -12417,7 +12440,7 @@
           <p:cNvPr id="6" name="">
             <a:extLst xmlns:a="http://schemas.openxmlformats.org/drawingml/2006/main">
               <a:ext uri="{FF2B5EF4-FFF2-40B4-BE49-F238E27FC236}">
-                <a16:creationId xmlns:a16="http://schemas.microsoft.com/office/drawing/2014/main" id="{AC1D76D5-4B7F-4EF1-B3F1-D4385E926708}"/>
+                <a16:creationId xmlns:a16="http://schemas.microsoft.com/office/drawing/2014/main" id="{632331A8-CE53-4C67-9589-DAAAEFD34CDD}"/>
               </a:ext>
             </a:extLst>
           </p:cNvPr>
@@ -12473,7 +12496,7 @@
           <p:cNvPr id="7" name="">
             <a:extLst xmlns:a="http://schemas.openxmlformats.org/drawingml/2006/main">
               <a:ext uri="{FF2B5EF4-FFF2-40B4-BE49-F238E27FC236}">
-                <a16:creationId xmlns:a16="http://schemas.microsoft.com/office/drawing/2014/main" id="{F5B4132E-46AF-4865-BAA9-5BEADD5DF27E}"/>
+                <a16:creationId xmlns:a16="http://schemas.microsoft.com/office/drawing/2014/main" id="{41812DAB-934F-4BF5-A141-2A84B0CE02C4}"/>
               </a:ext>
             </a:extLst>
           </p:cNvPr>
@@ -12529,7 +12552,7 @@
           <p:cNvPr id="8" name="">
             <a:extLst xmlns:a="http://schemas.openxmlformats.org/drawingml/2006/main">
               <a:ext uri="{FF2B5EF4-FFF2-40B4-BE49-F238E27FC236}">
-                <a16:creationId xmlns:a16="http://schemas.microsoft.com/office/drawing/2014/main" id="{9F7B6FEA-8578-4317-AA31-5F86FBA0B0F4}"/>
+                <a16:creationId xmlns:a16="http://schemas.microsoft.com/office/drawing/2014/main" id="{DF3822DB-7831-4743-995A-D83FDD582ABA}"/>
               </a:ext>
             </a:extLst>
           </p:cNvPr>
@@ -12564,7 +12587,7 @@
           <p:cNvPr id="9" name="">
             <a:extLst xmlns:a="http://schemas.openxmlformats.org/drawingml/2006/main">
               <a:ext uri="{FF2B5EF4-FFF2-40B4-BE49-F238E27FC236}">
-                <a16:creationId xmlns:a16="http://schemas.microsoft.com/office/drawing/2014/main" id="{391A3B76-42EB-4A73-AA4B-B6A8FA53B375}"/>
+                <a16:creationId xmlns:a16="http://schemas.microsoft.com/office/drawing/2014/main" id="{15BB2182-C53D-41AF-A85B-AF4C8705979A}"/>
               </a:ext>
             </a:extLst>
           </p:cNvPr>
@@ -12620,7 +12643,7 @@
           <p:cNvPr id="10" name="">
             <a:extLst xmlns:a="http://schemas.openxmlformats.org/drawingml/2006/main">
               <a:ext uri="{FF2B5EF4-FFF2-40B4-BE49-F238E27FC236}">
-                <a16:creationId xmlns:a16="http://schemas.microsoft.com/office/drawing/2014/main" id="{8F902BED-2FD7-4A16-B94A-AF1C43A2A131}"/>
+                <a16:creationId xmlns:a16="http://schemas.microsoft.com/office/drawing/2014/main" id="{CB97E5A7-2F25-48E9-BB30-3C591302F495}"/>
               </a:ext>
             </a:extLst>
           </p:cNvPr>
@@ -12676,7 +12699,7 @@
           <p:cNvPr id="11" name="">
             <a:extLst xmlns:a="http://schemas.openxmlformats.org/drawingml/2006/main">
               <a:ext uri="{FF2B5EF4-FFF2-40B4-BE49-F238E27FC236}">
-                <a16:creationId xmlns:a16="http://schemas.microsoft.com/office/drawing/2014/main" id="{B9270FBC-116E-47FE-A00E-9AE057B6D8E0}"/>
+                <a16:creationId xmlns:a16="http://schemas.microsoft.com/office/drawing/2014/main" id="{70A6DC34-78F1-4F6A-A4D9-172014185BCD}"/>
               </a:ext>
             </a:extLst>
           </p:cNvPr>
@@ -12711,7 +12734,7 @@
           <p:cNvPr id="12" name="">
             <a:extLst xmlns:a="http://schemas.openxmlformats.org/drawingml/2006/main">
               <a:ext uri="{FF2B5EF4-FFF2-40B4-BE49-F238E27FC236}">
-                <a16:creationId xmlns:a16="http://schemas.microsoft.com/office/drawing/2014/main" id="{6FF0B08C-A0B0-4ECB-9224-FF0293E83826}"/>
+                <a16:creationId xmlns:a16="http://schemas.microsoft.com/office/drawing/2014/main" id="{806ECE88-B950-423F-998E-68438B469442}"/>
               </a:ext>
             </a:extLst>
           </p:cNvPr>
@@ -12767,7 +12790,7 @@
           <p:cNvPr id="13" name="">
             <a:extLst xmlns:a="http://schemas.openxmlformats.org/drawingml/2006/main">
               <a:ext uri="{FF2B5EF4-FFF2-40B4-BE49-F238E27FC236}">
-                <a16:creationId xmlns:a16="http://schemas.microsoft.com/office/drawing/2014/main" id="{FCD65F17-7DDB-4EAC-B113-28C3C4BC37BD}"/>
+                <a16:creationId xmlns:a16="http://schemas.microsoft.com/office/drawing/2014/main" id="{38A3830F-0C42-4D3C-9F8F-B3CCD03757CF}"/>
               </a:ext>
             </a:extLst>
           </p:cNvPr>
@@ -12821,7 +12844,7 @@
     </p:spTree>
     <p:extLst>
       <p:ext uri="{BB962C8B-B14F-4D97-AF65-F5344CB8AC3E}">
-        <p14:creationId xmlns:p14="http://schemas.microsoft.com/office/powerpoint/2010/main" val="1369628916"/>
+        <p14:creationId xmlns:p14="http://schemas.microsoft.com/office/powerpoint/2010/main" val="1237216172"/>
       </p:ext>
     </p:extLst>
   </p:cSld>

</xml_diff>

<commit_message>
Reenfocar proyecto a digitalizacion de archivos publicos
</commit_message>
<xml_diff>
--- a/presentacion/PresentacionFinal_Grupo_RedesNeuronalesGrafos.pptx
+++ b/presentacion/PresentacionFinal_Grupo_RedesNeuronalesGrafos.pptx
@@ -2,27 +2,27 @@
 <file path=ppt/presentation.xml><?xml version="1.0" encoding="utf-8"?>
 <p:presentation xmlns:p="http://schemas.openxmlformats.org/presentationml/2006/main">
   <p:sldMasterIdLst>
-    <p:sldMasterId xmlns:r="http://schemas.openxmlformats.org/officeDocument/2006/relationships" id="2147483648" r:id="Ra1c8de7e41ec4033"/>
+    <p:sldMasterId xmlns:r="http://schemas.openxmlformats.org/officeDocument/2006/relationships" id="2147483648" r:id="Rf24ad4af764140ea"/>
   </p:sldMasterIdLst>
   <p:notesMasterIdLst>
-    <p:notesMasterId xmlns:r="http://schemas.openxmlformats.org/officeDocument/2006/relationships" r:id="Rb4c81f9e865941c5"/>
+    <p:notesMasterId xmlns:r="http://schemas.openxmlformats.org/officeDocument/2006/relationships" r:id="R5790b37768db41c0"/>
   </p:notesMasterIdLst>
   <p:sldIdLst>
-    <p:sldId xmlns:r="http://schemas.openxmlformats.org/officeDocument/2006/relationships" id="256" r:id="R80d4fefb2ad84c9c"/>
-    <p:sldId xmlns:r="http://schemas.openxmlformats.org/officeDocument/2006/relationships" id="257" r:id="R3508daa134a546d1"/>
-    <p:sldId xmlns:r="http://schemas.openxmlformats.org/officeDocument/2006/relationships" id="258" r:id="Rb1145e02880d45dc"/>
-    <p:sldId xmlns:r="http://schemas.openxmlformats.org/officeDocument/2006/relationships" id="259" r:id="Rd0f0232a0678499d"/>
-    <p:sldId xmlns:r="http://schemas.openxmlformats.org/officeDocument/2006/relationships" id="260" r:id="R954104fb7fce4909"/>
-    <p:sldId xmlns:r="http://schemas.openxmlformats.org/officeDocument/2006/relationships" id="261" r:id="Ra29e51cf3ad7448e"/>
-    <p:sldId xmlns:r="http://schemas.openxmlformats.org/officeDocument/2006/relationships" id="262" r:id="Ree908b4b5b974a8a"/>
-    <p:sldId xmlns:r="http://schemas.openxmlformats.org/officeDocument/2006/relationships" id="263" r:id="R1d0a962f0dee4a16"/>
-    <p:sldId xmlns:r="http://schemas.openxmlformats.org/officeDocument/2006/relationships" id="264" r:id="R6f5cb33008f14853"/>
-    <p:sldId xmlns:r="http://schemas.openxmlformats.org/officeDocument/2006/relationships" id="265" r:id="Radcbe6b1e8ef4c3d"/>
-    <p:sldId xmlns:r="http://schemas.openxmlformats.org/officeDocument/2006/relationships" id="266" r:id="R60257372645349c0"/>
-    <p:sldId xmlns:r="http://schemas.openxmlformats.org/officeDocument/2006/relationships" id="267" r:id="Rfdffe6eadad24e67"/>
-    <p:sldId xmlns:r="http://schemas.openxmlformats.org/officeDocument/2006/relationships" id="268" r:id="R63ac272e1342465f"/>
-    <p:sldId xmlns:r="http://schemas.openxmlformats.org/officeDocument/2006/relationships" id="269" r:id="R2569573867f84ba3"/>
-    <p:sldId xmlns:r="http://schemas.openxmlformats.org/officeDocument/2006/relationships" id="270" r:id="R30c002c6de6f43c1"/>
+    <p:sldId xmlns:r="http://schemas.openxmlformats.org/officeDocument/2006/relationships" id="256" r:id="R78f05ac6d8c24c7e"/>
+    <p:sldId xmlns:r="http://schemas.openxmlformats.org/officeDocument/2006/relationships" id="257" r:id="Rf10c775c31184fac"/>
+    <p:sldId xmlns:r="http://schemas.openxmlformats.org/officeDocument/2006/relationships" id="258" r:id="R66029ee419bf4b42"/>
+    <p:sldId xmlns:r="http://schemas.openxmlformats.org/officeDocument/2006/relationships" id="259" r:id="Rb6b617442cd94b30"/>
+    <p:sldId xmlns:r="http://schemas.openxmlformats.org/officeDocument/2006/relationships" id="260" r:id="R13db6016773043b3"/>
+    <p:sldId xmlns:r="http://schemas.openxmlformats.org/officeDocument/2006/relationships" id="261" r:id="Rfbef86b040304bde"/>
+    <p:sldId xmlns:r="http://schemas.openxmlformats.org/officeDocument/2006/relationships" id="262" r:id="Raf5d279000224205"/>
+    <p:sldId xmlns:r="http://schemas.openxmlformats.org/officeDocument/2006/relationships" id="263" r:id="R8551ef09867e4d74"/>
+    <p:sldId xmlns:r="http://schemas.openxmlformats.org/officeDocument/2006/relationships" id="264" r:id="R6cafed9d40f04458"/>
+    <p:sldId xmlns:r="http://schemas.openxmlformats.org/officeDocument/2006/relationships" id="265" r:id="Ra260cb0f67814f92"/>
+    <p:sldId xmlns:r="http://schemas.openxmlformats.org/officeDocument/2006/relationships" id="266" r:id="Refc58c1d756a40c8"/>
+    <p:sldId xmlns:r="http://schemas.openxmlformats.org/officeDocument/2006/relationships" id="267" r:id="Rd7b5380bc4214fe0"/>
+    <p:sldId xmlns:r="http://schemas.openxmlformats.org/officeDocument/2006/relationships" id="268" r:id="R0cf58f1a17cb4a10"/>
+    <p:sldId xmlns:r="http://schemas.openxmlformats.org/officeDocument/2006/relationships" id="269" r:id="R149571bb9cc5460c"/>
+    <p:sldId xmlns:r="http://schemas.openxmlformats.org/officeDocument/2006/relationships" id="270" r:id="Ra545aea54e7a475d"/>
   </p:sldIdLst>
   <p:sldSz cx="12192000" cy="6858000"/>
   <p:notesSz cx="6858000" cy="9144000"/>
@@ -479,6 +479,15 @@
               <a:t>[/Sources]</a:t>
             </a:r>
           </a:p>
+          <a:p xmlns:a="http://schemas.openxmlformats.org/drawingml/2006/main">
+            <a:r>
+              <a:t>
+[Sources]
+- https://archivonacional.go.cr/
+- https://www.archivonacional.go.cr/web/dsae/NTN-003_digitalizacio%CC%81n_textuales_papel_doc.pdf
+- https://yann.lecun.com/exdb/mnist/</a:t>
+            </a:r>
+          </a:p>
         </p:txBody>
       </p:sp>
       <p:sp>
@@ -569,6 +578,15 @@
               <a:t>[/Sources]</a:t>
             </a:r>
           </a:p>
+          <a:p xmlns:a="http://schemas.openxmlformats.org/drawingml/2006/main">
+            <a:r>
+              <a:t>
+[Sources]
+- https://archivonacional.go.cr/
+- https://www.archivonacional.go.cr/web/dsae/NTN-003_digitalizacio%CC%81n_textuales_papel_doc.pdf
+- https://yann.lecun.com/exdb/mnist/</a:t>
+            </a:r>
+          </a:p>
         </p:txBody>
       </p:sp>
       <p:sp>
@@ -659,6 +677,15 @@
               <a:t>[/Sources]</a:t>
             </a:r>
           </a:p>
+          <a:p xmlns:a="http://schemas.openxmlformats.org/drawingml/2006/main">
+            <a:r>
+              <a:t>
+[Sources]
+- https://archivonacional.go.cr/
+- https://www.archivonacional.go.cr/web/dsae/NTN-003_digitalizacio%CC%81n_textuales_papel_doc.pdf
+- https://yann.lecun.com/exdb/mnist/</a:t>
+            </a:r>
+          </a:p>
         </p:txBody>
       </p:sp>
       <p:sp>
@@ -754,6 +781,15 @@
               <a:t>[/Sources]</a:t>
             </a:r>
           </a:p>
+          <a:p xmlns:a="http://schemas.openxmlformats.org/drawingml/2006/main">
+            <a:r>
+              <a:t>
+[Sources]
+- https://archivonacional.go.cr/
+- https://www.archivonacional.go.cr/web/dsae/NTN-003_digitalizacio%CC%81n_textuales_papel_doc.pdf
+- https://yann.lecun.com/exdb/mnist/</a:t>
+            </a:r>
+          </a:p>
         </p:txBody>
       </p:sp>
       <p:sp>
@@ -849,6 +885,15 @@
               <a:t>[/Sources]</a:t>
             </a:r>
           </a:p>
+          <a:p xmlns:a="http://schemas.openxmlformats.org/drawingml/2006/main">
+            <a:r>
+              <a:t>
+[Sources]
+- https://archivonacional.go.cr/
+- https://www.archivonacional.go.cr/web/dsae/NTN-003_digitalizacio%CC%81n_textuales_papel_doc.pdf
+- https://yann.lecun.com/exdb/mnist/</a:t>
+            </a:r>
+          </a:p>
         </p:txBody>
       </p:sp>
       <p:sp>
@@ -939,6 +984,15 @@
               <a:t>[/Sources]</a:t>
             </a:r>
           </a:p>
+          <a:p xmlns:a="http://schemas.openxmlformats.org/drawingml/2006/main">
+            <a:r>
+              <a:t>
+[Sources]
+- https://archivonacional.go.cr/
+- https://www.archivonacional.go.cr/web/dsae/NTN-003_digitalizacio%CC%81n_textuales_papel_doc.pdf
+- https://yann.lecun.com/exdb/mnist/</a:t>
+            </a:r>
+          </a:p>
         </p:txBody>
       </p:sp>
       <p:sp>
@@ -1034,6 +1088,15 @@
               <a:t>[/Sources]</a:t>
             </a:r>
           </a:p>
+          <a:p xmlns:a="http://schemas.openxmlformats.org/drawingml/2006/main">
+            <a:r>
+              <a:t>
+[Sources]
+- https://archivonacional.go.cr/
+- https://www.archivonacional.go.cr/web/dsae/NTN-003_digitalizacio%CC%81n_textuales_papel_doc.pdf
+- https://yann.lecun.com/exdb/mnist/</a:t>
+            </a:r>
+          </a:p>
         </p:txBody>
       </p:sp>
       <p:sp>
@@ -1129,6 +1192,15 @@
               <a:t>[/Sources]</a:t>
             </a:r>
           </a:p>
+          <a:p xmlns:a="http://schemas.openxmlformats.org/drawingml/2006/main">
+            <a:r>
+              <a:t>
+[Sources]
+- https://archivonacional.go.cr/
+- https://www.archivonacional.go.cr/web/dsae/NTN-003_digitalizacio%CC%81n_textuales_papel_doc.pdf
+- https://yann.lecun.com/exdb/mnist/</a:t>
+            </a:r>
+          </a:p>
         </p:txBody>
       </p:sp>
       <p:sp>
@@ -1219,6 +1291,15 @@
               <a:t>[/Sources]</a:t>
             </a:r>
           </a:p>
+          <a:p xmlns:a="http://schemas.openxmlformats.org/drawingml/2006/main">
+            <a:r>
+              <a:t>
+[Sources]
+- https://archivonacional.go.cr/
+- https://www.archivonacional.go.cr/web/dsae/NTN-003_digitalizacio%CC%81n_textuales_papel_doc.pdf
+- https://yann.lecun.com/exdb/mnist/</a:t>
+            </a:r>
+          </a:p>
         </p:txBody>
       </p:sp>
       <p:sp>
@@ -1314,6 +1395,15 @@
               <a:t>[/Sources]</a:t>
             </a:r>
           </a:p>
+          <a:p xmlns:a="http://schemas.openxmlformats.org/drawingml/2006/main">
+            <a:r>
+              <a:t>
+[Sources]
+- https://archivonacional.go.cr/
+- https://www.archivonacional.go.cr/web/dsae/NTN-003_digitalizacio%CC%81n_textuales_papel_doc.pdf
+- https://yann.lecun.com/exdb/mnist/</a:t>
+            </a:r>
+          </a:p>
         </p:txBody>
       </p:sp>
       <p:sp>
@@ -1404,6 +1494,15 @@
               <a:t>[/Sources]</a:t>
             </a:r>
           </a:p>
+          <a:p xmlns:a="http://schemas.openxmlformats.org/drawingml/2006/main">
+            <a:r>
+              <a:t>
+[Sources]
+- https://archivonacional.go.cr/
+- https://www.archivonacional.go.cr/web/dsae/NTN-003_digitalizacio%CC%81n_textuales_papel_doc.pdf
+- https://yann.lecun.com/exdb/mnist/</a:t>
+            </a:r>
+          </a:p>
         </p:txBody>
       </p:sp>
       <p:sp>
@@ -1499,6 +1598,15 @@
               <a:t>[/Sources]</a:t>
             </a:r>
           </a:p>
+          <a:p xmlns:a="http://schemas.openxmlformats.org/drawingml/2006/main">
+            <a:r>
+              <a:t>
+[Sources]
+- https://archivonacional.go.cr/
+- https://www.archivonacional.go.cr/web/dsae/NTN-003_digitalizacio%CC%81n_textuales_papel_doc.pdf
+- https://yann.lecun.com/exdb/mnist/</a:t>
+            </a:r>
+          </a:p>
         </p:txBody>
       </p:sp>
       <p:sp>
@@ -1594,6 +1702,15 @@
               <a:t>[/Sources]</a:t>
             </a:r>
           </a:p>
+          <a:p xmlns:a="http://schemas.openxmlformats.org/drawingml/2006/main">
+            <a:r>
+              <a:t>
+[Sources]
+- https://archivonacional.go.cr/
+- https://www.archivonacional.go.cr/web/dsae/NTN-003_digitalizacio%CC%81n_textuales_papel_doc.pdf
+- https://yann.lecun.com/exdb/mnist/</a:t>
+            </a:r>
+          </a:p>
         </p:txBody>
       </p:sp>
       <p:sp>
@@ -1684,6 +1801,15 @@
               <a:t>[/Sources]</a:t>
             </a:r>
           </a:p>
+          <a:p xmlns:a="http://schemas.openxmlformats.org/drawingml/2006/main">
+            <a:r>
+              <a:t>
+[Sources]
+- https://archivonacional.go.cr/
+- https://www.archivonacional.go.cr/web/dsae/NTN-003_digitalizacio%CC%81n_textuales_papel_doc.pdf
+- https://yann.lecun.com/exdb/mnist/</a:t>
+            </a:r>
+          </a:p>
         </p:txBody>
       </p:sp>
       <p:sp>
@@ -1772,6 +1898,15 @@
           <a:p xmlns:a="http://schemas.openxmlformats.org/drawingml/2006/main">
             <a:r>
               <a:t>[/Sources]</a:t>
+            </a:r>
+          </a:p>
+          <a:p xmlns:a="http://schemas.openxmlformats.org/drawingml/2006/main">
+            <a:r>
+              <a:t>
+[Sources]
+- https://archivonacional.go.cr/
+- https://www.archivonacional.go.cr/web/dsae/NTN-003_digitalizacio%CC%81n_textuales_papel_doc.pdf
+- https://yann.lecun.com/exdb/mnist/</a:t>
             </a:r>
           </a:p>
         </p:txBody>
@@ -1839,7 +1974,7 @@
   </p:cSld>
   <p:clrMap bg1="lt1" tx1="dk1" bg2="lt2" tx2="dk2" accent1="accent1" accent2="accent2" accent3="accent3" accent4="accent4" accent5="accent5" accent6="accent6" hlink="hlink" folHlink="folHlink"/>
   <p:sldLayoutIdLst>
-    <p:sldLayoutId xmlns:r="http://schemas.openxmlformats.org/officeDocument/2006/relationships" id="2147483649" r:id="R50cd9cc6ccbb4e64"/>
+    <p:sldLayoutId xmlns:r="http://schemas.openxmlformats.org/officeDocument/2006/relationships" id="2147483649" r:id="R87abd9282ddd4cbb"/>
   </p:sldLayoutIdLst>
   <p:txStyles>
     <p:titleStyle>
@@ -2373,6 +2508,7 @@
     <c:plotArea>
       <c:lineChart>
         <c:grouping val="standard"/>
+        <c:varyColors val="0"/>
         <c:ser>
           <c:idx val="0"/>
           <c:order val="0"/>
@@ -2654,6 +2790,7 @@
           <a:lstStyle xmlns:a="http://schemas.openxmlformats.org/drawingml/2006/main"/>
           <a:p xmlns:a="http://schemas.openxmlformats.org/drawingml/2006/main">
             <a:pPr algn="l">
+              <a:buNone/>
               <a:defRPr sz="1500" b="1">
                 <a:solidFill>
                   <a:srgbClr val="BCEAE5"/>
@@ -2672,7 +2809,7 @@
                 <a:ea typeface="Arial"/>
                 <a:cs typeface="Arial"/>
               </a:rPr>
-              <a:t>REDES NEURONALES SOBRE GRAFOS</a:t>
+              <a:t>DIGITALIZACIÓN DE ARCHIVOS PÚBLICOS</a:t>
             </a:r>
           </a:p>
         </p:txBody>
@@ -2710,6 +2847,7 @@
           <a:lstStyle xmlns:a="http://schemas.openxmlformats.org/drawingml/2006/main"/>
           <a:p xmlns:a="http://schemas.openxmlformats.org/drawingml/2006/main">
             <a:pPr algn="l">
+              <a:buNone/>
               <a:defRPr sz="5400" b="1">
                 <a:solidFill>
                   <a:srgbClr val="FFFFFF"/>
@@ -2733,6 +2871,7 @@
           </a:p>
           <a:p xmlns:a="http://schemas.openxmlformats.org/drawingml/2006/main">
             <a:pPr algn="l">
+              <a:buNone/>
               <a:defRPr sz="5400" b="1">
                 <a:solidFill>
                   <a:srgbClr val="FFFFFF"/>
@@ -2789,6 +2928,7 @@
           <a:lstStyle xmlns:a="http://schemas.openxmlformats.org/drawingml/2006/main"/>
           <a:p xmlns:a="http://schemas.openxmlformats.org/drawingml/2006/main">
             <a:pPr algn="l">
+              <a:buNone/>
               <a:defRPr sz="2250" b="0">
                 <a:solidFill>
                   <a:srgbClr val="CFE0EC"/>
@@ -2807,7 +2947,7 @@
                 <a:ea typeface="Arial"/>
                 <a:cs typeface="Arial"/>
               </a:rPr>
-              <a:t>Softmax vs. Graph-MLP · MNIST</a:t>
+              <a:t>Prototipo OCR · Softmax vs. Graph-MLP</a:t>
             </a:r>
           </a:p>
         </p:txBody>
@@ -2876,6 +3016,7 @@
           <a:lstStyle xmlns:a="http://schemas.openxmlformats.org/drawingml/2006/main"/>
           <a:p xmlns:a="http://schemas.openxmlformats.org/drawingml/2006/main">
             <a:pPr algn="l">
+              <a:buNone/>
               <a:defRPr sz="1500" b="0">
                 <a:solidFill>
                   <a:srgbClr val="FFFFFF"/>
@@ -2899,6 +3040,7 @@
           </a:p>
           <a:p xmlns:a="http://schemas.openxmlformats.org/drawingml/2006/main">
             <a:pPr algn="l">
+              <a:buNone/>
               <a:defRPr sz="1500" b="0">
                 <a:solidFill>
                   <a:srgbClr val="FFFFFF"/>
@@ -2955,6 +3097,7 @@
           <a:lstStyle xmlns:a="http://schemas.openxmlformats.org/drawingml/2006/main"/>
           <a:p xmlns:a="http://schemas.openxmlformats.org/drawingml/2006/main">
             <a:pPr algn="l">
+              <a:buNone/>
               <a:defRPr sz="1350" b="0">
                 <a:solidFill>
                   <a:srgbClr val="CFE0EC"/>
@@ -3064,6 +3207,7 @@
           <a:lstStyle xmlns:a="http://schemas.openxmlformats.org/drawingml/2006/main"/>
           <a:p xmlns:a="http://schemas.openxmlformats.org/drawingml/2006/main">
             <a:pPr algn="l">
+              <a:buNone/>
               <a:defRPr sz="3450" b="1">
                 <a:solidFill>
                   <a:srgbClr val="16324F"/>
@@ -3120,6 +3264,7 @@
           <a:lstStyle xmlns:a="http://schemas.openxmlformats.org/drawingml/2006/main"/>
           <a:p xmlns:a="http://schemas.openxmlformats.org/drawingml/2006/main">
             <a:pPr algn="r">
+              <a:buNone/>
               <a:defRPr sz="1200" b="0">
                 <a:solidFill>
                   <a:srgbClr val="667085"/>
@@ -3145,14 +3290,14 @@
       </p:sp>
       <p:pic>
         <p:nvPicPr>
-          <p:cNvPr id="12" name=""/>
+          <p:cNvPr id="14" name=""/>
           <p:cNvPicPr>
             <a:picLocks xmlns:a="http://schemas.openxmlformats.org/drawingml/2006/main" noChangeAspect="1"/>
           </p:cNvPicPr>
           <p:nvPr/>
         </p:nvPicPr>
         <p:blipFill>
-          <a:blip xmlns:r="http://schemas.openxmlformats.org/officeDocument/2006/relationships" xmlns:a="http://schemas.openxmlformats.org/drawingml/2006/main" r:embed="R785367ca3e4247ee"/>
+          <a:blip xmlns:r="http://schemas.openxmlformats.org/officeDocument/2006/relationships" xmlns:a="http://schemas.openxmlformats.org/drawingml/2006/main" r:embed="R3250c75c1d314ada"/>
           <a:stretch xmlns:a="http://schemas.openxmlformats.org/drawingml/2006/main"/>
         </p:blipFill>
         <p:spPr>
@@ -3233,6 +3378,7 @@
           <a:lstStyle xmlns:a="http://schemas.openxmlformats.org/drawingml/2006/main"/>
           <a:p xmlns:a="http://schemas.openxmlformats.org/drawingml/2006/main">
             <a:pPr algn="l">
+              <a:buNone/>
               <a:defRPr sz="2100" b="1">
                 <a:solidFill>
                   <a:srgbClr val="16324F"/>
@@ -3289,6 +3435,7 @@
           <a:lstStyle xmlns:a="http://schemas.openxmlformats.org/drawingml/2006/main"/>
           <a:p xmlns:a="http://schemas.openxmlformats.org/drawingml/2006/main">
             <a:pPr algn="l">
+              <a:buNone/>
               <a:defRPr sz="1875" b="0">
                 <a:solidFill>
                   <a:srgbClr val="667085"/>
@@ -3312,6 +3459,7 @@
           </a:p>
           <a:p xmlns:a="http://schemas.openxmlformats.org/drawingml/2006/main">
             <a:pPr algn="l">
+              <a:buNone/>
               <a:defRPr sz="1875" b="0">
                 <a:solidFill>
                   <a:srgbClr val="667085"/>
@@ -3335,6 +3483,7 @@
           </a:p>
           <a:p xmlns:a="http://schemas.openxmlformats.org/drawingml/2006/main">
             <a:pPr algn="l">
+              <a:buNone/>
               <a:defRPr sz="1875" b="0">
                 <a:solidFill>
                   <a:srgbClr val="667085"/>
@@ -3358,6 +3507,7 @@
           </a:p>
           <a:p xmlns:a="http://schemas.openxmlformats.org/drawingml/2006/main">
             <a:pPr algn="l">
+              <a:buNone/>
               <a:defRPr sz="1875" b="0">
                 <a:solidFill>
                   <a:srgbClr val="667085"/>
@@ -3414,6 +3564,7 @@
           <a:lstStyle xmlns:a="http://schemas.openxmlformats.org/drawingml/2006/main"/>
           <a:p xmlns:a="http://schemas.openxmlformats.org/drawingml/2006/main">
             <a:pPr algn="ctr">
+              <a:buNone/>
               <a:defRPr sz="1725" b="1">
                 <a:solidFill>
                   <a:srgbClr val="13A89E"/>
@@ -3523,6 +3674,7 @@
           <a:lstStyle xmlns:a="http://schemas.openxmlformats.org/drawingml/2006/main"/>
           <a:p xmlns:a="http://schemas.openxmlformats.org/drawingml/2006/main">
             <a:pPr algn="l">
+              <a:buNone/>
               <a:defRPr sz="3450" b="1">
                 <a:solidFill>
                   <a:srgbClr val="16324F"/>
@@ -3579,6 +3731,7 @@
           <a:lstStyle xmlns:a="http://schemas.openxmlformats.org/drawingml/2006/main"/>
           <a:p xmlns:a="http://schemas.openxmlformats.org/drawingml/2006/main">
             <a:pPr algn="r">
+              <a:buNone/>
               <a:defRPr sz="1200" b="0">
                 <a:solidFill>
                   <a:srgbClr val="667085"/>
@@ -3604,7 +3757,7 @@
       </p:sp>
       <p:graphicFrame>
         <p:nvGraphicFramePr>
-          <p:cNvPr id="15" name="Chart"/>
+          <p:cNvPr id="17" name="Chart"/>
           <p:cNvGraphicFramePr/>
           <p:nvPr/>
         </p:nvGraphicFramePr>
@@ -3614,7 +3767,7 @@
         </p:xfrm>
         <a:graphic xmlns:a="http://schemas.openxmlformats.org/drawingml/2006/main">
           <a:graphicData uri="http://schemas.openxmlformats.org/drawingml/2006/chart">
-            <c:chart xmlns:r="http://schemas.openxmlformats.org/officeDocument/2006/relationships" xmlns:c="http://schemas.openxmlformats.org/drawingml/2006/chart" r:id="R1e5fe20a545f4405"/>
+            <c:chart xmlns:r="http://schemas.openxmlformats.org/officeDocument/2006/relationships" xmlns:c="http://schemas.openxmlformats.org/drawingml/2006/chart" r:id="R3f00733970014598"/>
           </a:graphicData>
         </a:graphic>
       </p:graphicFrame>
@@ -3686,6 +3839,7 @@
           <a:lstStyle xmlns:a="http://schemas.openxmlformats.org/drawingml/2006/main"/>
           <a:p xmlns:a="http://schemas.openxmlformats.org/drawingml/2006/main">
             <a:pPr algn="l">
+              <a:buNone/>
               <a:defRPr sz="2100" b="1">
                 <a:solidFill>
                   <a:srgbClr val="13A89E"/>
@@ -3742,6 +3896,7 @@
           <a:lstStyle xmlns:a="http://schemas.openxmlformats.org/drawingml/2006/main"/>
           <a:p xmlns:a="http://schemas.openxmlformats.org/drawingml/2006/main">
             <a:pPr algn="l">
+              <a:buNone/>
               <a:defRPr sz="1800" b="0">
                 <a:solidFill>
                   <a:srgbClr val="667085"/>
@@ -3833,6 +3988,7 @@
           <a:lstStyle xmlns:a="http://schemas.openxmlformats.org/drawingml/2006/main"/>
           <a:p xmlns:a="http://schemas.openxmlformats.org/drawingml/2006/main">
             <a:pPr algn="l">
+              <a:buNone/>
               <a:defRPr sz="2100" b="1">
                 <a:solidFill>
                   <a:srgbClr val="F2994A"/>
@@ -3889,6 +4045,7 @@
           <a:lstStyle xmlns:a="http://schemas.openxmlformats.org/drawingml/2006/main"/>
           <a:p xmlns:a="http://schemas.openxmlformats.org/drawingml/2006/main">
             <a:pPr algn="l">
+              <a:buNone/>
               <a:defRPr sz="1650" b="0">
                 <a:solidFill>
                   <a:srgbClr val="667085"/>
@@ -3912,6 +4069,7 @@
           </a:p>
           <a:p xmlns:a="http://schemas.openxmlformats.org/drawingml/2006/main">
             <a:pPr algn="l">
+              <a:buNone/>
               <a:defRPr sz="1650" b="0">
                 <a:solidFill>
                   <a:srgbClr val="667085"/>
@@ -3968,6 +4126,7 @@
           <a:lstStyle xmlns:a="http://schemas.openxmlformats.org/drawingml/2006/main"/>
           <a:p xmlns:a="http://schemas.openxmlformats.org/drawingml/2006/main">
             <a:pPr algn="ctr">
+              <a:buNone/>
               <a:defRPr sz="1950" b="1">
                 <a:solidFill>
                   <a:srgbClr val="16324F"/>
@@ -4077,6 +4236,7 @@
           <a:lstStyle xmlns:a="http://schemas.openxmlformats.org/drawingml/2006/main"/>
           <a:p xmlns:a="http://schemas.openxmlformats.org/drawingml/2006/main">
             <a:pPr algn="l">
+              <a:buNone/>
               <a:defRPr sz="3450" b="1">
                 <a:solidFill>
                   <a:srgbClr val="16324F"/>
@@ -4095,7 +4255,7 @@
                 <a:ea typeface="Arial"/>
                 <a:cs typeface="Arial"/>
               </a:rPr>
-              <a:t>95.5% en MNIST no autoriza una decisión real</a:t>
+              <a:t>95.5% en MNIST no autoriza migrar un archivo</a:t>
             </a:r>
           </a:p>
         </p:txBody>
@@ -4133,6 +4293,7 @@
           <a:lstStyle xmlns:a="http://schemas.openxmlformats.org/drawingml/2006/main"/>
           <a:p xmlns:a="http://schemas.openxmlformats.org/drawingml/2006/main">
             <a:pPr algn="r">
+              <a:buNone/>
               <a:defRPr sz="1200" b="0">
                 <a:solidFill>
                   <a:srgbClr val="667085"/>
@@ -4224,6 +4385,7 @@
           <a:lstStyle xmlns:a="http://schemas.openxmlformats.org/drawingml/2006/main"/>
           <a:p xmlns:a="http://schemas.openxmlformats.org/drawingml/2006/main">
             <a:pPr algn="l">
+              <a:buNone/>
               <a:defRPr sz="2550" b="1">
                 <a:solidFill>
                   <a:srgbClr val="2F80ED"/>
@@ -4280,6 +4442,7 @@
           <a:lstStyle xmlns:a="http://schemas.openxmlformats.org/drawingml/2006/main"/>
           <a:p xmlns:a="http://schemas.openxmlformats.org/drawingml/2006/main">
             <a:pPr algn="l">
+              <a:buNone/>
               <a:defRPr sz="1800" b="0">
                 <a:solidFill>
                   <a:srgbClr val="667085"/>
@@ -4303,6 +4466,7 @@
           </a:p>
           <a:p xmlns:a="http://schemas.openxmlformats.org/drawingml/2006/main">
             <a:pPr algn="l">
+              <a:buNone/>
               <a:defRPr sz="1800" b="0">
                 <a:solidFill>
                   <a:srgbClr val="667085"/>
@@ -4326,6 +4490,7 @@
           </a:p>
           <a:p xmlns:a="http://schemas.openxmlformats.org/drawingml/2006/main">
             <a:pPr algn="l">
+              <a:buNone/>
               <a:defRPr sz="1800" b="0">
                 <a:solidFill>
                   <a:srgbClr val="667085"/>
@@ -4349,6 +4514,7 @@
           </a:p>
           <a:p xmlns:a="http://schemas.openxmlformats.org/drawingml/2006/main">
             <a:pPr algn="l">
+              <a:buNone/>
               <a:defRPr sz="1800" b="0">
                 <a:solidFill>
                   <a:srgbClr val="667085"/>
@@ -4372,6 +4538,7 @@
           </a:p>
           <a:p xmlns:a="http://schemas.openxmlformats.org/drawingml/2006/main">
             <a:pPr algn="l">
+              <a:buNone/>
               <a:defRPr sz="1800" b="0">
                 <a:solidFill>
                   <a:srgbClr val="667085"/>
@@ -4463,6 +4630,7 @@
           <a:lstStyle xmlns:a="http://schemas.openxmlformats.org/drawingml/2006/main"/>
           <a:p xmlns:a="http://schemas.openxmlformats.org/drawingml/2006/main">
             <a:pPr algn="l">
+              <a:buNone/>
               <a:defRPr sz="2550" b="1">
                 <a:solidFill>
                   <a:srgbClr val="13A89E"/>
@@ -4519,6 +4687,7 @@
           <a:lstStyle xmlns:a="http://schemas.openxmlformats.org/drawingml/2006/main"/>
           <a:p xmlns:a="http://schemas.openxmlformats.org/drawingml/2006/main">
             <a:pPr algn="l">
+              <a:buNone/>
               <a:defRPr sz="1800" b="0">
                 <a:solidFill>
                   <a:srgbClr val="667085"/>
@@ -4542,6 +4711,7 @@
           </a:p>
           <a:p xmlns:a="http://schemas.openxmlformats.org/drawingml/2006/main">
             <a:pPr algn="l">
+              <a:buNone/>
               <a:defRPr sz="1800" b="0">
                 <a:solidFill>
                   <a:srgbClr val="667085"/>
@@ -4565,6 +4735,7 @@
           </a:p>
           <a:p xmlns:a="http://schemas.openxmlformats.org/drawingml/2006/main">
             <a:pPr algn="l">
+              <a:buNone/>
               <a:defRPr sz="1800" b="0">
                 <a:solidFill>
                   <a:srgbClr val="667085"/>
@@ -4588,6 +4759,7 @@
           </a:p>
           <a:p xmlns:a="http://schemas.openxmlformats.org/drawingml/2006/main">
             <a:pPr algn="l">
+              <a:buNone/>
               <a:defRPr sz="1800" b="0">
                 <a:solidFill>
                   <a:srgbClr val="667085"/>
@@ -4611,6 +4783,7 @@
           </a:p>
           <a:p xmlns:a="http://schemas.openxmlformats.org/drawingml/2006/main">
             <a:pPr algn="l">
+              <a:buNone/>
               <a:defRPr sz="1800" b="0">
                 <a:solidFill>
                   <a:srgbClr val="667085"/>
@@ -4720,6 +4893,7 @@
           <a:lstStyle xmlns:a="http://schemas.openxmlformats.org/drawingml/2006/main"/>
           <a:p xmlns:a="http://schemas.openxmlformats.org/drawingml/2006/main">
             <a:pPr algn="l">
+              <a:buNone/>
               <a:defRPr sz="3450" b="1">
                 <a:solidFill>
                   <a:srgbClr val="16324F"/>
@@ -4738,7 +4912,7 @@
                 <a:ea typeface="Arial"/>
                 <a:cs typeface="Arial"/>
               </a:rPr>
-              <a:t>La siguiente inversión debe ser en datos locales, no en más capas</a:t>
+              <a:t>La siguiente inversión debe ser en archivos locales etiquetados</a:t>
             </a:r>
           </a:p>
         </p:txBody>
@@ -4776,6 +4950,7 @@
           <a:lstStyle xmlns:a="http://schemas.openxmlformats.org/drawingml/2006/main"/>
           <a:p xmlns:a="http://schemas.openxmlformats.org/drawingml/2006/main">
             <a:pPr algn="r">
+              <a:buNone/>
               <a:defRPr sz="1200" b="0">
                 <a:solidFill>
                   <a:srgbClr val="667085"/>
@@ -4832,6 +5007,7 @@
           <a:lstStyle xmlns:a="http://schemas.openxmlformats.org/drawingml/2006/main"/>
           <a:p xmlns:a="http://schemas.openxmlformats.org/drawingml/2006/main">
             <a:pPr algn="l">
+              <a:buNone/>
               <a:defRPr sz="2400" b="1">
                 <a:solidFill>
                   <a:srgbClr val="13A89E"/>
@@ -4888,6 +5064,7 @@
           <a:lstStyle xmlns:a="http://schemas.openxmlformats.org/drawingml/2006/main"/>
           <a:p xmlns:a="http://schemas.openxmlformats.org/drawingml/2006/main">
             <a:pPr algn="l">
+              <a:buNone/>
               <a:defRPr sz="2025" b="1">
                 <a:solidFill>
                   <a:srgbClr val="16324F"/>
@@ -4906,7 +5083,7 @@
                 <a:ea typeface="Arial"/>
                 <a:cs typeface="Arial"/>
               </a:rPr>
-              <a:t>Graph-MLP mejora F1 y log-loss, pero la ablación muestra que la no linealidad aporta más que la propagación fija.</a:t>
+              <a:t>Graph-MLP mejora F1 y log-loss en MNIST; todavía no demuestra fidelidad sobre documentos públicos.</a:t>
             </a:r>
           </a:p>
         </p:txBody>
@@ -4944,6 +5121,7 @@
           <a:lstStyle xmlns:a="http://schemas.openxmlformats.org/drawingml/2006/main"/>
           <a:p xmlns:a="http://schemas.openxmlformats.org/drawingml/2006/main">
             <a:pPr algn="l">
+              <a:buNone/>
               <a:defRPr sz="2400" b="1">
                 <a:solidFill>
                   <a:srgbClr val="2F80ED"/>
@@ -5000,6 +5178,7 @@
           <a:lstStyle xmlns:a="http://schemas.openxmlformats.org/drawingml/2006/main"/>
           <a:p xmlns:a="http://schemas.openxmlformats.org/drawingml/2006/main">
             <a:pPr algn="l">
+              <a:buNone/>
               <a:defRPr sz="2025" b="1">
                 <a:solidFill>
                   <a:srgbClr val="16324F"/>
@@ -5018,7 +5197,7 @@
                 <a:ea typeface="Arial"/>
                 <a:cs typeface="Arial"/>
               </a:rPr>
-              <a:t>Recolectar 1,000–5,000 dígitos costarricenses, comparar MLP/CNN/GNN con capacidad equivalente y fijar revisión humana.</a:t>
+              <a:t>Etiquetar 1,000–5,000 recortes de una serie pública, comparar modelos y exigir revisión humana.</a:t>
             </a:r>
           </a:p>
         </p:txBody>
@@ -5091,6 +5270,7 @@
           <a:lstStyle xmlns:a="http://schemas.openxmlformats.org/drawingml/2006/main"/>
           <a:p xmlns:a="http://schemas.openxmlformats.org/drawingml/2006/main">
             <a:pPr algn="ctr">
+              <a:buNone/>
               <a:defRPr sz="2550" b="1">
                 <a:solidFill>
                   <a:srgbClr val="FFFFFF"/>
@@ -5109,7 +5289,7 @@
                 <a:ea typeface="Arial"/>
                 <a:cs typeface="Arial"/>
               </a:rPr>
-              <a:t>Un prototipo útil no es el que nunca falla; es el que sabe cuándo pedir ayuda.</a:t>
+              <a:t>Digitalizar no es borrar el papel: es preservar, transcribir y poder auditar.</a:t>
             </a:r>
           </a:p>
         </p:txBody>
@@ -5200,6 +5380,7 @@
           <a:lstStyle xmlns:a="http://schemas.openxmlformats.org/drawingml/2006/main"/>
           <a:p xmlns:a="http://schemas.openxmlformats.org/drawingml/2006/main">
             <a:pPr algn="l">
+              <a:buNone/>
               <a:defRPr sz="3450" b="1">
                 <a:solidFill>
                   <a:srgbClr val="16324F"/>
@@ -5256,6 +5437,7 @@
           <a:lstStyle xmlns:a="http://schemas.openxmlformats.org/drawingml/2006/main"/>
           <a:p xmlns:a="http://schemas.openxmlformats.org/drawingml/2006/main">
             <a:pPr algn="r">
+              <a:buNone/>
               <a:defRPr sz="1200" b="0">
                 <a:solidFill>
                   <a:srgbClr val="667085"/>
@@ -5281,7 +5463,7 @@
       </p:sp>
       <p:graphicFrame>
         <p:nvGraphicFramePr>
-          <p:cNvPr id="10" name=""/>
+          <p:cNvPr id="12" name=""/>
           <p:cNvGraphicFramePr/>
           <p:nvPr/>
         </p:nvGraphicFramePr>
@@ -5728,6 +5910,7 @@
           <a:lstStyle xmlns:a="http://schemas.openxmlformats.org/drawingml/2006/main"/>
           <a:p xmlns:a="http://schemas.openxmlformats.org/drawingml/2006/main">
             <a:pPr algn="ctr">
+              <a:buNone/>
               <a:defRPr sz="2250" b="1">
                 <a:solidFill>
                   <a:srgbClr val="16324F"/>
@@ -5784,6 +5967,7 @@
           <a:lstStyle xmlns:a="http://schemas.openxmlformats.org/drawingml/2006/main"/>
           <a:p xmlns:a="http://schemas.openxmlformats.org/drawingml/2006/main">
             <a:pPr algn="ctr">
+              <a:buNone/>
               <a:defRPr sz="1725" b="0">
                 <a:solidFill>
                   <a:srgbClr val="667085"/>
@@ -5893,6 +6077,7 @@
           <a:lstStyle xmlns:a="http://schemas.openxmlformats.org/drawingml/2006/main"/>
           <a:p xmlns:a="http://schemas.openxmlformats.org/drawingml/2006/main">
             <a:pPr algn="l">
+              <a:buNone/>
               <a:defRPr sz="3450" b="1">
                 <a:solidFill>
                   <a:srgbClr val="16324F"/>
@@ -5911,7 +6096,7 @@
                 <a:ea typeface="Arial"/>
                 <a:cs typeface="Arial"/>
               </a:rPr>
-              <a:t>Respaldo · qué se corrigió y cómo reproducir</a:t>
+              <a:t>Respaldo · corrección, reproducción y alcance archivístico</a:t>
             </a:r>
           </a:p>
         </p:txBody>
@@ -5949,6 +6134,7 @@
           <a:lstStyle xmlns:a="http://schemas.openxmlformats.org/drawingml/2006/main"/>
           <a:p xmlns:a="http://schemas.openxmlformats.org/drawingml/2006/main">
             <a:pPr algn="r">
+              <a:buNone/>
               <a:defRPr sz="1200" b="0">
                 <a:solidFill>
                   <a:srgbClr val="667085"/>
@@ -6005,6 +6191,7 @@
           <a:lstStyle xmlns:a="http://schemas.openxmlformats.org/drawingml/2006/main"/>
           <a:p xmlns:a="http://schemas.openxmlformats.org/drawingml/2006/main">
             <a:pPr algn="l">
+              <a:buNone/>
               <a:defRPr sz="2250" b="1">
                 <a:solidFill>
                   <a:srgbClr val="F2994A"/>
@@ -6096,6 +6283,7 @@
           <a:lstStyle xmlns:a="http://schemas.openxmlformats.org/drawingml/2006/main"/>
           <a:p xmlns:a="http://schemas.openxmlformats.org/drawingml/2006/main">
             <a:pPr algn="ctr">
+              <a:buNone/>
               <a:defRPr sz="1950" b="1">
                 <a:solidFill>
                   <a:srgbClr val="16324F"/>
@@ -6119,6 +6307,7 @@
           </a:p>
           <a:p xmlns:a="http://schemas.openxmlformats.org/drawingml/2006/main">
             <a:pPr algn="ctr">
+              <a:buNone/>
               <a:defRPr sz="1950" b="1">
                 <a:solidFill>
                   <a:srgbClr val="16324F"/>
@@ -6175,6 +6364,7 @@
           <a:lstStyle xmlns:a="http://schemas.openxmlformats.org/drawingml/2006/main"/>
           <a:p xmlns:a="http://schemas.openxmlformats.org/drawingml/2006/main">
             <a:pPr algn="l">
+              <a:buNone/>
               <a:defRPr sz="2250" b="1">
                 <a:solidFill>
                   <a:srgbClr val="13A89E"/>
@@ -6266,6 +6456,7 @@
           <a:lstStyle xmlns:a="http://schemas.openxmlformats.org/drawingml/2006/main"/>
           <a:p xmlns:a="http://schemas.openxmlformats.org/drawingml/2006/main">
             <a:pPr algn="ctr">
+              <a:buNone/>
               <a:defRPr sz="1950" b="1">
                 <a:solidFill>
                   <a:srgbClr val="16324F"/>
@@ -6289,6 +6480,7 @@
           </a:p>
           <a:p xmlns:a="http://schemas.openxmlformats.org/drawingml/2006/main">
             <a:pPr algn="ctr">
+              <a:buNone/>
               <a:defRPr sz="1950" b="1">
                 <a:solidFill>
                   <a:srgbClr val="16324F"/>
@@ -6345,6 +6537,7 @@
           <a:lstStyle xmlns:a="http://schemas.openxmlformats.org/drawingml/2006/main"/>
           <a:p xmlns:a="http://schemas.openxmlformats.org/drawingml/2006/main">
             <a:pPr algn="l">
+              <a:buNone/>
               <a:defRPr sz="2250" b="1">
                 <a:solidFill>
                   <a:srgbClr val="16324F"/>
@@ -6401,6 +6594,7 @@
           <a:lstStyle xmlns:a="http://schemas.openxmlformats.org/drawingml/2006/main"/>
           <a:p xmlns:a="http://schemas.openxmlformats.org/drawingml/2006/main">
             <a:pPr algn="ctr">
+              <a:buNone/>
               <a:defRPr sz="2025" b="0">
                 <a:solidFill>
                   <a:srgbClr val="2F80ED"/>
@@ -6457,6 +6651,7 @@
           <a:lstStyle xmlns:a="http://schemas.openxmlformats.org/drawingml/2006/main"/>
           <a:p xmlns:a="http://schemas.openxmlformats.org/drawingml/2006/main">
             <a:pPr algn="ctr">
+              <a:buNone/>
               <a:defRPr sz="1800" b="1">
                 <a:solidFill>
                   <a:srgbClr val="667085"/>
@@ -6475,7 +6670,7 @@
                 <a:ea typeface="Arial"/>
                 <a:cs typeface="Arial"/>
               </a:rPr>
-              <a:t>Sin rutas personales · datos incluidos · NumPy · README · LICENSE</a:t>
+              <a:t>Sin rutas personales · datos incluidos · README · LICENSE · revisión humana</a:t>
             </a:r>
           </a:p>
         </p:txBody>
@@ -6566,6 +6761,7 @@
           <a:lstStyle xmlns:a="http://schemas.openxmlformats.org/drawingml/2006/main"/>
           <a:p xmlns:a="http://schemas.openxmlformats.org/drawingml/2006/main">
             <a:pPr algn="l">
+              <a:buNone/>
               <a:defRPr sz="3450" b="1">
                 <a:solidFill>
                   <a:srgbClr val="16324F"/>
@@ -6584,7 +6780,7 @@
                 <a:ea typeface="Arial"/>
                 <a:cs typeface="Arial"/>
               </a:rPr>
-              <a:t>Los trazos importan más que los píxeles aislados</a:t>
+              <a:t>Fechas, folios y montos dependen de trazos completos</a:t>
             </a:r>
           </a:p>
         </p:txBody>
@@ -6622,6 +6818,7 @@
           <a:lstStyle xmlns:a="http://schemas.openxmlformats.org/drawingml/2006/main"/>
           <a:p xmlns:a="http://schemas.openxmlformats.org/drawingml/2006/main">
             <a:pPr algn="r">
+              <a:buNone/>
               <a:defRPr sz="1200" b="0">
                 <a:solidFill>
                   <a:srgbClr val="667085"/>
@@ -6678,6 +6875,7 @@
           <a:lstStyle xmlns:a="http://schemas.openxmlformats.org/drawingml/2006/main"/>
           <a:p xmlns:a="http://schemas.openxmlformats.org/drawingml/2006/main">
             <a:pPr algn="l">
+              <a:buNone/>
               <a:defRPr sz="2550" b="1">
                 <a:solidFill>
                   <a:srgbClr val="16324F"/>
@@ -6696,7 +6894,7 @@
                 <a:ea typeface="Arial"/>
                 <a:cs typeface="Arial"/>
               </a:rPr>
-              <a:t>Una imagen es una red</a:t>
+              <a:t>Un dígito es una red</a:t>
             </a:r>
           </a:p>
         </p:txBody>
@@ -6734,6 +6932,7 @@
           <a:lstStyle xmlns:a="http://schemas.openxmlformats.org/drawingml/2006/main"/>
           <a:p xmlns:a="http://schemas.openxmlformats.org/drawingml/2006/main">
             <a:pPr algn="l">
+              <a:buNone/>
               <a:defRPr sz="1950" b="0">
                 <a:solidFill>
                   <a:srgbClr val="16324F"/>
@@ -6794,7 +6993,7 @@
       </p:sp>
       <p:cxnSp>
         <p:nvCxnSpPr>
-          <p:cNvPr id="29" name=""/>
+          <p:cNvPr id="59" name=""/>
           <p:cNvCxnSpPr/>
           <p:nvPr/>
         </p:nvCxnSpPr>
@@ -6816,7 +7015,7 @@
       </p:cxnSp>
       <p:cxnSp>
         <p:nvCxnSpPr>
-          <p:cNvPr id="30" name=""/>
+          <p:cNvPr id="60" name=""/>
           <p:cNvCxnSpPr/>
           <p:nvPr/>
         </p:nvCxnSpPr>
@@ -6838,7 +7037,7 @@
       </p:cxnSp>
       <p:cxnSp>
         <p:nvCxnSpPr>
-          <p:cNvPr id="31" name=""/>
+          <p:cNvPr id="61" name=""/>
           <p:cNvCxnSpPr/>
           <p:nvPr/>
         </p:nvCxnSpPr>
@@ -6860,7 +7059,7 @@
       </p:cxnSp>
       <p:cxnSp>
         <p:nvCxnSpPr>
-          <p:cNvPr id="32" name=""/>
+          <p:cNvPr id="62" name=""/>
           <p:cNvCxnSpPr/>
           <p:nvPr/>
         </p:nvCxnSpPr>
@@ -6882,7 +7081,7 @@
       </p:cxnSp>
       <p:cxnSp>
         <p:nvCxnSpPr>
-          <p:cNvPr id="33" name=""/>
+          <p:cNvPr id="63" name=""/>
           <p:cNvCxnSpPr/>
           <p:nvPr/>
         </p:nvCxnSpPr>
@@ -6904,7 +7103,7 @@
       </p:cxnSp>
       <p:cxnSp>
         <p:nvCxnSpPr>
-          <p:cNvPr id="34" name=""/>
+          <p:cNvPr id="64" name=""/>
           <p:cNvCxnSpPr/>
           <p:nvPr/>
         </p:nvCxnSpPr>
@@ -6926,7 +7125,7 @@
       </p:cxnSp>
       <p:cxnSp>
         <p:nvCxnSpPr>
-          <p:cNvPr id="35" name=""/>
+          <p:cNvPr id="65" name=""/>
           <p:cNvCxnSpPr/>
           <p:nvPr/>
         </p:nvCxnSpPr>
@@ -6948,7 +7147,7 @@
       </p:cxnSp>
       <p:cxnSp>
         <p:nvCxnSpPr>
-          <p:cNvPr id="36" name=""/>
+          <p:cNvPr id="66" name=""/>
           <p:cNvCxnSpPr/>
           <p:nvPr/>
         </p:nvCxnSpPr>
@@ -6970,7 +7169,7 @@
       </p:cxnSp>
       <p:cxnSp>
         <p:nvCxnSpPr>
-          <p:cNvPr id="37" name=""/>
+          <p:cNvPr id="67" name=""/>
           <p:cNvCxnSpPr/>
           <p:nvPr/>
         </p:nvCxnSpPr>
@@ -7221,6 +7420,7 @@
           <a:lstStyle xmlns:a="http://schemas.openxmlformats.org/drawingml/2006/main"/>
           <a:p xmlns:a="http://schemas.openxmlformats.org/drawingml/2006/main">
             <a:pPr algn="l">
+              <a:buNone/>
               <a:defRPr sz="1875" b="1">
                 <a:solidFill>
                   <a:srgbClr val="13A89E"/>
@@ -7239,7 +7439,7 @@
                 <a:ea typeface="Arial"/>
                 <a:cs typeface="Arial"/>
               </a:rPr>
-              <a:t>En Costa Rica podría apoyar la transcripción de formularios y registros; MNIST solo es una prueba de concepto.</a:t>
+              <a:t>Aplicación propuesta: protocolos, formularios y expedientes en papel. MNIST es solo el banco de prueba.</a:t>
             </a:r>
           </a:p>
         </p:txBody>
@@ -7330,6 +7530,7 @@
           <a:lstStyle xmlns:a="http://schemas.openxmlformats.org/drawingml/2006/main"/>
           <a:p xmlns:a="http://schemas.openxmlformats.org/drawingml/2006/main">
             <a:pPr algn="l">
+              <a:buNone/>
               <a:defRPr sz="3450" b="1">
                 <a:solidFill>
                   <a:srgbClr val="16324F"/>
@@ -7348,7 +7549,7 @@
                 <a:ea typeface="Arial"/>
                 <a:cs typeface="Arial"/>
               </a:rPr>
-              <a:t>La pregunta es comparativa, no promocional</a:t>
+              <a:t>El prototipo se evalúa antes de tocar un expediente</a:t>
             </a:r>
           </a:p>
         </p:txBody>
@@ -7386,6 +7587,7 @@
           <a:lstStyle xmlns:a="http://schemas.openxmlformats.org/drawingml/2006/main"/>
           <a:p xmlns:a="http://schemas.openxmlformats.org/drawingml/2006/main">
             <a:pPr algn="r">
+              <a:buNone/>
               <a:defRPr sz="1200" b="0">
                 <a:solidFill>
                   <a:srgbClr val="667085"/>
@@ -7442,6 +7644,7 @@
           <a:lstStyle xmlns:a="http://schemas.openxmlformats.org/drawingml/2006/main"/>
           <a:p xmlns:a="http://schemas.openxmlformats.org/drawingml/2006/main">
             <a:pPr algn="l">
+              <a:buNone/>
               <a:defRPr sz="2850" b="1">
                 <a:solidFill>
                   <a:srgbClr val="16324F"/>
@@ -7460,7 +7663,7 @@
                 <a:ea typeface="Arial"/>
                 <a:cs typeface="Arial"/>
               </a:rPr>
-              <a:t>¿Incorporar vecindad local y una frontera no lineal mejora la clasificación frente a un modelo lineal?</a:t>
+              <a:t>¿El contexto local mejora el reconocimiento de dígitos y qué falta para validarlo en archivos públicos?</a:t>
             </a:r>
           </a:p>
         </p:txBody>
@@ -7533,6 +7736,7 @@
           <a:lstStyle xmlns:a="http://schemas.openxmlformats.org/drawingml/2006/main"/>
           <a:p xmlns:a="http://schemas.openxmlformats.org/drawingml/2006/main">
             <a:pPr algn="l">
+              <a:buNone/>
               <a:defRPr sz="2550" b="1">
                 <a:solidFill>
                   <a:srgbClr val="13A89E"/>
@@ -7589,6 +7793,7 @@
           <a:lstStyle xmlns:a="http://schemas.openxmlformats.org/drawingml/2006/main"/>
           <a:p xmlns:a="http://schemas.openxmlformats.org/drawingml/2006/main">
             <a:pPr algn="l">
+              <a:buNone/>
               <a:defRPr sz="1950" b="1">
                 <a:solidFill>
                   <a:srgbClr val="16324F"/>
@@ -7645,6 +7850,7 @@
           <a:lstStyle xmlns:a="http://schemas.openxmlformats.org/drawingml/2006/main"/>
           <a:p xmlns:a="http://schemas.openxmlformats.org/drawingml/2006/main">
             <a:pPr algn="l">
+              <a:buNone/>
               <a:defRPr sz="1500" b="0">
                 <a:solidFill>
                   <a:srgbClr val="667085"/>
@@ -7663,7 +7869,7 @@
                 <a:ea typeface="Arial"/>
                 <a:cs typeface="Arial"/>
               </a:rPr>
-              <a:t>MNIST como grafo de 784 nodos</a:t>
+              <a:t>Dígitos como grafos de 784 nodos</a:t>
             </a:r>
           </a:p>
         </p:txBody>
@@ -7736,6 +7942,7 @@
           <a:lstStyle xmlns:a="http://schemas.openxmlformats.org/drawingml/2006/main"/>
           <a:p xmlns:a="http://schemas.openxmlformats.org/drawingml/2006/main">
             <a:pPr algn="l">
+              <a:buNone/>
               <a:defRPr sz="2550" b="1">
                 <a:solidFill>
                   <a:srgbClr val="13A89E"/>
@@ -7792,6 +7999,7 @@
           <a:lstStyle xmlns:a="http://schemas.openxmlformats.org/drawingml/2006/main"/>
           <a:p xmlns:a="http://schemas.openxmlformats.org/drawingml/2006/main">
             <a:pPr algn="l">
+              <a:buNone/>
               <a:defRPr sz="1950" b="1">
                 <a:solidFill>
                   <a:srgbClr val="16324F"/>
@@ -7848,6 +8056,7 @@
           <a:lstStyle xmlns:a="http://schemas.openxmlformats.org/drawingml/2006/main"/>
           <a:p xmlns:a="http://schemas.openxmlformats.org/drawingml/2006/main">
             <a:pPr algn="l">
+              <a:buNone/>
               <a:defRPr sz="1500" b="0">
                 <a:solidFill>
                   <a:srgbClr val="667085"/>
@@ -7866,7 +8075,7 @@
                 <a:ea typeface="Arial"/>
                 <a:cs typeface="Arial"/>
               </a:rPr>
-              <a:t>Softmax y Graph-MLP en los mismos datos</a:t>
+              <a:t>Softmax y Graph-MLP bajo la misma prueba</a:t>
             </a:r>
           </a:p>
         </p:txBody>
@@ -7939,6 +8148,7 @@
           <a:lstStyle xmlns:a="http://schemas.openxmlformats.org/drawingml/2006/main"/>
           <a:p xmlns:a="http://schemas.openxmlformats.org/drawingml/2006/main">
             <a:pPr algn="l">
+              <a:buNone/>
               <a:defRPr sz="2550" b="1">
                 <a:solidFill>
                   <a:srgbClr val="13A89E"/>
@@ -7995,6 +8205,7 @@
           <a:lstStyle xmlns:a="http://schemas.openxmlformats.org/drawingml/2006/main"/>
           <a:p xmlns:a="http://schemas.openxmlformats.org/drawingml/2006/main">
             <a:pPr algn="l">
+              <a:buNone/>
               <a:defRPr sz="1950" b="1">
                 <a:solidFill>
                   <a:srgbClr val="16324F"/>
@@ -8051,6 +8262,7 @@
           <a:lstStyle xmlns:a="http://schemas.openxmlformats.org/drawingml/2006/main"/>
           <a:p xmlns:a="http://schemas.openxmlformats.org/drawingml/2006/main">
             <a:pPr algn="l">
+              <a:buNone/>
               <a:defRPr sz="1500" b="0">
                 <a:solidFill>
                   <a:srgbClr val="667085"/>
@@ -8069,7 +8281,7 @@
                 <a:ea typeface="Arial"/>
                 <a:cs typeface="Arial"/>
               </a:rPr>
-              <a:t>F1 macro, pérdida y tres pliegues</a:t>
+              <a:t>F1, pérdida y validación común</a:t>
             </a:r>
           </a:p>
         </p:txBody>
@@ -8142,6 +8354,7 @@
           <a:lstStyle xmlns:a="http://schemas.openxmlformats.org/drawingml/2006/main"/>
           <a:p xmlns:a="http://schemas.openxmlformats.org/drawingml/2006/main">
             <a:pPr algn="l">
+              <a:buNone/>
               <a:defRPr sz="2550" b="1">
                 <a:solidFill>
                   <a:srgbClr val="13A89E"/>
@@ -8198,6 +8411,7 @@
           <a:lstStyle xmlns:a="http://schemas.openxmlformats.org/drawingml/2006/main"/>
           <a:p xmlns:a="http://schemas.openxmlformats.org/drawingml/2006/main">
             <a:pPr algn="l">
+              <a:buNone/>
               <a:defRPr sz="1950" b="1">
                 <a:solidFill>
                   <a:srgbClr val="16324F"/>
@@ -8254,6 +8468,7 @@
           <a:lstStyle xmlns:a="http://schemas.openxmlformats.org/drawingml/2006/main"/>
           <a:p xmlns:a="http://schemas.openxmlformats.org/drawingml/2006/main">
             <a:pPr algn="l">
+              <a:buNone/>
               <a:defRPr sz="1500" b="0">
                 <a:solidFill>
                   <a:srgbClr val="667085"/>
@@ -8272,7 +8487,7 @@
                 <a:ea typeface="Arial"/>
                 <a:cs typeface="Arial"/>
               </a:rPr>
-              <a:t>L2, propagación y tamaño muestral</a:t>
+              <a:t>L2, propagación, datos y controles</a:t>
             </a:r>
           </a:p>
         </p:txBody>
@@ -8363,6 +8578,7 @@
           <a:lstStyle xmlns:a="http://schemas.openxmlformats.org/drawingml/2006/main"/>
           <a:p xmlns:a="http://schemas.openxmlformats.org/drawingml/2006/main">
             <a:pPr algn="l">
+              <a:buNone/>
               <a:defRPr sz="3450" b="1">
                 <a:solidFill>
                   <a:srgbClr val="16324F"/>
@@ -8419,6 +8635,7 @@
           <a:lstStyle xmlns:a="http://schemas.openxmlformats.org/drawingml/2006/main"/>
           <a:p xmlns:a="http://schemas.openxmlformats.org/drawingml/2006/main">
             <a:pPr algn="r">
+              <a:buNone/>
               <a:defRPr sz="1200" b="0">
                 <a:solidFill>
                   <a:srgbClr val="667085"/>
@@ -8444,7 +8661,7 @@
       </p:sp>
       <p:graphicFrame>
         <p:nvGraphicFramePr>
-          <p:cNvPr id="15" name=""/>
+          <p:cNvPr id="17" name=""/>
           <p:cNvGraphicFramePr/>
           <p:nvPr/>
         </p:nvGraphicFramePr>
@@ -8960,6 +9177,7 @@
           <a:lstStyle xmlns:a="http://schemas.openxmlformats.org/drawingml/2006/main"/>
           <a:p xmlns:a="http://schemas.openxmlformats.org/drawingml/2006/main">
             <a:pPr algn="ctr">
+              <a:buNone/>
               <a:defRPr sz="3750" b="1">
                 <a:solidFill>
                   <a:srgbClr val="13A89E"/>
@@ -9016,6 +9234,7 @@
           <a:lstStyle xmlns:a="http://schemas.openxmlformats.org/drawingml/2006/main"/>
           <a:p xmlns:a="http://schemas.openxmlformats.org/drawingml/2006/main">
             <a:pPr algn="ctr">
+              <a:buNone/>
               <a:defRPr sz="1425" b="0">
                 <a:solidFill>
                   <a:srgbClr val="667085"/>
@@ -9107,6 +9326,7 @@
           <a:lstStyle xmlns:a="http://schemas.openxmlformats.org/drawingml/2006/main"/>
           <a:p xmlns:a="http://schemas.openxmlformats.org/drawingml/2006/main">
             <a:pPr algn="ctr">
+              <a:buNone/>
               <a:defRPr sz="3750" b="1">
                 <a:solidFill>
                   <a:srgbClr val="2F80ED"/>
@@ -9163,6 +9383,7 @@
           <a:lstStyle xmlns:a="http://schemas.openxmlformats.org/drawingml/2006/main"/>
           <a:p xmlns:a="http://schemas.openxmlformats.org/drawingml/2006/main">
             <a:pPr algn="ctr">
+              <a:buNone/>
               <a:defRPr sz="1425" b="0">
                 <a:solidFill>
                   <a:srgbClr val="667085"/>
@@ -9219,6 +9440,7 @@
           <a:lstStyle xmlns:a="http://schemas.openxmlformats.org/drawingml/2006/main"/>
           <a:p xmlns:a="http://schemas.openxmlformats.org/drawingml/2006/main">
             <a:pPr algn="l">
+              <a:buNone/>
               <a:defRPr sz="1875" b="1">
                 <a:solidFill>
                   <a:srgbClr val="16324F"/>
@@ -9328,6 +9550,7 @@
           <a:lstStyle xmlns:a="http://schemas.openxmlformats.org/drawingml/2006/main"/>
           <a:p xmlns:a="http://schemas.openxmlformats.org/drawingml/2006/main">
             <a:pPr algn="l">
+              <a:buNone/>
               <a:defRPr sz="3450" b="1">
                 <a:solidFill>
                   <a:srgbClr val="16324F"/>
@@ -9384,6 +9607,7 @@
           <a:lstStyle xmlns:a="http://schemas.openxmlformats.org/drawingml/2006/main"/>
           <a:p xmlns:a="http://schemas.openxmlformats.org/drawingml/2006/main">
             <a:pPr algn="r">
+              <a:buNone/>
               <a:defRPr sz="1200" b="0">
                 <a:solidFill>
                   <a:srgbClr val="667085"/>
@@ -9409,14 +9633,14 @@
       </p:sp>
       <p:pic>
         <p:nvPicPr>
-          <p:cNvPr id="9" name=""/>
+          <p:cNvPr id="11" name=""/>
           <p:cNvPicPr>
             <a:picLocks xmlns:a="http://schemas.openxmlformats.org/drawingml/2006/main" noChangeAspect="1"/>
           </p:cNvPicPr>
           <p:nvPr/>
         </p:nvPicPr>
         <p:blipFill>
-          <a:blip xmlns:r="http://schemas.openxmlformats.org/officeDocument/2006/relationships" xmlns:a="http://schemas.openxmlformats.org/drawingml/2006/main" r:embed="R2afbd4057f104a22"/>
+          <a:blip xmlns:r="http://schemas.openxmlformats.org/officeDocument/2006/relationships" xmlns:a="http://schemas.openxmlformats.org/drawingml/2006/main" r:embed="R0747e2bfd50346fb"/>
           <a:stretch xmlns:a="http://schemas.openxmlformats.org/drawingml/2006/main"/>
         </p:blipFill>
         <p:spPr>
@@ -9462,6 +9686,7 @@
           <a:lstStyle xmlns:a="http://schemas.openxmlformats.org/drawingml/2006/main"/>
           <a:p xmlns:a="http://schemas.openxmlformats.org/drawingml/2006/main">
             <a:pPr algn="ctr">
+              <a:buNone/>
               <a:defRPr sz="1650" b="1">
                 <a:solidFill>
                   <a:srgbClr val="13A89E"/>
@@ -9571,6 +9796,7 @@
           <a:lstStyle xmlns:a="http://schemas.openxmlformats.org/drawingml/2006/main"/>
           <a:p xmlns:a="http://schemas.openxmlformats.org/drawingml/2006/main">
             <a:pPr algn="l">
+              <a:buNone/>
               <a:defRPr sz="3450" b="1">
                 <a:solidFill>
                   <a:srgbClr val="16324F"/>
@@ -9627,6 +9853,7 @@
           <a:lstStyle xmlns:a="http://schemas.openxmlformats.org/drawingml/2006/main"/>
           <a:p xmlns:a="http://schemas.openxmlformats.org/drawingml/2006/main">
             <a:pPr algn="r">
+              <a:buNone/>
               <a:defRPr sz="1200" b="0">
                 <a:solidFill>
                   <a:srgbClr val="667085"/>
@@ -9718,6 +9945,7 @@
           <a:lstStyle xmlns:a="http://schemas.openxmlformats.org/drawingml/2006/main"/>
           <a:p xmlns:a="http://schemas.openxmlformats.org/drawingml/2006/main">
             <a:pPr algn="ctr">
+              <a:buNone/>
               <a:defRPr sz="3150" b="1">
                 <a:solidFill>
                   <a:srgbClr val="13A89E"/>
@@ -9774,6 +10002,7 @@
           <a:lstStyle xmlns:a="http://schemas.openxmlformats.org/drawingml/2006/main"/>
           <a:p xmlns:a="http://schemas.openxmlformats.org/drawingml/2006/main">
             <a:pPr algn="ctr">
+              <a:buNone/>
               <a:defRPr sz="2250" b="1">
                 <a:solidFill>
                   <a:srgbClr val="2F80ED"/>
@@ -9830,6 +10059,7 @@
           <a:lstStyle xmlns:a="http://schemas.openxmlformats.org/drawingml/2006/main"/>
           <a:p xmlns:a="http://schemas.openxmlformats.org/drawingml/2006/main">
             <a:pPr algn="ctr">
+              <a:buNone/>
               <a:defRPr sz="1575" b="0">
                 <a:solidFill>
                   <a:srgbClr val="667085"/>
@@ -9886,6 +10116,7 @@
           <a:lstStyle xmlns:a="http://schemas.openxmlformats.org/drawingml/2006/main"/>
           <a:p xmlns:a="http://schemas.openxmlformats.org/drawingml/2006/main">
             <a:pPr algn="ctr">
+              <a:buNone/>
               <a:defRPr sz="2250" b="1">
                 <a:solidFill>
                   <a:srgbClr val="2F80ED"/>
@@ -9942,6 +10173,7 @@
           <a:lstStyle xmlns:a="http://schemas.openxmlformats.org/drawingml/2006/main"/>
           <a:p xmlns:a="http://schemas.openxmlformats.org/drawingml/2006/main">
             <a:pPr algn="ctr">
+              <a:buNone/>
               <a:defRPr sz="1575" b="0">
                 <a:solidFill>
                   <a:srgbClr val="667085"/>
@@ -9998,6 +10230,7 @@
           <a:lstStyle xmlns:a="http://schemas.openxmlformats.org/drawingml/2006/main"/>
           <a:p xmlns:a="http://schemas.openxmlformats.org/drawingml/2006/main">
             <a:pPr algn="ctr">
+              <a:buNone/>
               <a:defRPr sz="2250" b="1">
                 <a:solidFill>
                   <a:srgbClr val="2F80ED"/>
@@ -10054,6 +10287,7 @@
           <a:lstStyle xmlns:a="http://schemas.openxmlformats.org/drawingml/2006/main"/>
           <a:p xmlns:a="http://schemas.openxmlformats.org/drawingml/2006/main">
             <a:pPr algn="ctr">
+              <a:buNone/>
               <a:defRPr sz="1575" b="0">
                 <a:solidFill>
                   <a:srgbClr val="667085"/>
@@ -10110,6 +10344,7 @@
           <a:lstStyle xmlns:a="http://schemas.openxmlformats.org/drawingml/2006/main"/>
           <a:p xmlns:a="http://schemas.openxmlformats.org/drawingml/2006/main">
             <a:pPr algn="ctr">
+              <a:buNone/>
               <a:defRPr sz="2250" b="1">
                 <a:solidFill>
                   <a:srgbClr val="F2994A"/>
@@ -10166,6 +10401,7 @@
           <a:lstStyle xmlns:a="http://schemas.openxmlformats.org/drawingml/2006/main"/>
           <a:p xmlns:a="http://schemas.openxmlformats.org/drawingml/2006/main">
             <a:pPr algn="ctr">
+              <a:buNone/>
               <a:defRPr sz="1575" b="0">
                 <a:solidFill>
                   <a:srgbClr val="667085"/>
@@ -10222,6 +10458,7 @@
           <a:lstStyle xmlns:a="http://schemas.openxmlformats.org/drawingml/2006/main"/>
           <a:p xmlns:a="http://schemas.openxmlformats.org/drawingml/2006/main">
             <a:pPr algn="ctr">
+              <a:buNone/>
               <a:defRPr sz="1800" b="1">
                 <a:solidFill>
                   <a:srgbClr val="F2994A"/>
@@ -10331,6 +10568,7 @@
           <a:lstStyle xmlns:a="http://schemas.openxmlformats.org/drawingml/2006/main"/>
           <a:p xmlns:a="http://schemas.openxmlformats.org/drawingml/2006/main">
             <a:pPr algn="l">
+              <a:buNone/>
               <a:defRPr sz="3450" b="1">
                 <a:solidFill>
                   <a:srgbClr val="16324F"/>
@@ -10387,6 +10625,7 @@
           <a:lstStyle xmlns:a="http://schemas.openxmlformats.org/drawingml/2006/main"/>
           <a:p xmlns:a="http://schemas.openxmlformats.org/drawingml/2006/main">
             <a:pPr algn="r">
+              <a:buNone/>
               <a:defRPr sz="1200" b="0">
                 <a:solidFill>
                   <a:srgbClr val="667085"/>
@@ -10478,6 +10717,7 @@
           <a:lstStyle xmlns:a="http://schemas.openxmlformats.org/drawingml/2006/main"/>
           <a:p xmlns:a="http://schemas.openxmlformats.org/drawingml/2006/main">
             <a:pPr algn="l">
+              <a:buNone/>
               <a:defRPr sz="2850" b="1">
                 <a:solidFill>
                   <a:srgbClr val="2F80ED"/>
@@ -10534,6 +10774,7 @@
           <a:lstStyle xmlns:a="http://schemas.openxmlformats.org/drawingml/2006/main"/>
           <a:p xmlns:a="http://schemas.openxmlformats.org/drawingml/2006/main">
             <a:pPr algn="l">
+              <a:buNone/>
               <a:defRPr sz="2100" b="1">
                 <a:solidFill>
                   <a:srgbClr val="16324F"/>
@@ -10590,6 +10831,7 @@
           <a:lstStyle xmlns:a="http://schemas.openxmlformats.org/drawingml/2006/main"/>
           <a:p xmlns:a="http://schemas.openxmlformats.org/drawingml/2006/main">
             <a:pPr algn="l">
+              <a:buNone/>
               <a:defRPr sz="1800" b="0">
                 <a:solidFill>
                   <a:srgbClr val="667085"/>
@@ -10613,6 +10855,7 @@
           </a:p>
           <a:p xmlns:a="http://schemas.openxmlformats.org/drawingml/2006/main">
             <a:pPr algn="l">
+              <a:buNone/>
               <a:defRPr sz="1800" b="0">
                 <a:solidFill>
                   <a:srgbClr val="667085"/>
@@ -10636,6 +10879,7 @@
           </a:p>
           <a:p xmlns:a="http://schemas.openxmlformats.org/drawingml/2006/main">
             <a:pPr algn="l">
+              <a:buNone/>
               <a:defRPr sz="1800" b="0">
                 <a:solidFill>
                   <a:srgbClr val="667085"/>
@@ -10659,6 +10903,7 @@
           </a:p>
           <a:p xmlns:a="http://schemas.openxmlformats.org/drawingml/2006/main">
             <a:pPr algn="l">
+              <a:buNone/>
               <a:defRPr sz="1800" b="0">
                 <a:solidFill>
                   <a:srgbClr val="667085"/>
@@ -10750,6 +10995,7 @@
           <a:lstStyle xmlns:a="http://schemas.openxmlformats.org/drawingml/2006/main"/>
           <a:p xmlns:a="http://schemas.openxmlformats.org/drawingml/2006/main">
             <a:pPr algn="l">
+              <a:buNone/>
               <a:defRPr sz="2850" b="1">
                 <a:solidFill>
                   <a:srgbClr val="13A89E"/>
@@ -10806,6 +11052,7 @@
           <a:lstStyle xmlns:a="http://schemas.openxmlformats.org/drawingml/2006/main"/>
           <a:p xmlns:a="http://schemas.openxmlformats.org/drawingml/2006/main">
             <a:pPr algn="l">
+              <a:buNone/>
               <a:defRPr sz="2100" b="1">
                 <a:solidFill>
                   <a:srgbClr val="16324F"/>
@@ -10862,6 +11109,7 @@
           <a:lstStyle xmlns:a="http://schemas.openxmlformats.org/drawingml/2006/main"/>
           <a:p xmlns:a="http://schemas.openxmlformats.org/drawingml/2006/main">
             <a:pPr algn="l">
+              <a:buNone/>
               <a:defRPr sz="1800" b="0">
                 <a:solidFill>
                   <a:srgbClr val="667085"/>
@@ -10885,6 +11133,7 @@
           </a:p>
           <a:p xmlns:a="http://schemas.openxmlformats.org/drawingml/2006/main">
             <a:pPr algn="l">
+              <a:buNone/>
               <a:defRPr sz="1800" b="0">
                 <a:solidFill>
                   <a:srgbClr val="667085"/>
@@ -10908,6 +11157,7 @@
           </a:p>
           <a:p xmlns:a="http://schemas.openxmlformats.org/drawingml/2006/main">
             <a:pPr algn="l">
+              <a:buNone/>
               <a:defRPr sz="1800" b="0">
                 <a:solidFill>
                   <a:srgbClr val="667085"/>
@@ -10931,6 +11181,7 @@
           </a:p>
           <a:p xmlns:a="http://schemas.openxmlformats.org/drawingml/2006/main">
             <a:pPr algn="l">
+              <a:buNone/>
               <a:defRPr sz="1800" b="0">
                 <a:solidFill>
                   <a:srgbClr val="667085"/>
@@ -10987,6 +11238,7 @@
           <a:lstStyle xmlns:a="http://schemas.openxmlformats.org/drawingml/2006/main"/>
           <a:p xmlns:a="http://schemas.openxmlformats.org/drawingml/2006/main">
             <a:pPr algn="ctr">
+              <a:buNone/>
               <a:defRPr sz="1800" b="1">
                 <a:solidFill>
                   <a:srgbClr val="16324F"/>
@@ -11096,6 +11348,7 @@
           <a:lstStyle xmlns:a="http://schemas.openxmlformats.org/drawingml/2006/main"/>
           <a:p xmlns:a="http://schemas.openxmlformats.org/drawingml/2006/main">
             <a:pPr algn="l">
+              <a:buNone/>
               <a:defRPr sz="3450" b="1">
                 <a:solidFill>
                   <a:srgbClr val="16324F"/>
@@ -11152,6 +11405,7 @@
           <a:lstStyle xmlns:a="http://schemas.openxmlformats.org/drawingml/2006/main"/>
           <a:p xmlns:a="http://schemas.openxmlformats.org/drawingml/2006/main">
             <a:pPr algn="r">
+              <a:buNone/>
               <a:defRPr sz="1200" b="0">
                 <a:solidFill>
                   <a:srgbClr val="667085"/>
@@ -11177,7 +11431,7 @@
       </p:sp>
       <p:cxnSp>
         <p:nvCxnSpPr>
-          <p:cNvPr id="22" name=""/>
+          <p:cNvPr id="32" name=""/>
           <p:cNvCxnSpPr/>
           <p:nvPr/>
         </p:nvCxnSpPr>
@@ -11199,7 +11453,7 @@
       </p:cxnSp>
       <p:cxnSp>
         <p:nvCxnSpPr>
-          <p:cNvPr id="23" name=""/>
+          <p:cNvPr id="33" name=""/>
           <p:cNvCxnSpPr/>
           <p:nvPr/>
         </p:nvCxnSpPr>
@@ -11287,6 +11541,7 @@
           <a:lstStyle xmlns:a="http://schemas.openxmlformats.org/drawingml/2006/main"/>
           <a:p xmlns:a="http://schemas.openxmlformats.org/drawingml/2006/main">
             <a:pPr algn="ctr">
+              <a:buNone/>
               <a:defRPr sz="3600" b="1">
                 <a:solidFill>
                   <a:srgbClr val="2F80ED"/>
@@ -11343,6 +11598,7 @@
           <a:lstStyle xmlns:a="http://schemas.openxmlformats.org/drawingml/2006/main"/>
           <a:p xmlns:a="http://schemas.openxmlformats.org/drawingml/2006/main">
             <a:pPr algn="ctr">
+              <a:buNone/>
               <a:defRPr sz="1725" b="1">
                 <a:solidFill>
                   <a:srgbClr val="16324F"/>
@@ -11399,6 +11655,7 @@
           <a:lstStyle xmlns:a="http://schemas.openxmlformats.org/drawingml/2006/main"/>
           <a:p xmlns:a="http://schemas.openxmlformats.org/drawingml/2006/main">
             <a:pPr algn="ctr">
+              <a:buNone/>
               <a:defRPr sz="1350" b="0">
                 <a:solidFill>
                   <a:srgbClr val="667085"/>
@@ -11490,6 +11747,7 @@
           <a:lstStyle xmlns:a="http://schemas.openxmlformats.org/drawingml/2006/main"/>
           <a:p xmlns:a="http://schemas.openxmlformats.org/drawingml/2006/main">
             <a:pPr algn="ctr">
+              <a:buNone/>
               <a:defRPr sz="3600" b="1">
                 <a:solidFill>
                   <a:srgbClr val="2F80ED"/>
@@ -11546,6 +11804,7 @@
           <a:lstStyle xmlns:a="http://schemas.openxmlformats.org/drawingml/2006/main"/>
           <a:p xmlns:a="http://schemas.openxmlformats.org/drawingml/2006/main">
             <a:pPr algn="ctr">
+              <a:buNone/>
               <a:defRPr sz="1725" b="1">
                 <a:solidFill>
                   <a:srgbClr val="16324F"/>
@@ -11602,6 +11861,7 @@
           <a:lstStyle xmlns:a="http://schemas.openxmlformats.org/drawingml/2006/main"/>
           <a:p xmlns:a="http://schemas.openxmlformats.org/drawingml/2006/main">
             <a:pPr algn="ctr">
+              <a:buNone/>
               <a:defRPr sz="1350" b="0">
                 <a:solidFill>
                   <a:srgbClr val="667085"/>
@@ -11693,6 +11953,7 @@
           <a:lstStyle xmlns:a="http://schemas.openxmlformats.org/drawingml/2006/main"/>
           <a:p xmlns:a="http://schemas.openxmlformats.org/drawingml/2006/main">
             <a:pPr algn="ctr">
+              <a:buNone/>
               <a:defRPr sz="3600" b="1">
                 <a:solidFill>
                   <a:srgbClr val="13A89E"/>
@@ -11749,6 +12010,7 @@
           <a:lstStyle xmlns:a="http://schemas.openxmlformats.org/drawingml/2006/main"/>
           <a:p xmlns:a="http://schemas.openxmlformats.org/drawingml/2006/main">
             <a:pPr algn="ctr">
+              <a:buNone/>
               <a:defRPr sz="1725" b="1">
                 <a:solidFill>
                   <a:srgbClr val="16324F"/>
@@ -11805,6 +12067,7 @@
           <a:lstStyle xmlns:a="http://schemas.openxmlformats.org/drawingml/2006/main"/>
           <a:p xmlns:a="http://schemas.openxmlformats.org/drawingml/2006/main">
             <a:pPr algn="ctr">
+              <a:buNone/>
               <a:defRPr sz="1350" b="0">
                 <a:solidFill>
                   <a:srgbClr val="667085"/>
@@ -11861,6 +12124,7 @@
           <a:lstStyle xmlns:a="http://schemas.openxmlformats.org/drawingml/2006/main"/>
           <a:p xmlns:a="http://schemas.openxmlformats.org/drawingml/2006/main">
             <a:pPr algn="ctr">
+              <a:buNone/>
               <a:defRPr sz="2025" b="1">
                 <a:solidFill>
                   <a:srgbClr val="16324F"/>
@@ -11970,6 +12234,7 @@
           <a:lstStyle xmlns:a="http://schemas.openxmlformats.org/drawingml/2006/main"/>
           <a:p xmlns:a="http://schemas.openxmlformats.org/drawingml/2006/main">
             <a:pPr algn="l">
+              <a:buNone/>
               <a:defRPr sz="3450" b="1">
                 <a:solidFill>
                   <a:srgbClr val="16324F"/>
@@ -12026,6 +12291,7 @@
           <a:lstStyle xmlns:a="http://schemas.openxmlformats.org/drawingml/2006/main"/>
           <a:p xmlns:a="http://schemas.openxmlformats.org/drawingml/2006/main">
             <a:pPr algn="r">
+              <a:buNone/>
               <a:defRPr sz="1200" b="0">
                 <a:solidFill>
                   <a:srgbClr val="667085"/>
@@ -12051,7 +12317,7 @@
       </p:sp>
       <p:graphicFrame>
         <p:nvGraphicFramePr>
-          <p:cNvPr id="17" name=""/>
+          <p:cNvPr id="19" name=""/>
           <p:cNvGraphicFramePr/>
           <p:nvPr/>
         </p:nvGraphicFramePr>
@@ -12468,6 +12734,7 @@
           <a:lstStyle xmlns:a="http://schemas.openxmlformats.org/drawingml/2006/main"/>
           <a:p xmlns:a="http://schemas.openxmlformats.org/drawingml/2006/main">
             <a:pPr algn="ctr">
+              <a:buNone/>
               <a:defRPr sz="3900" b="1">
                 <a:solidFill>
                   <a:srgbClr val="13A89E"/>
@@ -12524,6 +12791,7 @@
           <a:lstStyle xmlns:a="http://schemas.openxmlformats.org/drawingml/2006/main"/>
           <a:p xmlns:a="http://schemas.openxmlformats.org/drawingml/2006/main">
             <a:pPr algn="ctr">
+              <a:buNone/>
               <a:defRPr sz="1575" b="0">
                 <a:solidFill>
                   <a:srgbClr val="667085"/>
@@ -12615,6 +12883,7 @@
           <a:lstStyle xmlns:a="http://schemas.openxmlformats.org/drawingml/2006/main"/>
           <a:p xmlns:a="http://schemas.openxmlformats.org/drawingml/2006/main">
             <a:pPr algn="ctr">
+              <a:buNone/>
               <a:defRPr sz="3900" b="1">
                 <a:solidFill>
                   <a:srgbClr val="2F80ED"/>
@@ -12671,6 +12940,7 @@
           <a:lstStyle xmlns:a="http://schemas.openxmlformats.org/drawingml/2006/main"/>
           <a:p xmlns:a="http://schemas.openxmlformats.org/drawingml/2006/main">
             <a:pPr algn="ctr">
+              <a:buNone/>
               <a:defRPr sz="1575" b="0">
                 <a:solidFill>
                   <a:srgbClr val="667085"/>
@@ -12762,6 +13032,7 @@
           <a:lstStyle xmlns:a="http://schemas.openxmlformats.org/drawingml/2006/main"/>
           <a:p xmlns:a="http://schemas.openxmlformats.org/drawingml/2006/main">
             <a:pPr algn="ctr">
+              <a:buNone/>
               <a:defRPr sz="3900" b="1">
                 <a:solidFill>
                   <a:srgbClr val="13A89E"/>
@@ -12818,6 +13089,7 @@
           <a:lstStyle xmlns:a="http://schemas.openxmlformats.org/drawingml/2006/main"/>
           <a:p xmlns:a="http://schemas.openxmlformats.org/drawingml/2006/main">
             <a:pPr algn="ctr">
+              <a:buNone/>
               <a:defRPr sz="1575" b="0">
                 <a:solidFill>
                   <a:srgbClr val="667085"/>

</xml_diff>